<commit_message>
Change 2: Department Insights (slides 6-7)
Slide 6 frames the page as the working view for a Records Officer: the same
measures as Bank-wide cut by department, office and RM, with drill-down from
department to site to library.

Slide 7 leads on the Division list again, noting explicitly that one answer
settles both pages, and names the four sections on this page that depend on
it. The remaining asks are the internal and external visitor split, the site
naming convention, and whether access grants and denials are logged
anywhere reachable.

Co-Authored-By: Claude Haiku 4.5 <noreply@anthropic.com>
Claude-Session: https://claude.ai/code/session_011o1oYM1TYcdL65Q8iw3Pih
</commit_message>
<xml_diff>
--- a/EDRMS_Utilization_Confirmation_Workshop.pptx
+++ b/EDRMS_Utilization_Confirmation_Workshop.pptx
@@ -9235,16 +9235,18 @@
 
 <file path=ppt/slides/slide6.xml><?xml version="1.0" encoding="utf-8"?>
 <p:sld xmlns:a="http://schemas.openxmlformats.org/drawingml/2006/main" xmlns:r="http://schemas.openxmlformats.org/officeDocument/2006/relationships" xmlns:p="http://schemas.openxmlformats.org/presentationml/2006/main">
-  <p:cSld>
+  <p:cSld name="Department Insights">
+    <p:bg>
+      <p:bgPr>
+        <a:solidFill>
+          <a:srgbClr val="FFFFFF"/>
+        </a:solidFill>
+        <a:effectLst/>
+      </p:bgPr>
+    </p:bg>
     <p:spTree>
       <p:nvGrpSpPr>
-        <p:cNvPr id="1" name="">
-          <a:extLst>
-            <a:ext uri="{FF2B5EF4-FFF2-40B4-BE49-F238E27FC236}">
-              <a16:creationId xmlns:a16="http://schemas.microsoft.com/office/drawing/2014/main" id="{B6EDE8DC-A15F-834B-F14D-A79A8B15D0F6}"/>
-            </a:ext>
-          </a:extLst>
-        </p:cNvPr>
+        <p:cNvPr id="1" name=""/>
         <p:cNvGrpSpPr/>
         <p:nvPr/>
       </p:nvGrpSpPr>
@@ -9258,19 +9260,13 @@
       </p:grpSpPr>
       <p:sp>
         <p:nvSpPr>
-          <p:cNvPr id="4" name="Text 2">
-            <a:extLst>
-              <a:ext uri="{FF2B5EF4-FFF2-40B4-BE49-F238E27FC236}">
-                <a16:creationId xmlns:a16="http://schemas.microsoft.com/office/drawing/2014/main" id="{9612B9FC-6B79-FF57-F3F1-BF18A0672E88}"/>
-              </a:ext>
-            </a:extLst>
-          </p:cNvPr>
-          <p:cNvSpPr/>
-          <p:nvPr/>
-        </p:nvSpPr>
-        <p:spPr>
-          <a:xfrm>
-            <a:off x="198186" y="93986"/>
+          <p:cNvPr id="1001" name="Title"/>
+          <p:cNvSpPr/>
+          <p:nvPr/>
+        </p:nvSpPr>
+        <p:spPr>
+          <a:xfrm>
+            <a:off x="201168" y="91440"/>
             <a:ext cx="8412480" cy="493776"/>
           </a:xfrm>
           <a:prstGeom prst="rect">
@@ -9280,44 +9276,1409 @@
           <a:ln/>
         </p:spPr>
         <p:txBody>
-          <a:bodyPr wrap="square" lIns="0" tIns="0" rIns="0" bIns="0" rtlCol="0" anchor="ctr"/>
-          <a:lstStyle/>
-          <a:p>
-            <a:pPr marL="0" indent="0">
+          <a:bodyPr wrap="square" rtlCol="0" anchor="ctr">
+            <a:normAutofit/>
+          </a:bodyPr>
+          <a:lstStyle/>
+          <a:p>
+            <a:pPr marL="0" indent="0" algn="l">
               <a:buNone/>
             </a:pPr>
             <a:r>
-              <a:rPr lang="en-US" sz="2700" b="1" dirty="0">
-                <a:solidFill>
-                  <a:schemeClr val="tx2">
-                    <a:lumMod val="76000"/>
-                  </a:schemeClr>
-                </a:solidFill>
-                <a:latin typeface="Cambria"/>
-                <a:ea typeface="Cambria"/>
-                <a:cs typeface="Cambria" pitchFamily="34" charset="-120"/>
+              <a:rPr lang="en-US" sz="2700" b="1" kern="0" dirty="0">
+                <a:solidFill>
+                  <a:srgbClr val="003D5B"/>
+                </a:solidFill>
+                <a:latin typeface="Calibri" pitchFamily="34" charset="0"/>
+                <a:ea typeface="Calibri" pitchFamily="34" charset="-122"/>
+                <a:cs typeface="Calibri" pitchFamily="34" charset="-120"/>
               </a:rPr>
               <a:t>Department Insights</a:t>
             </a:r>
-            <a:endParaRPr lang="en-US" sz="2700" dirty="0">
-              <a:solidFill>
-                <a:schemeClr val="tx2">
-                  <a:lumMod val="76000"/>
-                </a:schemeClr>
-              </a:solidFill>
-              <a:latin typeface="Cambria"/>
-              <a:ea typeface="Cambria"/>
-              <a:cs typeface="Calibri"/>
-            </a:endParaRPr>
+          </a:p>
+        </p:txBody>
+      </p:sp>
+      <p:sp>
+        <p:nvSpPr>
+          <p:cNvPr id="1002" name="Subtitle"/>
+          <p:cNvSpPr/>
+          <p:nvPr/>
+        </p:nvSpPr>
+        <p:spPr>
+          <a:xfrm>
+            <a:off x="192024" y="640080"/>
+            <a:ext cx="8412480" cy="310896"/>
+          </a:xfrm>
+          <a:prstGeom prst="rect">
+            <a:avLst/>
+          </a:prstGeom>
+          <a:noFill/>
+          <a:ln/>
+        </p:spPr>
+        <p:txBody>
+          <a:bodyPr wrap="square" rtlCol="0" anchor="ctr">
+            <a:normAutofit/>
+          </a:bodyPr>
+          <a:lstStyle/>
+          <a:p>
+            <a:pPr marL="0" indent="0" algn="l">
+              <a:buNone/>
+            </a:pPr>
+            <a:r>
+              <a:rPr lang="en-US" sz="1400" b="0" kern="0" dirty="0">
+                <a:solidFill>
+                  <a:srgbClr val="009B8A"/>
+                </a:solidFill>
+                <a:latin typeface="Calibri" pitchFamily="34" charset="0"/>
+                <a:ea typeface="Calibri" pitchFamily="34" charset="-122"/>
+                <a:cs typeface="Calibri" pitchFamily="34" charset="-120"/>
+              </a:rPr>
+              <a:t>The same measures as Bank-wide, cut by department, office and Records Management unit.</a:t>
+            </a:r>
+          </a:p>
+        </p:txBody>
+      </p:sp>
+      <p:sp>
+        <p:nvSpPr>
+          <p:cNvPr id="1003" name="Rule"/>
+          <p:cNvSpPr/>
+          <p:nvPr/>
+        </p:nvSpPr>
+        <p:spPr>
+          <a:xfrm>
+            <a:off x="411480" y="1097280"/>
+            <a:ext cx="2578608" cy="36576"/>
+          </a:xfrm>
+          <a:prstGeom prst="rect">
+            <a:avLst/>
+          </a:prstGeom>
+          <a:solidFill>
+            <a:srgbClr val="009B8A"/>
+          </a:solidFill>
+          <a:ln/>
+        </p:spPr>
+        <p:txBody>
+          <a:bodyPr/>
+          <a:lstStyle/>
+          <a:p>
+            <a:endParaRPr lang="en-PH" sz="1000"/>
+          </a:p>
+        </p:txBody>
+      </p:sp>
+      <p:sp>
+        <p:nvSpPr>
+          <p:cNvPr id="1004" name="Text"/>
+          <p:cNvSpPr/>
+          <p:nvPr/>
+        </p:nvSpPr>
+        <p:spPr>
+          <a:xfrm>
+            <a:off x="411480" y="1152144"/>
+            <a:ext cx="2578608" cy="210312"/>
+          </a:xfrm>
+          <a:prstGeom prst="rect">
+            <a:avLst/>
+          </a:prstGeom>
+          <a:noFill/>
+          <a:ln/>
+        </p:spPr>
+        <p:txBody>
+          <a:bodyPr wrap="square" rtlCol="0" anchor="ctr">
+            <a:normAutofit/>
+          </a:bodyPr>
+          <a:lstStyle/>
+          <a:p>
+            <a:pPr marL="0" indent="0" algn="l">
+              <a:buNone/>
+            </a:pPr>
+            <a:r>
+              <a:rPr lang="en-US" sz="1200" b="1" kern="0" dirty="0">
+                <a:solidFill>
+                  <a:srgbClr val="003D5B"/>
+                </a:solidFill>
+                <a:latin typeface="Calibri" pitchFamily="34" charset="0"/>
+                <a:ea typeface="Calibri" pitchFamily="34" charset="-122"/>
+                <a:cs typeface="Calibri" pitchFamily="34" charset="-120"/>
+              </a:rPr>
+              <a:t>Compare like with like</a:t>
+            </a:r>
+          </a:p>
+        </p:txBody>
+      </p:sp>
+      <p:sp>
+        <p:nvSpPr>
+          <p:cNvPr id="1005" name="Text"/>
+          <p:cNvSpPr/>
+          <p:nvPr/>
+        </p:nvSpPr>
+        <p:spPr>
+          <a:xfrm>
+            <a:off x="411480" y="1435607"/>
+            <a:ext cx="2578608" cy="786384"/>
+          </a:xfrm>
+          <a:prstGeom prst="rect">
+            <a:avLst/>
+          </a:prstGeom>
+          <a:noFill/>
+          <a:ln/>
+        </p:spPr>
+        <p:txBody>
+          <a:bodyPr wrap="square" rtlCol="0" anchor="t">
+            <a:normAutofit/>
+          </a:bodyPr>
+          <a:lstStyle/>
+          <a:p>
+            <a:pPr marL="0" indent="0" algn="l">
+              <a:lnSpc>
+                <a:spcPct val="92000"/>
+              </a:lnSpc>
+              <a:buNone/>
+            </a:pPr>
+            <a:r>
+              <a:rPr lang="en-US" sz="1000" b="0" kern="0" dirty="0">
+                <a:solidFill>
+                  <a:srgbClr val="333333"/>
+                </a:solidFill>
+                <a:latin typeface="Calibri" pitchFamily="34" charset="0"/>
+                <a:ea typeface="Calibri" pitchFamily="34" charset="-122"/>
+                <a:cs typeface="Calibri" pitchFamily="34" charset="-120"/>
+              </a:rPr>
+              <a:t>Departments side by side on the same measures, so a strong or weak performer is visible without a separate report.</a:t>
+            </a:r>
+          </a:p>
+        </p:txBody>
+      </p:sp>
+      <p:sp>
+        <p:nvSpPr>
+          <p:cNvPr id="1006" name="Rule"/>
+          <p:cNvSpPr/>
+          <p:nvPr/>
+        </p:nvSpPr>
+        <p:spPr>
+          <a:xfrm>
+            <a:off x="3282696" y="1097280"/>
+            <a:ext cx="2578608" cy="36576"/>
+          </a:xfrm>
+          <a:prstGeom prst="rect">
+            <a:avLst/>
+          </a:prstGeom>
+          <a:solidFill>
+            <a:srgbClr val="009B8A"/>
+          </a:solidFill>
+          <a:ln/>
+        </p:spPr>
+        <p:txBody>
+          <a:bodyPr/>
+          <a:lstStyle/>
+          <a:p>
+            <a:endParaRPr lang="en-PH" sz="1000"/>
+          </a:p>
+        </p:txBody>
+      </p:sp>
+      <p:sp>
+        <p:nvSpPr>
+          <p:cNvPr id="1007" name="Text"/>
+          <p:cNvSpPr/>
+          <p:nvPr/>
+        </p:nvSpPr>
+        <p:spPr>
+          <a:xfrm>
+            <a:off x="3282696" y="1152144"/>
+            <a:ext cx="2578608" cy="210312"/>
+          </a:xfrm>
+          <a:prstGeom prst="rect">
+            <a:avLst/>
+          </a:prstGeom>
+          <a:noFill/>
+          <a:ln/>
+        </p:spPr>
+        <p:txBody>
+          <a:bodyPr wrap="square" rtlCol="0" anchor="ctr">
+            <a:normAutofit/>
+          </a:bodyPr>
+          <a:lstStyle/>
+          <a:p>
+            <a:pPr marL="0" indent="0" algn="l">
+              <a:buNone/>
+            </a:pPr>
+            <a:r>
+              <a:rPr lang="en-US" sz="1200" b="1" kern="0" dirty="0">
+                <a:solidFill>
+                  <a:srgbClr val="003D5B"/>
+                </a:solidFill>
+                <a:latin typeface="Calibri" pitchFamily="34" charset="0"/>
+                <a:ea typeface="Calibri" pitchFamily="34" charset="-122"/>
+                <a:cs typeface="Calibri" pitchFamily="34" charset="-120"/>
+              </a:rPr>
+              <a:t>Drill down to the source</a:t>
+            </a:r>
+          </a:p>
+        </p:txBody>
+      </p:sp>
+      <p:sp>
+        <p:nvSpPr>
+          <p:cNvPr id="1008" name="Text"/>
+          <p:cNvSpPr/>
+          <p:nvPr/>
+        </p:nvSpPr>
+        <p:spPr>
+          <a:xfrm>
+            <a:off x="3282696" y="1435607"/>
+            <a:ext cx="2578608" cy="786384"/>
+          </a:xfrm>
+          <a:prstGeom prst="rect">
+            <a:avLst/>
+          </a:prstGeom>
+          <a:noFill/>
+          <a:ln/>
+        </p:spPr>
+        <p:txBody>
+          <a:bodyPr wrap="square" rtlCol="0" anchor="t">
+            <a:normAutofit/>
+          </a:bodyPr>
+          <a:lstStyle/>
+          <a:p>
+            <a:pPr marL="0" indent="0" algn="l">
+              <a:lnSpc>
+                <a:spcPct val="92000"/>
+              </a:lnSpc>
+              <a:buNone/>
+            </a:pPr>
+            <a:r>
+              <a:rPr lang="en-US" sz="1000" b="0" kern="0" dirty="0">
+                <a:solidFill>
+                  <a:srgbClr val="333333"/>
+                </a:solidFill>
+                <a:latin typeface="Calibri" pitchFamily="34" charset="0"/>
+                <a:ea typeface="Calibri" pitchFamily="34" charset="-122"/>
+                <a:cs typeface="Calibri" pitchFamily="34" charset="-120"/>
+              </a:rPr>
+              <a:t>From department to site to library, so a number can always be traced to the place the activity happened.</a:t>
+            </a:r>
+          </a:p>
+        </p:txBody>
+      </p:sp>
+      <p:sp>
+        <p:nvSpPr>
+          <p:cNvPr id="1009" name="Rule"/>
+          <p:cNvSpPr/>
+          <p:nvPr/>
+        </p:nvSpPr>
+        <p:spPr>
+          <a:xfrm>
+            <a:off x="6153912" y="1097280"/>
+            <a:ext cx="2578608" cy="36576"/>
+          </a:xfrm>
+          <a:prstGeom prst="rect">
+            <a:avLst/>
+          </a:prstGeom>
+          <a:solidFill>
+            <a:srgbClr val="009B8A"/>
+          </a:solidFill>
+          <a:ln/>
+        </p:spPr>
+        <p:txBody>
+          <a:bodyPr/>
+          <a:lstStyle/>
+          <a:p>
+            <a:endParaRPr lang="en-PH" sz="1000"/>
+          </a:p>
+        </p:txBody>
+      </p:sp>
+      <p:sp>
+        <p:nvSpPr>
+          <p:cNvPr id="1010" name="Text"/>
+          <p:cNvSpPr/>
+          <p:nvPr/>
+        </p:nvSpPr>
+        <p:spPr>
+          <a:xfrm>
+            <a:off x="6153912" y="1152144"/>
+            <a:ext cx="2578608" cy="210312"/>
+          </a:xfrm>
+          <a:prstGeom prst="rect">
+            <a:avLst/>
+          </a:prstGeom>
+          <a:noFill/>
+          <a:ln/>
+        </p:spPr>
+        <p:txBody>
+          <a:bodyPr wrap="square" rtlCol="0" anchor="ctr">
+            <a:normAutofit/>
+          </a:bodyPr>
+          <a:lstStyle/>
+          <a:p>
+            <a:pPr marL="0" indent="0" algn="l">
+              <a:buNone/>
+            </a:pPr>
+            <a:r>
+              <a:rPr lang="en-US" sz="1200" b="1" kern="0" dirty="0">
+                <a:solidFill>
+                  <a:srgbClr val="003D5B"/>
+                </a:solidFill>
+                <a:latin typeface="Calibri" pitchFamily="34" charset="0"/>
+                <a:ea typeface="Calibri" pitchFamily="34" charset="-122"/>
+                <a:cs typeface="Calibri" pitchFamily="34" charset="-120"/>
+              </a:rPr>
+              <a:t>The working page</a:t>
+            </a:r>
+          </a:p>
+        </p:txBody>
+      </p:sp>
+      <p:sp>
+        <p:nvSpPr>
+          <p:cNvPr id="1011" name="Text"/>
+          <p:cNvSpPr/>
+          <p:nvPr/>
+        </p:nvSpPr>
+        <p:spPr>
+          <a:xfrm>
+            <a:off x="6153912" y="1435607"/>
+            <a:ext cx="2578608" cy="786384"/>
+          </a:xfrm>
+          <a:prstGeom prst="rect">
+            <a:avLst/>
+          </a:prstGeom>
+          <a:noFill/>
+          <a:ln/>
+        </p:spPr>
+        <p:txBody>
+          <a:bodyPr wrap="square" rtlCol="0" anchor="t">
+            <a:normAutofit/>
+          </a:bodyPr>
+          <a:lstStyle/>
+          <a:p>
+            <a:pPr marL="0" indent="0" algn="l">
+              <a:lnSpc>
+                <a:spcPct val="92000"/>
+              </a:lnSpc>
+              <a:buNone/>
+            </a:pPr>
+            <a:r>
+              <a:rPr lang="en-US" sz="1000" b="0" kern="0" dirty="0">
+                <a:solidFill>
+                  <a:srgbClr val="333333"/>
+                </a:solidFill>
+                <a:latin typeface="Calibri" pitchFamily="34" charset="0"/>
+                <a:ea typeface="Calibri" pitchFamily="34" charset="-122"/>
+                <a:cs typeface="Calibri" pitchFamily="34" charset="-120"/>
+              </a:rPr>
+              <a:t>This is where a Records Officer spends their time. It is the largest and most detailed page in the report.</a:t>
+            </a:r>
+          </a:p>
+        </p:txBody>
+      </p:sp>
+      <p:sp>
+        <p:nvSpPr>
+          <p:cNvPr id="1012" name="Text"/>
+          <p:cNvSpPr/>
+          <p:nvPr/>
+        </p:nvSpPr>
+        <p:spPr>
+          <a:xfrm>
+            <a:off x="411480" y="2231136"/>
+            <a:ext cx="4572000" cy="201168"/>
+          </a:xfrm>
+          <a:prstGeom prst="rect">
+            <a:avLst/>
+          </a:prstGeom>
+          <a:noFill/>
+          <a:ln/>
+        </p:spPr>
+        <p:txBody>
+          <a:bodyPr wrap="square" rtlCol="0" anchor="ctr">
+            <a:normAutofit/>
+          </a:bodyPr>
+          <a:lstStyle/>
+          <a:p>
+            <a:pPr marL="0" indent="0" algn="l">
+              <a:buNone/>
+            </a:pPr>
+            <a:r>
+              <a:rPr lang="en-US" sz="1200" b="1" kern="0" spc="105" dirty="0">
+                <a:solidFill>
+                  <a:srgbClr val="003D5B"/>
+                </a:solidFill>
+                <a:latin typeface="Calibri" pitchFamily="34" charset="0"/>
+                <a:ea typeface="Calibri" pitchFamily="34" charset="-122"/>
+                <a:cs typeface="Calibri" pitchFamily="34" charset="-120"/>
+              </a:rPr>
+              <a:t>WHAT YOU WILL SEE ON THE PAGE</a:t>
+            </a:r>
+          </a:p>
+        </p:txBody>
+      </p:sp>
+      <p:sp>
+        <p:nvSpPr>
+          <p:cNvPr id="1013" name="Panel"/>
+          <p:cNvSpPr/>
+          <p:nvPr/>
+        </p:nvSpPr>
+        <p:spPr>
+          <a:xfrm>
+            <a:off x="411480" y="2487168"/>
+            <a:ext cx="8321040" cy="2084831"/>
+          </a:xfrm>
+          <a:prstGeom prst="rect">
+            <a:avLst/>
+          </a:prstGeom>
+          <a:solidFill>
+            <a:srgbClr val="F4F7F8"/>
+          </a:solidFill>
+          <a:ln w="12700">
+            <a:solidFill>
+              <a:srgbClr val="D8DEE1"/>
+            </a:solidFill>
+            <a:prstDash val="solid"/>
+          </a:ln>
+        </p:spPr>
+        <p:txBody>
+          <a:bodyPr/>
+          <a:lstStyle/>
+          <a:p>
+            <a:endParaRPr lang="en-PH" sz="1000"/>
+          </a:p>
+        </p:txBody>
+      </p:sp>
+      <p:sp>
+        <p:nvSpPr>
+          <p:cNvPr id="1014" name="Rule"/>
+          <p:cNvSpPr/>
+          <p:nvPr/>
+        </p:nvSpPr>
+        <p:spPr>
+          <a:xfrm>
+            <a:off x="612648" y="2688336"/>
+            <a:ext cx="1655063" cy="32004"/>
+          </a:xfrm>
+          <a:prstGeom prst="rect">
+            <a:avLst/>
+          </a:prstGeom>
+          <a:solidFill>
+            <a:srgbClr val="009B8A"/>
+          </a:solidFill>
+          <a:ln/>
+        </p:spPr>
+        <p:txBody>
+          <a:bodyPr/>
+          <a:lstStyle/>
+          <a:p>
+            <a:endParaRPr lang="en-PH" sz="1000"/>
+          </a:p>
+        </p:txBody>
+      </p:sp>
+      <p:sp>
+        <p:nvSpPr>
+          <p:cNvPr id="1015" name="Text"/>
+          <p:cNvSpPr/>
+          <p:nvPr/>
+        </p:nvSpPr>
+        <p:spPr>
+          <a:xfrm>
+            <a:off x="612648" y="2761488"/>
+            <a:ext cx="1655063" cy="219456"/>
+          </a:xfrm>
+          <a:prstGeom prst="rect">
+            <a:avLst/>
+          </a:prstGeom>
+          <a:noFill/>
+          <a:ln/>
+        </p:spPr>
+        <p:txBody>
+          <a:bodyPr wrap="square" rtlCol="0" anchor="ctr">
+            <a:normAutofit/>
+          </a:bodyPr>
+          <a:lstStyle/>
+          <a:p>
+            <a:pPr marL="0" indent="0" algn="l">
+              <a:buNone/>
+            </a:pPr>
+            <a:r>
+              <a:rPr lang="en-US" sz="1050" b="1" kern="0" dirty="0">
+                <a:solidFill>
+                  <a:srgbClr val="003D5B"/>
+                </a:solidFill>
+                <a:latin typeface="Calibri" pitchFamily="34" charset="0"/>
+                <a:ea typeface="Calibri" pitchFamily="34" charset="-122"/>
+                <a:cs typeface="Calibri" pitchFamily="34" charset="-120"/>
+              </a:rPr>
+              <a:t>Profile</a:t>
+            </a:r>
+          </a:p>
+        </p:txBody>
+      </p:sp>
+      <p:sp>
+        <p:nvSpPr>
+          <p:cNvPr id="1016" name="Bullet"/>
+          <p:cNvSpPr/>
+          <p:nvPr/>
+        </p:nvSpPr>
+        <p:spPr>
+          <a:xfrm>
+            <a:off x="612648" y="3118103"/>
+            <a:ext cx="50292" cy="50292"/>
+          </a:xfrm>
+          <a:prstGeom prst="rect">
+            <a:avLst/>
+          </a:prstGeom>
+          <a:solidFill>
+            <a:srgbClr val="009B8A"/>
+          </a:solidFill>
+          <a:ln/>
+        </p:spPr>
+        <p:txBody>
+          <a:bodyPr/>
+          <a:lstStyle/>
+          <a:p>
+            <a:endParaRPr lang="en-PH" sz="1000"/>
+          </a:p>
+        </p:txBody>
+      </p:sp>
+      <p:sp>
+        <p:nvSpPr>
+          <p:cNvPr id="1017" name="Text"/>
+          <p:cNvSpPr/>
+          <p:nvPr/>
+        </p:nvSpPr>
+        <p:spPr>
+          <a:xfrm>
+            <a:off x="758952" y="3054096"/>
+            <a:ext cx="1545336" cy="201168"/>
+          </a:xfrm>
+          <a:prstGeom prst="rect">
+            <a:avLst/>
+          </a:prstGeom>
+          <a:noFill/>
+          <a:ln/>
+        </p:spPr>
+        <p:txBody>
+          <a:bodyPr wrap="square" rtlCol="0" anchor="ctr">
+            <a:normAutofit/>
+          </a:bodyPr>
+          <a:lstStyle/>
+          <a:p>
+            <a:pPr marL="0" indent="0" algn="l">
+              <a:buNone/>
+            </a:pPr>
+            <a:r>
+              <a:rPr lang="en-US" sz="900" b="0" kern="0" dirty="0">
+                <a:solidFill>
+                  <a:srgbClr val="333333"/>
+                </a:solidFill>
+                <a:latin typeface="Calibri" pitchFamily="34" charset="0"/>
+                <a:ea typeface="Calibri" pitchFamily="34" charset="-122"/>
+                <a:cs typeface="Calibri" pitchFamily="34" charset="-120"/>
+              </a:rPr>
+              <a:t>EDRMS compliant sites created</a:t>
+            </a:r>
+          </a:p>
+        </p:txBody>
+      </p:sp>
+      <p:sp>
+        <p:nvSpPr>
+          <p:cNvPr id="1018" name="Bullet"/>
+          <p:cNvSpPr/>
+          <p:nvPr/>
+        </p:nvSpPr>
+        <p:spPr>
+          <a:xfrm>
+            <a:off x="612648" y="3392423"/>
+            <a:ext cx="50292" cy="50292"/>
+          </a:xfrm>
+          <a:prstGeom prst="rect">
+            <a:avLst/>
+          </a:prstGeom>
+          <a:solidFill>
+            <a:srgbClr val="009B8A"/>
+          </a:solidFill>
+          <a:ln/>
+        </p:spPr>
+        <p:txBody>
+          <a:bodyPr/>
+          <a:lstStyle/>
+          <a:p>
+            <a:endParaRPr lang="en-PH" sz="1000"/>
+          </a:p>
+        </p:txBody>
+      </p:sp>
+      <p:sp>
+        <p:nvSpPr>
+          <p:cNvPr id="1019" name="Text"/>
+          <p:cNvSpPr/>
+          <p:nvPr/>
+        </p:nvSpPr>
+        <p:spPr>
+          <a:xfrm>
+            <a:off x="758952" y="3328415"/>
+            <a:ext cx="1545336" cy="201168"/>
+          </a:xfrm>
+          <a:prstGeom prst="rect">
+            <a:avLst/>
+          </a:prstGeom>
+          <a:noFill/>
+          <a:ln/>
+        </p:spPr>
+        <p:txBody>
+          <a:bodyPr wrap="square" rtlCol="0" anchor="ctr">
+            <a:normAutofit/>
+          </a:bodyPr>
+          <a:lstStyle/>
+          <a:p>
+            <a:pPr marL="0" indent="0" algn="l">
+              <a:buNone/>
+            </a:pPr>
+            <a:r>
+              <a:rPr lang="en-US" sz="900" b="0" kern="0" dirty="0">
+                <a:solidFill>
+                  <a:srgbClr val="333333"/>
+                </a:solidFill>
+                <a:latin typeface="Calibri" pitchFamily="34" charset="0"/>
+                <a:ea typeface="Calibri" pitchFamily="34" charset="-122"/>
+                <a:cs typeface="Calibri" pitchFamily="34" charset="-120"/>
+              </a:rPr>
+              <a:t>Users with recorded activity</a:t>
+            </a:r>
+          </a:p>
+        </p:txBody>
+      </p:sp>
+      <p:sp>
+        <p:nvSpPr>
+          <p:cNvPr id="1020" name="Bullet"/>
+          <p:cNvSpPr/>
+          <p:nvPr/>
+        </p:nvSpPr>
+        <p:spPr>
+          <a:xfrm>
+            <a:off x="612648" y="3666744"/>
+            <a:ext cx="50292" cy="50292"/>
+          </a:xfrm>
+          <a:prstGeom prst="rect">
+            <a:avLst/>
+          </a:prstGeom>
+          <a:solidFill>
+            <a:srgbClr val="009B8A"/>
+          </a:solidFill>
+          <a:ln/>
+        </p:spPr>
+        <p:txBody>
+          <a:bodyPr/>
+          <a:lstStyle/>
+          <a:p>
+            <a:endParaRPr lang="en-PH" sz="1000"/>
+          </a:p>
+        </p:txBody>
+      </p:sp>
+      <p:sp>
+        <p:nvSpPr>
+          <p:cNvPr id="1021" name="Text"/>
+          <p:cNvSpPr/>
+          <p:nvPr/>
+        </p:nvSpPr>
+        <p:spPr>
+          <a:xfrm>
+            <a:off x="758952" y="3602735"/>
+            <a:ext cx="1545336" cy="201168"/>
+          </a:xfrm>
+          <a:prstGeom prst="rect">
+            <a:avLst/>
+          </a:prstGeom>
+          <a:noFill/>
+          <a:ln/>
+        </p:spPr>
+        <p:txBody>
+          <a:bodyPr wrap="square" rtlCol="0" anchor="ctr">
+            <a:normAutofit/>
+          </a:bodyPr>
+          <a:lstStyle/>
+          <a:p>
+            <a:pPr marL="0" indent="0" algn="l">
+              <a:buNone/>
+            </a:pPr>
+            <a:r>
+              <a:rPr lang="en-US" sz="900" b="0" kern="0" dirty="0">
+                <a:solidFill>
+                  <a:srgbClr val="333333"/>
+                </a:solidFill>
+                <a:latin typeface="Calibri" pitchFamily="34" charset="0"/>
+                <a:ea typeface="Calibri" pitchFamily="34" charset="-122"/>
+                <a:cs typeface="Calibri" pitchFamily="34" charset="-120"/>
+              </a:rPr>
+              <a:t>Site visits</a:t>
+            </a:r>
+          </a:p>
+        </p:txBody>
+      </p:sp>
+      <p:sp>
+        <p:nvSpPr>
+          <p:cNvPr id="1022" name="Rule"/>
+          <p:cNvSpPr/>
+          <p:nvPr/>
+        </p:nvSpPr>
+        <p:spPr>
+          <a:xfrm>
+            <a:off x="2578608" y="2688336"/>
+            <a:ext cx="1655063" cy="32004"/>
+          </a:xfrm>
+          <a:prstGeom prst="rect">
+            <a:avLst/>
+          </a:prstGeom>
+          <a:solidFill>
+            <a:srgbClr val="009B8A"/>
+          </a:solidFill>
+          <a:ln/>
+        </p:spPr>
+        <p:txBody>
+          <a:bodyPr/>
+          <a:lstStyle/>
+          <a:p>
+            <a:endParaRPr lang="en-PH" sz="1000"/>
+          </a:p>
+        </p:txBody>
+      </p:sp>
+      <p:sp>
+        <p:nvSpPr>
+          <p:cNvPr id="1023" name="Text"/>
+          <p:cNvSpPr/>
+          <p:nvPr/>
+        </p:nvSpPr>
+        <p:spPr>
+          <a:xfrm>
+            <a:off x="2578608" y="2761488"/>
+            <a:ext cx="1655063" cy="219456"/>
+          </a:xfrm>
+          <a:prstGeom prst="rect">
+            <a:avLst/>
+          </a:prstGeom>
+          <a:noFill/>
+          <a:ln/>
+        </p:spPr>
+        <p:txBody>
+          <a:bodyPr wrap="square" rtlCol="0" anchor="ctr">
+            <a:normAutofit/>
+          </a:bodyPr>
+          <a:lstStyle/>
+          <a:p>
+            <a:pPr marL="0" indent="0" algn="l">
+              <a:buNone/>
+            </a:pPr>
+            <a:r>
+              <a:rPr lang="en-US" sz="1050" b="1" kern="0" dirty="0">
+                <a:solidFill>
+                  <a:srgbClr val="003D5B"/>
+                </a:solidFill>
+                <a:latin typeface="Calibri" pitchFamily="34" charset="0"/>
+                <a:ea typeface="Calibri" pitchFamily="34" charset="-122"/>
+                <a:cs typeface="Calibri" pitchFamily="34" charset="-120"/>
+              </a:rPr>
+              <a:t>Content</a:t>
+            </a:r>
+          </a:p>
+        </p:txBody>
+      </p:sp>
+      <p:sp>
+        <p:nvSpPr>
+          <p:cNvPr id="1024" name="Bullet"/>
+          <p:cNvSpPr/>
+          <p:nvPr/>
+        </p:nvSpPr>
+        <p:spPr>
+          <a:xfrm>
+            <a:off x="2578608" y="3118103"/>
+            <a:ext cx="50292" cy="50292"/>
+          </a:xfrm>
+          <a:prstGeom prst="rect">
+            <a:avLst/>
+          </a:prstGeom>
+          <a:solidFill>
+            <a:srgbClr val="009B8A"/>
+          </a:solidFill>
+          <a:ln/>
+        </p:spPr>
+        <p:txBody>
+          <a:bodyPr/>
+          <a:lstStyle/>
+          <a:p>
+            <a:endParaRPr lang="en-PH" sz="1000"/>
+          </a:p>
+        </p:txBody>
+      </p:sp>
+      <p:sp>
+        <p:nvSpPr>
+          <p:cNvPr id="1025" name="Text"/>
+          <p:cNvSpPr/>
+          <p:nvPr/>
+        </p:nvSpPr>
+        <p:spPr>
+          <a:xfrm>
+            <a:off x="2724912" y="3054096"/>
+            <a:ext cx="1545336" cy="201168"/>
+          </a:xfrm>
+          <a:prstGeom prst="rect">
+            <a:avLst/>
+          </a:prstGeom>
+          <a:noFill/>
+          <a:ln/>
+        </p:spPr>
+        <p:txBody>
+          <a:bodyPr wrap="square" rtlCol="0" anchor="ctr">
+            <a:normAutofit/>
+          </a:bodyPr>
+          <a:lstStyle/>
+          <a:p>
+            <a:pPr marL="0" indent="0" algn="l">
+              <a:buNone/>
+            </a:pPr>
+            <a:r>
+              <a:rPr lang="en-US" sz="900" b="0" kern="0" dirty="0">
+                <a:solidFill>
+                  <a:srgbClr val="333333"/>
+                </a:solidFill>
+                <a:latin typeface="Calibri" pitchFamily="34" charset="0"/>
+                <a:ea typeface="Calibri" pitchFamily="34" charset="-122"/>
+                <a:cs typeface="Calibri" pitchFamily="34" charset="-120"/>
+              </a:rPr>
+              <a:t>Total documents</a:t>
+            </a:r>
+          </a:p>
+        </p:txBody>
+      </p:sp>
+      <p:sp>
+        <p:nvSpPr>
+          <p:cNvPr id="1026" name="Bullet"/>
+          <p:cNvSpPr/>
+          <p:nvPr/>
+        </p:nvSpPr>
+        <p:spPr>
+          <a:xfrm>
+            <a:off x="2578608" y="3392423"/>
+            <a:ext cx="50292" cy="50292"/>
+          </a:xfrm>
+          <a:prstGeom prst="rect">
+            <a:avLst/>
+          </a:prstGeom>
+          <a:solidFill>
+            <a:srgbClr val="009B8A"/>
+          </a:solidFill>
+          <a:ln/>
+        </p:spPr>
+        <p:txBody>
+          <a:bodyPr/>
+          <a:lstStyle/>
+          <a:p>
+            <a:endParaRPr lang="en-PH" sz="1000"/>
+          </a:p>
+        </p:txBody>
+      </p:sp>
+      <p:sp>
+        <p:nvSpPr>
+          <p:cNvPr id="1027" name="Text"/>
+          <p:cNvSpPr/>
+          <p:nvPr/>
+        </p:nvSpPr>
+        <p:spPr>
+          <a:xfrm>
+            <a:off x="2724912" y="3328415"/>
+            <a:ext cx="1545336" cy="201168"/>
+          </a:xfrm>
+          <a:prstGeom prst="rect">
+            <a:avLst/>
+          </a:prstGeom>
+          <a:noFill/>
+          <a:ln/>
+        </p:spPr>
+        <p:txBody>
+          <a:bodyPr wrap="square" rtlCol="0" anchor="ctr">
+            <a:normAutofit/>
+          </a:bodyPr>
+          <a:lstStyle/>
+          <a:p>
+            <a:pPr marL="0" indent="0" algn="l">
+              <a:buNone/>
+            </a:pPr>
+            <a:r>
+              <a:rPr lang="en-US" sz="900" b="0" kern="0" dirty="0">
+                <a:solidFill>
+                  <a:srgbClr val="333333"/>
+                </a:solidFill>
+                <a:latin typeface="Calibri" pitchFamily="34" charset="0"/>
+                <a:ea typeface="Calibri" pitchFamily="34" charset="-122"/>
+                <a:cs typeface="Calibri" pitchFamily="34" charset="-120"/>
+              </a:rPr>
+              <a:t>Total documents size</a:t>
+            </a:r>
+          </a:p>
+        </p:txBody>
+      </p:sp>
+      <p:sp>
+        <p:nvSpPr>
+          <p:cNvPr id="1028" name="Bullet"/>
+          <p:cNvSpPr/>
+          <p:nvPr/>
+        </p:nvSpPr>
+        <p:spPr>
+          <a:xfrm>
+            <a:off x="2578608" y="3666744"/>
+            <a:ext cx="50292" cy="50292"/>
+          </a:xfrm>
+          <a:prstGeom prst="rect">
+            <a:avLst/>
+          </a:prstGeom>
+          <a:solidFill>
+            <a:srgbClr val="009B8A"/>
+          </a:solidFill>
+          <a:ln/>
+        </p:spPr>
+        <p:txBody>
+          <a:bodyPr/>
+          <a:lstStyle/>
+          <a:p>
+            <a:endParaRPr lang="en-PH" sz="1000"/>
+          </a:p>
+        </p:txBody>
+      </p:sp>
+      <p:sp>
+        <p:nvSpPr>
+          <p:cNvPr id="1029" name="Text"/>
+          <p:cNvSpPr/>
+          <p:nvPr/>
+        </p:nvSpPr>
+        <p:spPr>
+          <a:xfrm>
+            <a:off x="2724912" y="3602735"/>
+            <a:ext cx="1545336" cy="201168"/>
+          </a:xfrm>
+          <a:prstGeom prst="rect">
+            <a:avLst/>
+          </a:prstGeom>
+          <a:noFill/>
+          <a:ln/>
+        </p:spPr>
+        <p:txBody>
+          <a:bodyPr wrap="square" rtlCol="0" anchor="ctr">
+            <a:normAutofit/>
+          </a:bodyPr>
+          <a:lstStyle/>
+          <a:p>
+            <a:pPr marL="0" indent="0" algn="l">
+              <a:buNone/>
+            </a:pPr>
+            <a:r>
+              <a:rPr lang="en-US" sz="900" b="0" kern="0" dirty="0">
+                <a:solidFill>
+                  <a:srgbClr val="333333"/>
+                </a:solidFill>
+                <a:latin typeface="Calibri" pitchFamily="34" charset="0"/>
+                <a:ea typeface="Calibri" pitchFamily="34" charset="-122"/>
+                <a:cs typeface="Calibri" pitchFamily="34" charset="-120"/>
+              </a:rPr>
+              <a:t>Records declared and who declared them</a:t>
+            </a:r>
+          </a:p>
+        </p:txBody>
+      </p:sp>
+      <p:sp>
+        <p:nvSpPr>
+          <p:cNvPr id="1030" name="Rule"/>
+          <p:cNvSpPr/>
+          <p:nvPr/>
+        </p:nvSpPr>
+        <p:spPr>
+          <a:xfrm>
+            <a:off x="4544568" y="2688336"/>
+            <a:ext cx="1655063" cy="32004"/>
+          </a:xfrm>
+          <a:prstGeom prst="rect">
+            <a:avLst/>
+          </a:prstGeom>
+          <a:solidFill>
+            <a:srgbClr val="009B8A"/>
+          </a:solidFill>
+          <a:ln/>
+        </p:spPr>
+        <p:txBody>
+          <a:bodyPr/>
+          <a:lstStyle/>
+          <a:p>
+            <a:endParaRPr lang="en-PH" sz="1000"/>
+          </a:p>
+        </p:txBody>
+      </p:sp>
+      <p:sp>
+        <p:nvSpPr>
+          <p:cNvPr id="1031" name="Text"/>
+          <p:cNvSpPr/>
+          <p:nvPr/>
+        </p:nvSpPr>
+        <p:spPr>
+          <a:xfrm>
+            <a:off x="4544568" y="2761488"/>
+            <a:ext cx="1655063" cy="219456"/>
+          </a:xfrm>
+          <a:prstGeom prst="rect">
+            <a:avLst/>
+          </a:prstGeom>
+          <a:noFill/>
+          <a:ln/>
+        </p:spPr>
+        <p:txBody>
+          <a:bodyPr wrap="square" rtlCol="0" anchor="ctr">
+            <a:normAutofit/>
+          </a:bodyPr>
+          <a:lstStyle/>
+          <a:p>
+            <a:pPr marL="0" indent="0" algn="l">
+              <a:buNone/>
+            </a:pPr>
+            <a:r>
+              <a:rPr lang="en-US" sz="1050" b="1" kern="0" dirty="0">
+                <a:solidFill>
+                  <a:srgbClr val="003D5B"/>
+                </a:solidFill>
+                <a:latin typeface="Calibri" pitchFamily="34" charset="0"/>
+                <a:ea typeface="Calibri" pitchFamily="34" charset="-122"/>
+                <a:cs typeface="Calibri" pitchFamily="34" charset="-120"/>
+              </a:rPr>
+              <a:t>Engagement</a:t>
+            </a:r>
+          </a:p>
+        </p:txBody>
+      </p:sp>
+      <p:sp>
+        <p:nvSpPr>
+          <p:cNvPr id="1032" name="Bullet"/>
+          <p:cNvSpPr/>
+          <p:nvPr/>
+        </p:nvSpPr>
+        <p:spPr>
+          <a:xfrm>
+            <a:off x="4544568" y="3118103"/>
+            <a:ext cx="50292" cy="50292"/>
+          </a:xfrm>
+          <a:prstGeom prst="rect">
+            <a:avLst/>
+          </a:prstGeom>
+          <a:solidFill>
+            <a:srgbClr val="009B8A"/>
+          </a:solidFill>
+          <a:ln/>
+        </p:spPr>
+        <p:txBody>
+          <a:bodyPr/>
+          <a:lstStyle/>
+          <a:p>
+            <a:endParaRPr lang="en-PH" sz="1000"/>
+          </a:p>
+        </p:txBody>
+      </p:sp>
+      <p:sp>
+        <p:nvSpPr>
+          <p:cNvPr id="1033" name="Text"/>
+          <p:cNvSpPr/>
+          <p:nvPr/>
+        </p:nvSpPr>
+        <p:spPr>
+          <a:xfrm>
+            <a:off x="4690872" y="3054096"/>
+            <a:ext cx="1545336" cy="201168"/>
+          </a:xfrm>
+          <a:prstGeom prst="rect">
+            <a:avLst/>
+          </a:prstGeom>
+          <a:noFill/>
+          <a:ln/>
+        </p:spPr>
+        <p:txBody>
+          <a:bodyPr wrap="square" rtlCol="0" anchor="ctr">
+            <a:normAutofit/>
+          </a:bodyPr>
+          <a:lstStyle/>
+          <a:p>
+            <a:pPr marL="0" indent="0" algn="l">
+              <a:buNone/>
+            </a:pPr>
+            <a:r>
+              <a:rPr lang="en-US" sz="900" b="0" kern="0" dirty="0">
+                <a:solidFill>
+                  <a:srgbClr val="333333"/>
+                </a:solidFill>
+                <a:latin typeface="Calibri" pitchFamily="34" charset="0"/>
+                <a:ea typeface="Calibri" pitchFamily="34" charset="-122"/>
+                <a:cs typeface="Calibri" pitchFamily="34" charset="-120"/>
+              </a:rPr>
+              <a:t>Sites with no declared record in 180 days</a:t>
+            </a:r>
+          </a:p>
+        </p:txBody>
+      </p:sp>
+      <p:sp>
+        <p:nvSpPr>
+          <p:cNvPr id="1034" name="Bullet"/>
+          <p:cNvSpPr/>
+          <p:nvPr/>
+        </p:nvSpPr>
+        <p:spPr>
+          <a:xfrm>
+            <a:off x="4544568" y="3392423"/>
+            <a:ext cx="50292" cy="50292"/>
+          </a:xfrm>
+          <a:prstGeom prst="rect">
+            <a:avLst/>
+          </a:prstGeom>
+          <a:solidFill>
+            <a:srgbClr val="009B8A"/>
+          </a:solidFill>
+          <a:ln/>
+        </p:spPr>
+        <p:txBody>
+          <a:bodyPr/>
+          <a:lstStyle/>
+          <a:p>
+            <a:endParaRPr lang="en-PH" sz="1000"/>
+          </a:p>
+        </p:txBody>
+      </p:sp>
+      <p:sp>
+        <p:nvSpPr>
+          <p:cNvPr id="1035" name="Text"/>
+          <p:cNvSpPr/>
+          <p:nvPr/>
+        </p:nvSpPr>
+        <p:spPr>
+          <a:xfrm>
+            <a:off x="4690872" y="3328415"/>
+            <a:ext cx="1545336" cy="201168"/>
+          </a:xfrm>
+          <a:prstGeom prst="rect">
+            <a:avLst/>
+          </a:prstGeom>
+          <a:noFill/>
+          <a:ln/>
+        </p:spPr>
+        <p:txBody>
+          <a:bodyPr wrap="square" rtlCol="0" anchor="ctr">
+            <a:normAutofit/>
+          </a:bodyPr>
+          <a:lstStyle/>
+          <a:p>
+            <a:pPr marL="0" indent="0" algn="l">
+              <a:buNone/>
+            </a:pPr>
+            <a:r>
+              <a:rPr lang="en-US" sz="900" b="0" kern="0" dirty="0">
+                <a:solidFill>
+                  <a:srgbClr val="333333"/>
+                </a:solidFill>
+                <a:latin typeface="Calibri" pitchFamily="34" charset="0"/>
+                <a:ea typeface="Calibri" pitchFamily="34" charset="-122"/>
+                <a:cs typeface="Calibri" pitchFamily="34" charset="-120"/>
+              </a:rPr>
+              <a:t>Access activity per site</a:t>
+            </a:r>
+          </a:p>
+        </p:txBody>
+      </p:sp>
+      <p:sp>
+        <p:nvSpPr>
+          <p:cNvPr id="1036" name="Rule"/>
+          <p:cNvSpPr/>
+          <p:nvPr/>
+        </p:nvSpPr>
+        <p:spPr>
+          <a:xfrm>
+            <a:off x="6510527" y="2688336"/>
+            <a:ext cx="1655063" cy="32004"/>
+          </a:xfrm>
+          <a:prstGeom prst="rect">
+            <a:avLst/>
+          </a:prstGeom>
+          <a:solidFill>
+            <a:srgbClr val="009B8A"/>
+          </a:solidFill>
+          <a:ln/>
+        </p:spPr>
+        <p:txBody>
+          <a:bodyPr/>
+          <a:lstStyle/>
+          <a:p>
+            <a:endParaRPr lang="en-PH" sz="1000"/>
+          </a:p>
+        </p:txBody>
+      </p:sp>
+      <p:sp>
+        <p:nvSpPr>
+          <p:cNvPr id="1037" name="Text"/>
+          <p:cNvSpPr/>
+          <p:nvPr/>
+        </p:nvSpPr>
+        <p:spPr>
+          <a:xfrm>
+            <a:off x="6510527" y="2761488"/>
+            <a:ext cx="1655063" cy="219456"/>
+          </a:xfrm>
+          <a:prstGeom prst="rect">
+            <a:avLst/>
+          </a:prstGeom>
+          <a:noFill/>
+          <a:ln/>
+        </p:spPr>
+        <p:txBody>
+          <a:bodyPr wrap="square" rtlCol="0" anchor="ctr">
+            <a:normAutofit/>
+          </a:bodyPr>
+          <a:lstStyle/>
+          <a:p>
+            <a:pPr marL="0" indent="0" algn="l">
+              <a:buNone/>
+            </a:pPr>
+            <a:r>
+              <a:rPr lang="en-US" sz="1050" b="1" kern="0" dirty="0">
+                <a:solidFill>
+                  <a:srgbClr val="003D5B"/>
+                </a:solidFill>
+                <a:latin typeface="Calibri" pitchFamily="34" charset="0"/>
+                <a:ea typeface="Calibri" pitchFamily="34" charset="-122"/>
+                <a:cs typeface="Calibri" pitchFamily="34" charset="-120"/>
+              </a:rPr>
+              <a:t>Retention position</a:t>
+            </a:r>
+          </a:p>
+        </p:txBody>
+      </p:sp>
+      <p:sp>
+        <p:nvSpPr>
+          <p:cNvPr id="1038" name="Bullet"/>
+          <p:cNvSpPr/>
+          <p:nvPr/>
+        </p:nvSpPr>
+        <p:spPr>
+          <a:xfrm>
+            <a:off x="6510527" y="3118103"/>
+            <a:ext cx="50292" cy="50292"/>
+          </a:xfrm>
+          <a:prstGeom prst="rect">
+            <a:avLst/>
+          </a:prstGeom>
+          <a:solidFill>
+            <a:srgbClr val="009B8A"/>
+          </a:solidFill>
+          <a:ln/>
+        </p:spPr>
+        <p:txBody>
+          <a:bodyPr/>
+          <a:lstStyle/>
+          <a:p>
+            <a:endParaRPr lang="en-PH" sz="1000"/>
+          </a:p>
+        </p:txBody>
+      </p:sp>
+      <p:sp>
+        <p:nvSpPr>
+          <p:cNvPr id="1039" name="Text"/>
+          <p:cNvSpPr/>
+          <p:nvPr/>
+        </p:nvSpPr>
+        <p:spPr>
+          <a:xfrm>
+            <a:off x="6656831" y="3054096"/>
+            <a:ext cx="1545336" cy="201168"/>
+          </a:xfrm>
+          <a:prstGeom prst="rect">
+            <a:avLst/>
+          </a:prstGeom>
+          <a:noFill/>
+          <a:ln/>
+        </p:spPr>
+        <p:txBody>
+          <a:bodyPr wrap="square" rtlCol="0" anchor="ctr">
+            <a:normAutofit/>
+          </a:bodyPr>
+          <a:lstStyle/>
+          <a:p>
+            <a:pPr marL="0" indent="0" algn="l">
+              <a:buNone/>
+            </a:pPr>
+            <a:r>
+              <a:rPr lang="en-US" sz="900" b="0" kern="0" dirty="0">
+                <a:solidFill>
+                  <a:srgbClr val="333333"/>
+                </a:solidFill>
+                <a:latin typeface="Calibri" pitchFamily="34" charset="0"/>
+                <a:ea typeface="Calibri" pitchFamily="34" charset="-122"/>
+                <a:cs typeface="Calibri" pitchFamily="34" charset="-120"/>
+              </a:rPr>
+              <a:t>Due within 3, 6 and 12 months</a:t>
+            </a:r>
+          </a:p>
+        </p:txBody>
+      </p:sp>
+      <p:sp>
+        <p:nvSpPr>
+          <p:cNvPr id="1040" name="Bullet"/>
+          <p:cNvSpPr/>
+          <p:nvPr/>
+        </p:nvSpPr>
+        <p:spPr>
+          <a:xfrm>
+            <a:off x="6510527" y="3392423"/>
+            <a:ext cx="50292" cy="50292"/>
+          </a:xfrm>
+          <a:prstGeom prst="rect">
+            <a:avLst/>
+          </a:prstGeom>
+          <a:solidFill>
+            <a:srgbClr val="009B8A"/>
+          </a:solidFill>
+          <a:ln/>
+        </p:spPr>
+        <p:txBody>
+          <a:bodyPr/>
+          <a:lstStyle/>
+          <a:p>
+            <a:endParaRPr lang="en-PH" sz="1000"/>
+          </a:p>
+        </p:txBody>
+      </p:sp>
+      <p:sp>
+        <p:nvSpPr>
+          <p:cNvPr id="1041" name="Text"/>
+          <p:cNvSpPr/>
+          <p:nvPr/>
+        </p:nvSpPr>
+        <p:spPr>
+          <a:xfrm>
+            <a:off x="6656831" y="3328415"/>
+            <a:ext cx="1545336" cy="201168"/>
+          </a:xfrm>
+          <a:prstGeom prst="rect">
+            <a:avLst/>
+          </a:prstGeom>
+          <a:noFill/>
+          <a:ln/>
+        </p:spPr>
+        <p:txBody>
+          <a:bodyPr wrap="square" rtlCol="0" anchor="ctr">
+            <a:normAutofit/>
+          </a:bodyPr>
+          <a:lstStyle/>
+          <a:p>
+            <a:pPr marL="0" indent="0" algn="l">
+              <a:buNone/>
+            </a:pPr>
+            <a:r>
+              <a:rPr lang="en-US" sz="900" b="0" kern="0" dirty="0">
+                <a:solidFill>
+                  <a:srgbClr val="333333"/>
+                </a:solidFill>
+                <a:latin typeface="Calibri" pitchFamily="34" charset="0"/>
+                <a:ea typeface="Calibri" pitchFamily="34" charset="-122"/>
+                <a:cs typeface="Calibri" pitchFamily="34" charset="-120"/>
+              </a:rPr>
+              <a:t>Records with a physical counterpart</a:t>
+            </a:r>
           </a:p>
         </p:txBody>
       </p:sp>
     </p:spTree>
-    <p:extLst>
-      <p:ext uri="{BB962C8B-B14F-4D97-AF65-F5344CB8AC3E}">
-        <p14:creationId xmlns:p14="http://schemas.microsoft.com/office/powerpoint/2010/main" val="512977960"/>
-      </p:ext>
-    </p:extLst>
   </p:cSld>
   <p:clrMapOvr>
     <a:masterClrMapping/>
@@ -9327,16 +10688,18 @@
 
 <file path=ppt/slides/slide7.xml><?xml version="1.0" encoding="utf-8"?>
 <p:sld xmlns:a="http://schemas.openxmlformats.org/drawingml/2006/main" xmlns:r="http://schemas.openxmlformats.org/officeDocument/2006/relationships" xmlns:p="http://schemas.openxmlformats.org/presentationml/2006/main">
-  <p:cSld>
+  <p:cSld name="Department Insights — asks">
+    <p:bg>
+      <p:bgPr>
+        <a:solidFill>
+          <a:srgbClr val="FFFFFF"/>
+        </a:solidFill>
+        <a:effectLst/>
+      </p:bgPr>
+    </p:bg>
     <p:spTree>
       <p:nvGrpSpPr>
-        <p:cNvPr id="1" name="">
-          <a:extLst>
-            <a:ext uri="{FF2B5EF4-FFF2-40B4-BE49-F238E27FC236}">
-              <a16:creationId xmlns:a16="http://schemas.microsoft.com/office/drawing/2014/main" id="{20056439-71B3-50FB-9825-0741497DE1CA}"/>
-            </a:ext>
-          </a:extLst>
-        </p:cNvPr>
+        <p:cNvPr id="1" name=""/>
         <p:cNvGrpSpPr/>
         <p:nvPr/>
       </p:nvGrpSpPr>
@@ -9350,19 +10713,13 @@
       </p:grpSpPr>
       <p:sp>
         <p:nvSpPr>
-          <p:cNvPr id="4" name="Text 2">
-            <a:extLst>
-              <a:ext uri="{FF2B5EF4-FFF2-40B4-BE49-F238E27FC236}">
-                <a16:creationId xmlns:a16="http://schemas.microsoft.com/office/drawing/2014/main" id="{A3C9C16C-A28B-9EF2-8661-23A4ED2443E9}"/>
-              </a:ext>
-            </a:extLst>
-          </p:cNvPr>
-          <p:cNvSpPr/>
-          <p:nvPr/>
-        </p:nvSpPr>
-        <p:spPr>
-          <a:xfrm>
-            <a:off x="198186" y="93986"/>
+          <p:cNvPr id="1042" name="Title"/>
+          <p:cNvSpPr/>
+          <p:nvPr/>
+        </p:nvSpPr>
+        <p:spPr>
+          <a:xfrm>
+            <a:off x="201168" y="91440"/>
             <a:ext cx="8412480" cy="493776"/>
           </a:xfrm>
           <a:prstGeom prst="rect">
@@ -9372,44 +10729,1076 @@
           <a:ln/>
         </p:spPr>
         <p:txBody>
-          <a:bodyPr wrap="square" lIns="0" tIns="0" rIns="0" bIns="0" rtlCol="0" anchor="ctr"/>
-          <a:lstStyle/>
-          <a:p>
-            <a:pPr marL="0" indent="0">
+          <a:bodyPr wrap="square" rtlCol="0" anchor="ctr">
+            <a:normAutofit/>
+          </a:bodyPr>
+          <a:lstStyle/>
+          <a:p>
+            <a:pPr marL="0" indent="0" algn="l">
               <a:buNone/>
             </a:pPr>
             <a:r>
-              <a:rPr lang="en-US" sz="2700" b="1" dirty="0">
-                <a:solidFill>
-                  <a:schemeClr val="tx2">
-                    <a:lumMod val="76000"/>
-                  </a:schemeClr>
-                </a:solidFill>
-                <a:latin typeface="Cambria"/>
-                <a:ea typeface="Cambria"/>
-                <a:cs typeface="Cambria" pitchFamily="34" charset="-120"/>
+              <a:rPr lang="en-US" sz="2700" b="1" kern="0" dirty="0">
+                <a:solidFill>
+                  <a:srgbClr val="003D5B"/>
+                </a:solidFill>
+                <a:latin typeface="Calibri" pitchFamily="34" charset="0"/>
+                <a:ea typeface="Calibri" pitchFamily="34" charset="-122"/>
+                <a:cs typeface="Calibri" pitchFamily="34" charset="-120"/>
               </a:rPr>
               <a:t>Department Insights</a:t>
             </a:r>
-            <a:endParaRPr lang="en-US" sz="2700" dirty="0">
-              <a:solidFill>
-                <a:schemeClr val="tx2">
-                  <a:lumMod val="76000"/>
-                </a:schemeClr>
-              </a:solidFill>
-              <a:latin typeface="Cambria"/>
-              <a:ea typeface="Cambria"/>
-              <a:cs typeface="Calibri"/>
-            </a:endParaRPr>
+          </a:p>
+        </p:txBody>
+      </p:sp>
+      <p:sp>
+        <p:nvSpPr>
+          <p:cNvPr id="1043" name="Subtitle"/>
+          <p:cNvSpPr/>
+          <p:nvPr/>
+        </p:nvSpPr>
+        <p:spPr>
+          <a:xfrm>
+            <a:off x="192024" y="640080"/>
+            <a:ext cx="8412480" cy="310896"/>
+          </a:xfrm>
+          <a:prstGeom prst="rect">
+            <a:avLst/>
+          </a:prstGeom>
+          <a:noFill/>
+          <a:ln/>
+        </p:spPr>
+        <p:txBody>
+          <a:bodyPr wrap="square" rtlCol="0" anchor="ctr">
+            <a:normAutofit/>
+          </a:bodyPr>
+          <a:lstStyle/>
+          <a:p>
+            <a:pPr marL="0" indent="0" algn="l">
+              <a:buNone/>
+            </a:pPr>
+            <a:r>
+              <a:rPr lang="en-US" sz="1400" b="0" kern="0" dirty="0">
+                <a:solidFill>
+                  <a:srgbClr val="009B8A"/>
+                </a:solidFill>
+                <a:latin typeface="Calibri" pitchFamily="34" charset="0"/>
+                <a:ea typeface="Calibri" pitchFamily="34" charset="-122"/>
+                <a:cs typeface="Calibri" pitchFamily="34" charset="-120"/>
+              </a:rPr>
+              <a:t>What we need from you before these can be built.</a:t>
+            </a:r>
+          </a:p>
+        </p:txBody>
+      </p:sp>
+      <p:sp>
+        <p:nvSpPr>
+          <p:cNvPr id="1044" name="Text"/>
+          <p:cNvSpPr/>
+          <p:nvPr/>
+        </p:nvSpPr>
+        <p:spPr>
+          <a:xfrm>
+            <a:off x="411480" y="1024128"/>
+            <a:ext cx="4572000" cy="201168"/>
+          </a:xfrm>
+          <a:prstGeom prst="rect">
+            <a:avLst/>
+          </a:prstGeom>
+          <a:noFill/>
+          <a:ln/>
+        </p:spPr>
+        <p:txBody>
+          <a:bodyPr wrap="square" rtlCol="0" anchor="ctr">
+            <a:normAutofit/>
+          </a:bodyPr>
+          <a:lstStyle/>
+          <a:p>
+            <a:pPr marL="0" indent="0" algn="l">
+              <a:buNone/>
+            </a:pPr>
+            <a:r>
+              <a:rPr lang="en-US" sz="1200" b="1" kern="0" spc="105" dirty="0">
+                <a:solidFill>
+                  <a:srgbClr val="003D5B"/>
+                </a:solidFill>
+                <a:latin typeface="Calibri" pitchFamily="34" charset="0"/>
+                <a:ea typeface="Calibri" pitchFamily="34" charset="-122"/>
+                <a:cs typeface="Calibri" pitchFamily="34" charset="-120"/>
+              </a:rPr>
+              <a:t>WHAT WE NEED FROM YOU</a:t>
+            </a:r>
+          </a:p>
+        </p:txBody>
+      </p:sp>
+      <p:sp>
+        <p:nvSpPr>
+          <p:cNvPr id="1045" name="Panel"/>
+          <p:cNvSpPr/>
+          <p:nvPr/>
+        </p:nvSpPr>
+        <p:spPr>
+          <a:xfrm>
+            <a:off x="411480" y="1298448"/>
+            <a:ext cx="8321040" cy="1188720"/>
+          </a:xfrm>
+          <a:prstGeom prst="rect">
+            <a:avLst/>
+          </a:prstGeom>
+          <a:solidFill>
+            <a:srgbClr val="D1FAE5"/>
+          </a:solidFill>
+          <a:ln w="12700">
+            <a:solidFill>
+              <a:srgbClr val="6EE7B7"/>
+            </a:solidFill>
+            <a:prstDash val="solid"/>
+          </a:ln>
+        </p:spPr>
+        <p:txBody>
+          <a:bodyPr/>
+          <a:lstStyle/>
+          <a:p>
+            <a:endParaRPr lang="en-PH" sz="1000"/>
+          </a:p>
+        </p:txBody>
+      </p:sp>
+      <p:sp>
+        <p:nvSpPr>
+          <p:cNvPr id="1046" name="Shape"/>
+          <p:cNvSpPr/>
+          <p:nvPr/>
+        </p:nvSpPr>
+        <p:spPr>
+          <a:xfrm>
+            <a:off x="411480" y="1298448"/>
+            <a:ext cx="50292" cy="1188720"/>
+          </a:xfrm>
+          <a:prstGeom prst="rect">
+            <a:avLst/>
+          </a:prstGeom>
+          <a:solidFill>
+            <a:srgbClr val="009B8A"/>
+          </a:solidFill>
+          <a:ln/>
+        </p:spPr>
+        <p:txBody>
+          <a:bodyPr/>
+          <a:lstStyle/>
+          <a:p>
+            <a:endParaRPr lang="en-PH" sz="1000"/>
+          </a:p>
+        </p:txBody>
+      </p:sp>
+      <p:sp>
+        <p:nvSpPr>
+          <p:cNvPr id="1047" name="Shape"/>
+          <p:cNvSpPr/>
+          <p:nvPr/>
+        </p:nvSpPr>
+        <p:spPr>
+          <a:xfrm>
+            <a:off x="630936" y="1444752"/>
+            <a:ext cx="256032" cy="256032"/>
+          </a:xfrm>
+          <a:prstGeom prst="ellipse">
+            <a:avLst/>
+          </a:prstGeom>
+          <a:solidFill>
+            <a:srgbClr val="009B8A"/>
+          </a:solidFill>
+          <a:ln/>
+        </p:spPr>
+        <p:txBody>
+          <a:bodyPr/>
+          <a:lstStyle/>
+          <a:p>
+            <a:endParaRPr lang="en-PH" sz="1000"/>
+          </a:p>
+        </p:txBody>
+      </p:sp>
+      <p:sp>
+        <p:nvSpPr>
+          <p:cNvPr id="1048" name="Text"/>
+          <p:cNvSpPr/>
+          <p:nvPr/>
+        </p:nvSpPr>
+        <p:spPr>
+          <a:xfrm>
+            <a:off x="630936" y="1463040"/>
+            <a:ext cx="256032" cy="219456"/>
+          </a:xfrm>
+          <a:prstGeom prst="rect">
+            <a:avLst/>
+          </a:prstGeom>
+          <a:noFill/>
+          <a:ln/>
+        </p:spPr>
+        <p:txBody>
+          <a:bodyPr wrap="square" rtlCol="0" anchor="ctr">
+            <a:normAutofit/>
+          </a:bodyPr>
+          <a:lstStyle/>
+          <a:p>
+            <a:pPr marL="0" indent="0" algn="ctr">
+              <a:buNone/>
+            </a:pPr>
+            <a:r>
+              <a:rPr lang="en-US" sz="1100" b="1" kern="0" dirty="0">
+                <a:solidFill>
+                  <a:srgbClr val="FFFFFF"/>
+                </a:solidFill>
+                <a:latin typeface="Calibri" pitchFamily="34" charset="0"/>
+                <a:ea typeface="Calibri" pitchFamily="34" charset="-122"/>
+                <a:cs typeface="Calibri" pitchFamily="34" charset="-120"/>
+              </a:rPr>
+              <a:t>1</a:t>
+            </a:r>
+          </a:p>
+        </p:txBody>
+      </p:sp>
+      <p:sp>
+        <p:nvSpPr>
+          <p:cNvPr id="1049" name="Text"/>
+          <p:cNvSpPr/>
+          <p:nvPr/>
+        </p:nvSpPr>
+        <p:spPr>
+          <a:xfrm>
+            <a:off x="978408" y="1426464"/>
+            <a:ext cx="2926080" cy="256032"/>
+          </a:xfrm>
+          <a:prstGeom prst="rect">
+            <a:avLst/>
+          </a:prstGeom>
+          <a:noFill/>
+          <a:ln/>
+        </p:spPr>
+        <p:txBody>
+          <a:bodyPr wrap="square" rtlCol="0" anchor="ctr">
+            <a:normAutofit/>
+          </a:bodyPr>
+          <a:lstStyle/>
+          <a:p>
+            <a:pPr marL="0" indent="0" algn="l">
+              <a:buNone/>
+            </a:pPr>
+            <a:r>
+              <a:rPr lang="en-US" sz="1250" b="1" kern="0" dirty="0">
+                <a:solidFill>
+                  <a:srgbClr val="003D5B"/>
+                </a:solidFill>
+                <a:latin typeface="Calibri" pitchFamily="34" charset="0"/>
+                <a:ea typeface="Calibri" pitchFamily="34" charset="-122"/>
+                <a:cs typeface="Calibri" pitchFamily="34" charset="-120"/>
+              </a:rPr>
+              <a:t>The Division list</a:t>
+            </a:r>
+          </a:p>
+        </p:txBody>
+      </p:sp>
+      <p:sp>
+        <p:nvSpPr>
+          <p:cNvPr id="1050" name="Text"/>
+          <p:cNvSpPr/>
+          <p:nvPr/>
+        </p:nvSpPr>
+        <p:spPr>
+          <a:xfrm>
+            <a:off x="978408" y="1700784"/>
+            <a:ext cx="3931920" cy="640080"/>
+          </a:xfrm>
+          <a:prstGeom prst="rect">
+            <a:avLst/>
+          </a:prstGeom>
+          <a:noFill/>
+          <a:ln/>
+        </p:spPr>
+        <p:txBody>
+          <a:bodyPr wrap="square" rtlCol="0" anchor="t">
+            <a:normAutofit/>
+          </a:bodyPr>
+          <a:lstStyle/>
+          <a:p>
+            <a:pPr marL="0" indent="0" algn="l">
+              <a:lnSpc>
+                <a:spcPct val="92000"/>
+              </a:lnSpc>
+              <a:buNone/>
+            </a:pPr>
+            <a:r>
+              <a:rPr lang="en-US" sz="1000" b="0" kern="0" dirty="0">
+                <a:solidFill>
+                  <a:srgbClr val="333333"/>
+                </a:solidFill>
+                <a:latin typeface="Calibri" pitchFamily="34" charset="0"/>
+                <a:ea typeface="Calibri" pitchFamily="34" charset="-122"/>
+                <a:cs typeface="Calibri" pitchFamily="34" charset="-120"/>
+              </a:rPr>
+              <a:t>The same list Bank-wide needs. One answer settles both pages — this is the single highest-value thing you can give us.</a:t>
+            </a:r>
+          </a:p>
+        </p:txBody>
+      </p:sp>
+      <p:sp>
+        <p:nvSpPr>
+          <p:cNvPr id="1051" name="Text"/>
+          <p:cNvSpPr/>
+          <p:nvPr/>
+        </p:nvSpPr>
+        <p:spPr>
+          <a:xfrm>
+            <a:off x="5120640" y="1426464"/>
+            <a:ext cx="3291840" cy="201168"/>
+          </a:xfrm>
+          <a:prstGeom prst="rect">
+            <a:avLst/>
+          </a:prstGeom>
+          <a:noFill/>
+          <a:ln/>
+        </p:spPr>
+        <p:txBody>
+          <a:bodyPr wrap="square" rtlCol="0" anchor="ctr">
+            <a:normAutofit/>
+          </a:bodyPr>
+          <a:lstStyle/>
+          <a:p>
+            <a:pPr marL="0" indent="0" algn="l">
+              <a:buNone/>
+            </a:pPr>
+            <a:r>
+              <a:rPr lang="en-US" sz="950" b="1" kern="0" spc="105" dirty="0">
+                <a:solidFill>
+                  <a:srgbClr val="009B8A"/>
+                </a:solidFill>
+                <a:latin typeface="Calibri" pitchFamily="34" charset="0"/>
+                <a:ea typeface="Calibri" pitchFamily="34" charset="-122"/>
+                <a:cs typeface="Calibri" pitchFamily="34" charset="-120"/>
+              </a:rPr>
+              <a:t>WHERE IT IS USED</a:t>
+            </a:r>
+          </a:p>
+        </p:txBody>
+      </p:sp>
+      <p:sp>
+        <p:nvSpPr>
+          <p:cNvPr id="1052" name="Bullet"/>
+          <p:cNvSpPr/>
+          <p:nvPr/>
+        </p:nvSpPr>
+        <p:spPr>
+          <a:xfrm>
+            <a:off x="5120640" y="1746504"/>
+            <a:ext cx="50292" cy="50292"/>
+          </a:xfrm>
+          <a:prstGeom prst="rect">
+            <a:avLst/>
+          </a:prstGeom>
+          <a:solidFill>
+            <a:srgbClr val="009B8A"/>
+          </a:solidFill>
+          <a:ln/>
+        </p:spPr>
+        <p:txBody>
+          <a:bodyPr/>
+          <a:lstStyle/>
+          <a:p>
+            <a:endParaRPr lang="en-PH" sz="1000"/>
+          </a:p>
+        </p:txBody>
+      </p:sp>
+      <p:sp>
+        <p:nvSpPr>
+          <p:cNvPr id="1053" name="Text"/>
+          <p:cNvSpPr/>
+          <p:nvPr/>
+        </p:nvSpPr>
+        <p:spPr>
+          <a:xfrm>
+            <a:off x="5266944" y="1682496"/>
+            <a:ext cx="3099815" cy="201168"/>
+          </a:xfrm>
+          <a:prstGeom prst="rect">
+            <a:avLst/>
+          </a:prstGeom>
+          <a:noFill/>
+          <a:ln/>
+        </p:spPr>
+        <p:txBody>
+          <a:bodyPr wrap="square" rtlCol="0" anchor="ctr">
+            <a:normAutofit/>
+          </a:bodyPr>
+          <a:lstStyle/>
+          <a:p>
+            <a:pPr marL="0" indent="0" algn="l">
+              <a:buNone/>
+            </a:pPr>
+            <a:r>
+              <a:rPr lang="en-US" sz="920" b="0" kern="0" dirty="0">
+                <a:solidFill>
+                  <a:srgbClr val="333333"/>
+                </a:solidFill>
+                <a:latin typeface="Calibri" pitchFamily="34" charset="0"/>
+                <a:ea typeface="Calibri" pitchFamily="34" charset="-122"/>
+                <a:cs typeface="Calibri" pitchFamily="34" charset="-120"/>
+              </a:rPr>
+              <a:t>Records declared per division</a:t>
+            </a:r>
+          </a:p>
+        </p:txBody>
+      </p:sp>
+      <p:sp>
+        <p:nvSpPr>
+          <p:cNvPr id="1054" name="Bullet"/>
+          <p:cNvSpPr/>
+          <p:nvPr/>
+        </p:nvSpPr>
+        <p:spPr>
+          <a:xfrm>
+            <a:off x="5120640" y="1943100"/>
+            <a:ext cx="50292" cy="50292"/>
+          </a:xfrm>
+          <a:prstGeom prst="rect">
+            <a:avLst/>
+          </a:prstGeom>
+          <a:solidFill>
+            <a:srgbClr val="009B8A"/>
+          </a:solidFill>
+          <a:ln/>
+        </p:spPr>
+        <p:txBody>
+          <a:bodyPr/>
+          <a:lstStyle/>
+          <a:p>
+            <a:endParaRPr lang="en-PH" sz="1000"/>
+          </a:p>
+        </p:txBody>
+      </p:sp>
+      <p:sp>
+        <p:nvSpPr>
+          <p:cNvPr id="1055" name="Text"/>
+          <p:cNvSpPr/>
+          <p:nvPr/>
+        </p:nvSpPr>
+        <p:spPr>
+          <a:xfrm>
+            <a:off x="5266944" y="1879092"/>
+            <a:ext cx="3099815" cy="201168"/>
+          </a:xfrm>
+          <a:prstGeom prst="rect">
+            <a:avLst/>
+          </a:prstGeom>
+          <a:noFill/>
+          <a:ln/>
+        </p:spPr>
+        <p:txBody>
+          <a:bodyPr wrap="square" rtlCol="0" anchor="ctr">
+            <a:normAutofit/>
+          </a:bodyPr>
+          <a:lstStyle/>
+          <a:p>
+            <a:pPr marL="0" indent="0" algn="l">
+              <a:buNone/>
+            </a:pPr>
+            <a:r>
+              <a:rPr lang="en-US" sz="920" b="0" kern="0" dirty="0">
+                <a:solidFill>
+                  <a:srgbClr val="333333"/>
+                </a:solidFill>
+                <a:latin typeface="Calibri" pitchFamily="34" charset="0"/>
+                <a:ea typeface="Calibri" pitchFamily="34" charset="-122"/>
+                <a:cs typeface="Calibri" pitchFamily="34" charset="-120"/>
+              </a:rPr>
+              <a:t>Users declaring records per division</a:t>
+            </a:r>
+          </a:p>
+        </p:txBody>
+      </p:sp>
+      <p:sp>
+        <p:nvSpPr>
+          <p:cNvPr id="1056" name="Bullet"/>
+          <p:cNvSpPr/>
+          <p:nvPr/>
+        </p:nvSpPr>
+        <p:spPr>
+          <a:xfrm>
+            <a:off x="5120640" y="2139696"/>
+            <a:ext cx="50292" cy="50292"/>
+          </a:xfrm>
+          <a:prstGeom prst="rect">
+            <a:avLst/>
+          </a:prstGeom>
+          <a:solidFill>
+            <a:srgbClr val="009B8A"/>
+          </a:solidFill>
+          <a:ln/>
+        </p:spPr>
+        <p:txBody>
+          <a:bodyPr/>
+          <a:lstStyle/>
+          <a:p>
+            <a:endParaRPr lang="en-PH" sz="1000"/>
+          </a:p>
+        </p:txBody>
+      </p:sp>
+      <p:sp>
+        <p:nvSpPr>
+          <p:cNvPr id="1057" name="Text"/>
+          <p:cNvSpPr/>
+          <p:nvPr/>
+        </p:nvSpPr>
+        <p:spPr>
+          <a:xfrm>
+            <a:off x="5266944" y="2075688"/>
+            <a:ext cx="3099815" cy="201168"/>
+          </a:xfrm>
+          <a:prstGeom prst="rect">
+            <a:avLst/>
+          </a:prstGeom>
+          <a:noFill/>
+          <a:ln/>
+        </p:spPr>
+        <p:txBody>
+          <a:bodyPr wrap="square" rtlCol="0" anchor="ctr">
+            <a:normAutofit/>
+          </a:bodyPr>
+          <a:lstStyle/>
+          <a:p>
+            <a:pPr marL="0" indent="0" algn="l">
+              <a:buNone/>
+            </a:pPr>
+            <a:r>
+              <a:rPr lang="en-US" sz="920" b="0" kern="0" dirty="0">
+                <a:solidFill>
+                  <a:srgbClr val="333333"/>
+                </a:solidFill>
+                <a:latin typeface="Calibri" pitchFamily="34" charset="0"/>
+                <a:ea typeface="Calibri" pitchFamily="34" charset="-122"/>
+                <a:cs typeface="Calibri" pitchFamily="34" charset="-120"/>
+              </a:rPr>
+              <a:t>Physical counterparts per division</a:t>
+            </a:r>
+          </a:p>
+        </p:txBody>
+      </p:sp>
+      <p:sp>
+        <p:nvSpPr>
+          <p:cNvPr id="1058" name="Bullet"/>
+          <p:cNvSpPr/>
+          <p:nvPr/>
+        </p:nvSpPr>
+        <p:spPr>
+          <a:xfrm>
+            <a:off x="5120640" y="2336291"/>
+            <a:ext cx="50292" cy="50292"/>
+          </a:xfrm>
+          <a:prstGeom prst="rect">
+            <a:avLst/>
+          </a:prstGeom>
+          <a:solidFill>
+            <a:srgbClr val="009B8A"/>
+          </a:solidFill>
+          <a:ln/>
+        </p:spPr>
+        <p:txBody>
+          <a:bodyPr/>
+          <a:lstStyle/>
+          <a:p>
+            <a:endParaRPr lang="en-PH" sz="1000"/>
+          </a:p>
+        </p:txBody>
+      </p:sp>
+      <p:sp>
+        <p:nvSpPr>
+          <p:cNvPr id="1059" name="Text"/>
+          <p:cNvSpPr/>
+          <p:nvPr/>
+        </p:nvSpPr>
+        <p:spPr>
+          <a:xfrm>
+            <a:off x="5266944" y="2272284"/>
+            <a:ext cx="3099815" cy="201168"/>
+          </a:xfrm>
+          <a:prstGeom prst="rect">
+            <a:avLst/>
+          </a:prstGeom>
+          <a:noFill/>
+          <a:ln/>
+        </p:spPr>
+        <p:txBody>
+          <a:bodyPr wrap="square" rtlCol="0" anchor="ctr">
+            <a:normAutofit/>
+          </a:bodyPr>
+          <a:lstStyle/>
+          <a:p>
+            <a:pPr marL="0" indent="0" algn="l">
+              <a:buNone/>
+            </a:pPr>
+            <a:r>
+              <a:rPr lang="en-US" sz="920" b="0" kern="0" dirty="0">
+                <a:solidFill>
+                  <a:srgbClr val="333333"/>
+                </a:solidFill>
+                <a:latin typeface="Calibri" pitchFamily="34" charset="0"/>
+                <a:ea typeface="Calibri" pitchFamily="34" charset="-122"/>
+                <a:cs typeface="Calibri" pitchFamily="34" charset="-120"/>
+              </a:rPr>
+              <a:t>Per-library indicators by division</a:t>
+            </a:r>
+          </a:p>
+        </p:txBody>
+      </p:sp>
+      <p:sp>
+        <p:nvSpPr>
+          <p:cNvPr id="1060" name="Dot"/>
+          <p:cNvSpPr/>
+          <p:nvPr/>
+        </p:nvSpPr>
+        <p:spPr>
+          <a:xfrm>
+            <a:off x="411480" y="2743200"/>
+            <a:ext cx="256032" cy="256032"/>
+          </a:xfrm>
+          <a:prstGeom prst="ellipse">
+            <a:avLst/>
+          </a:prstGeom>
+          <a:solidFill>
+            <a:srgbClr val="009B8A"/>
+          </a:solidFill>
+          <a:ln/>
+        </p:spPr>
+        <p:txBody>
+          <a:bodyPr/>
+          <a:lstStyle/>
+          <a:p>
+            <a:endParaRPr lang="en-PH" sz="1000"/>
+          </a:p>
+        </p:txBody>
+      </p:sp>
+      <p:sp>
+        <p:nvSpPr>
+          <p:cNvPr id="1061" name="Text"/>
+          <p:cNvSpPr/>
+          <p:nvPr/>
+        </p:nvSpPr>
+        <p:spPr>
+          <a:xfrm>
+            <a:off x="411480" y="2761488"/>
+            <a:ext cx="256032" cy="219456"/>
+          </a:xfrm>
+          <a:prstGeom prst="rect">
+            <a:avLst/>
+          </a:prstGeom>
+          <a:noFill/>
+          <a:ln/>
+        </p:spPr>
+        <p:txBody>
+          <a:bodyPr wrap="square" rtlCol="0" anchor="ctr">
+            <a:normAutofit/>
+          </a:bodyPr>
+          <a:lstStyle/>
+          <a:p>
+            <a:pPr marL="0" indent="0" algn="ctr">
+              <a:buNone/>
+            </a:pPr>
+            <a:r>
+              <a:rPr lang="en-US" sz="1100" b="1" kern="0" dirty="0">
+                <a:solidFill>
+                  <a:srgbClr val="FFFFFF"/>
+                </a:solidFill>
+                <a:latin typeface="Calibri" pitchFamily="34" charset="0"/>
+                <a:ea typeface="Calibri" pitchFamily="34" charset="-122"/>
+                <a:cs typeface="Calibri" pitchFamily="34" charset="-120"/>
+              </a:rPr>
+              <a:t>2</a:t>
+            </a:r>
+          </a:p>
+        </p:txBody>
+      </p:sp>
+      <p:sp>
+        <p:nvSpPr>
+          <p:cNvPr id="1062" name="Text"/>
+          <p:cNvSpPr/>
+          <p:nvPr/>
+        </p:nvSpPr>
+        <p:spPr>
+          <a:xfrm>
+            <a:off x="758952" y="2734056"/>
+            <a:ext cx="2231136" cy="237744"/>
+          </a:xfrm>
+          <a:prstGeom prst="rect">
+            <a:avLst/>
+          </a:prstGeom>
+          <a:noFill/>
+          <a:ln/>
+        </p:spPr>
+        <p:txBody>
+          <a:bodyPr wrap="square" rtlCol="0" anchor="ctr">
+            <a:normAutofit/>
+          </a:bodyPr>
+          <a:lstStyle/>
+          <a:p>
+            <a:pPr marL="0" indent="0" algn="l">
+              <a:buNone/>
+            </a:pPr>
+            <a:r>
+              <a:rPr lang="en-US" sz="1200" b="1" kern="0" dirty="0">
+                <a:solidFill>
+                  <a:srgbClr val="003D5B"/>
+                </a:solidFill>
+                <a:latin typeface="Calibri" pitchFamily="34" charset="0"/>
+                <a:ea typeface="Calibri" pitchFamily="34" charset="-122"/>
+                <a:cs typeface="Calibri" pitchFamily="34" charset="-120"/>
+              </a:rPr>
+              <a:t>Internal and external visitors</a:t>
+            </a:r>
+          </a:p>
+        </p:txBody>
+      </p:sp>
+      <p:sp>
+        <p:nvSpPr>
+          <p:cNvPr id="1063" name="Text"/>
+          <p:cNvSpPr/>
+          <p:nvPr/>
+        </p:nvSpPr>
+        <p:spPr>
+          <a:xfrm>
+            <a:off x="758952" y="2990088"/>
+            <a:ext cx="2212848" cy="960120"/>
+          </a:xfrm>
+          <a:prstGeom prst="rect">
+            <a:avLst/>
+          </a:prstGeom>
+          <a:noFill/>
+          <a:ln/>
+        </p:spPr>
+        <p:txBody>
+          <a:bodyPr wrap="square" rtlCol="0" anchor="t">
+            <a:normAutofit/>
+          </a:bodyPr>
+          <a:lstStyle/>
+          <a:p>
+            <a:pPr marL="0" indent="0" algn="l">
+              <a:lnSpc>
+                <a:spcPct val="92000"/>
+              </a:lnSpc>
+              <a:buNone/>
+            </a:pPr>
+            <a:r>
+              <a:rPr lang="en-US" sz="1000" b="0" kern="0" dirty="0">
+                <a:solidFill>
+                  <a:srgbClr val="333333"/>
+                </a:solidFill>
+                <a:latin typeface="Calibri" pitchFamily="34" charset="0"/>
+                <a:ea typeface="Calibri" pitchFamily="34" charset="-122"/>
+                <a:cs typeface="Calibri" pitchFamily="34" charset="-120"/>
+              </a:rPr>
+              <a:t>Which report separates site visitors into internal and external. We can currently report visits, but not who made them.</a:t>
+            </a:r>
+          </a:p>
+        </p:txBody>
+      </p:sp>
+      <p:sp>
+        <p:nvSpPr>
+          <p:cNvPr id="1064" name="Dot"/>
+          <p:cNvSpPr/>
+          <p:nvPr/>
+        </p:nvSpPr>
+        <p:spPr>
+          <a:xfrm>
+            <a:off x="3282696" y="2743200"/>
+            <a:ext cx="256032" cy="256032"/>
+          </a:xfrm>
+          <a:prstGeom prst="ellipse">
+            <a:avLst/>
+          </a:prstGeom>
+          <a:solidFill>
+            <a:srgbClr val="009B8A"/>
+          </a:solidFill>
+          <a:ln/>
+        </p:spPr>
+        <p:txBody>
+          <a:bodyPr/>
+          <a:lstStyle/>
+          <a:p>
+            <a:endParaRPr lang="en-PH" sz="1000"/>
+          </a:p>
+        </p:txBody>
+      </p:sp>
+      <p:sp>
+        <p:nvSpPr>
+          <p:cNvPr id="1065" name="Text"/>
+          <p:cNvSpPr/>
+          <p:nvPr/>
+        </p:nvSpPr>
+        <p:spPr>
+          <a:xfrm>
+            <a:off x="3282696" y="2761488"/>
+            <a:ext cx="256032" cy="219456"/>
+          </a:xfrm>
+          <a:prstGeom prst="rect">
+            <a:avLst/>
+          </a:prstGeom>
+          <a:noFill/>
+          <a:ln/>
+        </p:spPr>
+        <p:txBody>
+          <a:bodyPr wrap="square" rtlCol="0" anchor="ctr">
+            <a:normAutofit/>
+          </a:bodyPr>
+          <a:lstStyle/>
+          <a:p>
+            <a:pPr marL="0" indent="0" algn="ctr">
+              <a:buNone/>
+            </a:pPr>
+            <a:r>
+              <a:rPr lang="en-US" sz="1100" b="1" kern="0" dirty="0">
+                <a:solidFill>
+                  <a:srgbClr val="FFFFFF"/>
+                </a:solidFill>
+                <a:latin typeface="Calibri" pitchFamily="34" charset="0"/>
+                <a:ea typeface="Calibri" pitchFamily="34" charset="-122"/>
+                <a:cs typeface="Calibri" pitchFamily="34" charset="-120"/>
+              </a:rPr>
+              <a:t>3</a:t>
+            </a:r>
+          </a:p>
+        </p:txBody>
+      </p:sp>
+      <p:sp>
+        <p:nvSpPr>
+          <p:cNvPr id="1066" name="Text"/>
+          <p:cNvSpPr/>
+          <p:nvPr/>
+        </p:nvSpPr>
+        <p:spPr>
+          <a:xfrm>
+            <a:off x="3630168" y="2734056"/>
+            <a:ext cx="2231136" cy="237744"/>
+          </a:xfrm>
+          <a:prstGeom prst="rect">
+            <a:avLst/>
+          </a:prstGeom>
+          <a:noFill/>
+          <a:ln/>
+        </p:spPr>
+        <p:txBody>
+          <a:bodyPr wrap="square" rtlCol="0" anchor="ctr">
+            <a:normAutofit/>
+          </a:bodyPr>
+          <a:lstStyle/>
+          <a:p>
+            <a:pPr marL="0" indent="0" algn="l">
+              <a:buNone/>
+            </a:pPr>
+            <a:r>
+              <a:rPr lang="en-US" sz="1200" b="1" kern="0" dirty="0">
+                <a:solidFill>
+                  <a:srgbClr val="003D5B"/>
+                </a:solidFill>
+                <a:latin typeface="Calibri" pitchFamily="34" charset="0"/>
+                <a:ea typeface="Calibri" pitchFamily="34" charset="-122"/>
+                <a:cs typeface="Calibri" pitchFamily="34" charset="-120"/>
+              </a:rPr>
+              <a:t>Site naming convention</a:t>
+            </a:r>
+          </a:p>
+        </p:txBody>
+      </p:sp>
+      <p:sp>
+        <p:nvSpPr>
+          <p:cNvPr id="1067" name="Text"/>
+          <p:cNvSpPr/>
+          <p:nvPr/>
+        </p:nvSpPr>
+        <p:spPr>
+          <a:xfrm>
+            <a:off x="3630168" y="2990088"/>
+            <a:ext cx="2212848" cy="960120"/>
+          </a:xfrm>
+          <a:prstGeom prst="rect">
+            <a:avLst/>
+          </a:prstGeom>
+          <a:noFill/>
+          <a:ln/>
+        </p:spPr>
+        <p:txBody>
+          <a:bodyPr wrap="square" rtlCol="0" anchor="t">
+            <a:normAutofit/>
+          </a:bodyPr>
+          <a:lstStyle/>
+          <a:p>
+            <a:pPr marL="0" indent="0" algn="l">
+              <a:lnSpc>
+                <a:spcPct val="92000"/>
+              </a:lnSpc>
+              <a:buNone/>
+            </a:pPr>
+            <a:r>
+              <a:rPr lang="en-US" sz="1000" b="0" kern="0" dirty="0">
+                <a:solidFill>
+                  <a:srgbClr val="333333"/>
+                </a:solidFill>
+                <a:latin typeface="Calibri" pitchFamily="34" charset="0"/>
+                <a:ea typeface="Calibri" pitchFamily="34" charset="-122"/>
+                <a:cs typeface="Calibri" pitchFamily="34" charset="-120"/>
+              </a:rPr>
+              <a:t>Is there an approved site, library and folder convention we can measure compliance against?</a:t>
+            </a:r>
+          </a:p>
+        </p:txBody>
+      </p:sp>
+      <p:sp>
+        <p:nvSpPr>
+          <p:cNvPr id="1068" name="Dot"/>
+          <p:cNvSpPr/>
+          <p:nvPr/>
+        </p:nvSpPr>
+        <p:spPr>
+          <a:xfrm>
+            <a:off x="6153912" y="2743200"/>
+            <a:ext cx="256032" cy="256032"/>
+          </a:xfrm>
+          <a:prstGeom prst="ellipse">
+            <a:avLst/>
+          </a:prstGeom>
+          <a:solidFill>
+            <a:srgbClr val="009B8A"/>
+          </a:solidFill>
+          <a:ln/>
+        </p:spPr>
+        <p:txBody>
+          <a:bodyPr/>
+          <a:lstStyle/>
+          <a:p>
+            <a:endParaRPr lang="en-PH" sz="1000"/>
+          </a:p>
+        </p:txBody>
+      </p:sp>
+      <p:sp>
+        <p:nvSpPr>
+          <p:cNvPr id="1069" name="Text"/>
+          <p:cNvSpPr/>
+          <p:nvPr/>
+        </p:nvSpPr>
+        <p:spPr>
+          <a:xfrm>
+            <a:off x="6153912" y="2761488"/>
+            <a:ext cx="256032" cy="219456"/>
+          </a:xfrm>
+          <a:prstGeom prst="rect">
+            <a:avLst/>
+          </a:prstGeom>
+          <a:noFill/>
+          <a:ln/>
+        </p:spPr>
+        <p:txBody>
+          <a:bodyPr wrap="square" rtlCol="0" anchor="ctr">
+            <a:normAutofit/>
+          </a:bodyPr>
+          <a:lstStyle/>
+          <a:p>
+            <a:pPr marL="0" indent="0" algn="ctr">
+              <a:buNone/>
+            </a:pPr>
+            <a:r>
+              <a:rPr lang="en-US" sz="1100" b="1" kern="0" dirty="0">
+                <a:solidFill>
+                  <a:srgbClr val="FFFFFF"/>
+                </a:solidFill>
+                <a:latin typeface="Calibri" pitchFamily="34" charset="0"/>
+                <a:ea typeface="Calibri" pitchFamily="34" charset="-122"/>
+                <a:cs typeface="Calibri" pitchFamily="34" charset="-120"/>
+              </a:rPr>
+              <a:t>4</a:t>
+            </a:r>
+          </a:p>
+        </p:txBody>
+      </p:sp>
+      <p:sp>
+        <p:nvSpPr>
+          <p:cNvPr id="1070" name="Text"/>
+          <p:cNvSpPr/>
+          <p:nvPr/>
+        </p:nvSpPr>
+        <p:spPr>
+          <a:xfrm>
+            <a:off x="6501383" y="2734056"/>
+            <a:ext cx="2231136" cy="237744"/>
+          </a:xfrm>
+          <a:prstGeom prst="rect">
+            <a:avLst/>
+          </a:prstGeom>
+          <a:noFill/>
+          <a:ln/>
+        </p:spPr>
+        <p:txBody>
+          <a:bodyPr wrap="square" rtlCol="0" anchor="ctr">
+            <a:normAutofit/>
+          </a:bodyPr>
+          <a:lstStyle/>
+          <a:p>
+            <a:pPr marL="0" indent="0" algn="l">
+              <a:buNone/>
+            </a:pPr>
+            <a:r>
+              <a:rPr lang="en-US" sz="1200" b="1" kern="0" dirty="0">
+                <a:solidFill>
+                  <a:srgbClr val="003D5B"/>
+                </a:solidFill>
+                <a:latin typeface="Calibri" pitchFamily="34" charset="0"/>
+                <a:ea typeface="Calibri" pitchFamily="34" charset="-122"/>
+                <a:cs typeface="Calibri" pitchFamily="34" charset="-120"/>
+              </a:rPr>
+              <a:t>Access requests</a:t>
+            </a:r>
+          </a:p>
+        </p:txBody>
+      </p:sp>
+      <p:sp>
+        <p:nvSpPr>
+          <p:cNvPr id="1071" name="Text"/>
+          <p:cNvSpPr/>
+          <p:nvPr/>
+        </p:nvSpPr>
+        <p:spPr>
+          <a:xfrm>
+            <a:off x="6501383" y="2990088"/>
+            <a:ext cx="2212848" cy="960120"/>
+          </a:xfrm>
+          <a:prstGeom prst="rect">
+            <a:avLst/>
+          </a:prstGeom>
+          <a:noFill/>
+          <a:ln/>
+        </p:spPr>
+        <p:txBody>
+          <a:bodyPr wrap="square" rtlCol="0" anchor="t">
+            <a:normAutofit/>
+          </a:bodyPr>
+          <a:lstStyle/>
+          <a:p>
+            <a:pPr marL="0" indent="0" algn="l">
+              <a:lnSpc>
+                <a:spcPct val="92000"/>
+              </a:lnSpc>
+              <a:buNone/>
+            </a:pPr>
+            <a:r>
+              <a:rPr lang="en-US" sz="1000" b="0" kern="0" dirty="0">
+                <a:solidFill>
+                  <a:srgbClr val="333333"/>
+                </a:solidFill>
+                <a:latin typeface="Calibri" pitchFamily="34" charset="0"/>
+                <a:ea typeface="Calibri" pitchFamily="34" charset="-122"/>
+                <a:cs typeface="Calibri" pitchFamily="34" charset="-120"/>
+              </a:rPr>
+              <a:t>Are access requests granted and denied logged anywhere we can reach?</a:t>
+            </a:r>
           </a:p>
         </p:txBody>
       </p:sp>
     </p:spTree>
-    <p:extLst>
-      <p:ext uri="{BB962C8B-B14F-4D97-AF65-F5344CB8AC3E}">
-        <p14:creationId xmlns:p14="http://schemas.microsoft.com/office/powerpoint/2010/main" val="2339412854"/>
-      </p:ext>
-    </p:extLst>
   </p:cSld>
   <p:clrMapOvr>
     <a:masterClrMapping/>

</xml_diff>

<commit_message>
Change 3: Project Insights and Institutional File Plan (slides 8-11)
Project Insights is framed as built but unsourced: every field and tile
exists in the prototype, and the whole of the ask is naming a system to read
project attributes from. Its four questions run system of record, read
access, the site-to-project register, and whether deriving the link by
scanning site names would be acceptable if no register exists.

Institutional File Plan is framed as complete, so its page asks for
confirmation rather than new information: whether the hierarchy matches the
approved plan, how retired terms should behave, who supplies updates, and an
explicit invitation to flag anything absent.

Both question slides use the two-by-two layout, since neither depends on the
Division list.

Co-Authored-By: Claude Haiku 4.5 <noreply@anthropic.com>
Claude-Session: https://claude.ai/code/session_011o1oYM1TYcdL65Q8iw3Pih
</commit_message>
<xml_diff>
--- a/EDRMS_Utilization_Confirmation_Workshop.pptx
+++ b/EDRMS_Utilization_Confirmation_Workshop.pptx
@@ -3359,16 +3359,18 @@
 
 <file path=ppt/slides/slide10.xml><?xml version="1.0" encoding="utf-8"?>
 <p:sld xmlns:a="http://schemas.openxmlformats.org/drawingml/2006/main" xmlns:r="http://schemas.openxmlformats.org/officeDocument/2006/relationships" xmlns:p="http://schemas.openxmlformats.org/presentationml/2006/main">
-  <p:cSld>
+  <p:cSld name="Institutional File Plan">
+    <p:bg>
+      <p:bgPr>
+        <a:solidFill>
+          <a:srgbClr val="FFFFFF"/>
+        </a:solidFill>
+        <a:effectLst/>
+      </p:bgPr>
+    </p:bg>
     <p:spTree>
       <p:nvGrpSpPr>
-        <p:cNvPr id="1" name="">
-          <a:extLst>
-            <a:ext uri="{FF2B5EF4-FFF2-40B4-BE49-F238E27FC236}">
-              <a16:creationId xmlns:a16="http://schemas.microsoft.com/office/drawing/2014/main" id="{3B0FFCE7-BFC6-413A-C5DB-1DD8A1A5546C}"/>
-            </a:ext>
-          </a:extLst>
-        </p:cNvPr>
+        <p:cNvPr id="1" name=""/>
         <p:cNvGrpSpPr/>
         <p:nvPr/>
       </p:nvGrpSpPr>
@@ -3382,19 +3384,13 @@
       </p:grpSpPr>
       <p:sp>
         <p:nvSpPr>
-          <p:cNvPr id="4" name="Text 2">
-            <a:extLst>
-              <a:ext uri="{FF2B5EF4-FFF2-40B4-BE49-F238E27FC236}">
-                <a16:creationId xmlns:a16="http://schemas.microsoft.com/office/drawing/2014/main" id="{F5DDBC9D-AF41-1901-6219-16D3B623F23D}"/>
-              </a:ext>
-            </a:extLst>
-          </p:cNvPr>
-          <p:cNvSpPr/>
-          <p:nvPr/>
-        </p:nvSpPr>
-        <p:spPr>
-          <a:xfrm>
-            <a:off x="198186" y="93986"/>
+          <p:cNvPr id="1061" name="Title"/>
+          <p:cNvSpPr/>
+          <p:nvPr/>
+        </p:nvSpPr>
+        <p:spPr>
+          <a:xfrm>
+            <a:off x="201168" y="91440"/>
             <a:ext cx="8412480" cy="493776"/>
           </a:xfrm>
           <a:prstGeom prst="rect">
@@ -3404,44 +3400,1275 @@
           <a:ln/>
         </p:spPr>
         <p:txBody>
-          <a:bodyPr wrap="square" lIns="0" tIns="0" rIns="0" bIns="0" rtlCol="0" anchor="ctr"/>
-          <a:lstStyle/>
-          <a:p>
-            <a:pPr marL="0" indent="0">
-              <a:buNone/>
-            </a:pPr>
-            <a:r>
-              <a:rPr lang="en-US" sz="2700" b="1" dirty="0">
-                <a:solidFill>
-                  <a:schemeClr val="tx2">
-                    <a:lumMod val="76000"/>
-                  </a:schemeClr>
-                </a:solidFill>
-                <a:latin typeface="Cambria"/>
-                <a:ea typeface="Cambria"/>
-                <a:cs typeface="Cambria" pitchFamily="34" charset="-120"/>
+          <a:bodyPr wrap="square" rtlCol="0" anchor="ctr">
+            <a:normAutofit/>
+          </a:bodyPr>
+          <a:lstStyle/>
+          <a:p>
+            <a:pPr marL="0" indent="0" algn="l">
+              <a:buNone/>
+            </a:pPr>
+            <a:r>
+              <a:rPr lang="en-US" sz="2700" b="1" kern="0" dirty="0">
+                <a:solidFill>
+                  <a:srgbClr val="003D5B"/>
+                </a:solidFill>
+                <a:latin typeface="Calibri" pitchFamily="34" charset="0"/>
+                <a:ea typeface="Calibri" pitchFamily="34" charset="-122"/>
+                <a:cs typeface="Calibri" pitchFamily="34" charset="-120"/>
               </a:rPr>
               <a:t>Institutional File Plan</a:t>
             </a:r>
-            <a:endParaRPr lang="en-US" sz="2700" dirty="0">
-              <a:solidFill>
-                <a:schemeClr val="tx2">
-                  <a:lumMod val="76000"/>
-                </a:schemeClr>
-              </a:solidFill>
-              <a:latin typeface="Cambria"/>
-              <a:ea typeface="Cambria"/>
-              <a:cs typeface="Calibri"/>
-            </a:endParaRPr>
+          </a:p>
+        </p:txBody>
+      </p:sp>
+      <p:sp>
+        <p:nvSpPr>
+          <p:cNvPr id="1062" name="Subtitle"/>
+          <p:cNvSpPr/>
+          <p:nvPr/>
+        </p:nvSpPr>
+        <p:spPr>
+          <a:xfrm>
+            <a:off x="192024" y="640080"/>
+            <a:ext cx="8412480" cy="310896"/>
+          </a:xfrm>
+          <a:prstGeom prst="rect">
+            <a:avLst/>
+          </a:prstGeom>
+          <a:noFill/>
+          <a:ln/>
+        </p:spPr>
+        <p:txBody>
+          <a:bodyPr wrap="square" rtlCol="0" anchor="ctr">
+            <a:normAutofit/>
+          </a:bodyPr>
+          <a:lstStyle/>
+          <a:p>
+            <a:pPr marL="0" indent="0" algn="l">
+              <a:buNone/>
+            </a:pPr>
+            <a:r>
+              <a:rPr lang="en-US" sz="1400" b="0" kern="0" dirty="0">
+                <a:solidFill>
+                  <a:srgbClr val="009B8A"/>
+                </a:solidFill>
+                <a:latin typeface="Calibri" pitchFamily="34" charset="0"/>
+                <a:ea typeface="Calibri" pitchFamily="34" charset="-122"/>
+                <a:cs typeface="Calibri" pitchFamily="34" charset="-120"/>
+              </a:rPr>
+              <a:t>The retention class hierarchy, and how records sit against it.</a:t>
+            </a:r>
+          </a:p>
+        </p:txBody>
+      </p:sp>
+      <p:sp>
+        <p:nvSpPr>
+          <p:cNvPr id="1063" name="Rule"/>
+          <p:cNvSpPr/>
+          <p:nvPr/>
+        </p:nvSpPr>
+        <p:spPr>
+          <a:xfrm>
+            <a:off x="411480" y="1097280"/>
+            <a:ext cx="2578608" cy="36576"/>
+          </a:xfrm>
+          <a:prstGeom prst="rect">
+            <a:avLst/>
+          </a:prstGeom>
+          <a:solidFill>
+            <a:srgbClr val="009B8A"/>
+          </a:solidFill>
+          <a:ln/>
+        </p:spPr>
+        <p:txBody>
+          <a:bodyPr/>
+          <a:lstStyle/>
+          <a:p>
+            <a:endParaRPr lang="en-PH" sz="1000"/>
+          </a:p>
+        </p:txBody>
+      </p:sp>
+      <p:sp>
+        <p:nvSpPr>
+          <p:cNvPr id="1064" name="Text"/>
+          <p:cNvSpPr/>
+          <p:nvPr/>
+        </p:nvSpPr>
+        <p:spPr>
+          <a:xfrm>
+            <a:off x="411480" y="1152144"/>
+            <a:ext cx="2578608" cy="210312"/>
+          </a:xfrm>
+          <a:prstGeom prst="rect">
+            <a:avLst/>
+          </a:prstGeom>
+          <a:noFill/>
+          <a:ln/>
+        </p:spPr>
+        <p:txBody>
+          <a:bodyPr wrap="square" rtlCol="0" anchor="ctr">
+            <a:normAutofit/>
+          </a:bodyPr>
+          <a:lstStyle/>
+          <a:p>
+            <a:pPr marL="0" indent="0" algn="l">
+              <a:buNone/>
+            </a:pPr>
+            <a:r>
+              <a:rPr lang="en-US" sz="1200" b="1" kern="0" dirty="0">
+                <a:solidFill>
+                  <a:srgbClr val="003D5B"/>
+                </a:solidFill>
+                <a:latin typeface="Calibri" pitchFamily="34" charset="0"/>
+                <a:ea typeface="Calibri" pitchFamily="34" charset="-122"/>
+                <a:cs typeface="Calibri" pitchFamily="34" charset="-120"/>
+              </a:rPr>
+              <a:t>The reference page</a:t>
+            </a:r>
+          </a:p>
+        </p:txBody>
+      </p:sp>
+      <p:sp>
+        <p:nvSpPr>
+          <p:cNvPr id="1065" name="Text"/>
+          <p:cNvSpPr/>
+          <p:nvPr/>
+        </p:nvSpPr>
+        <p:spPr>
+          <a:xfrm>
+            <a:off x="411480" y="1435607"/>
+            <a:ext cx="2578608" cy="786384"/>
+          </a:xfrm>
+          <a:prstGeom prst="rect">
+            <a:avLst/>
+          </a:prstGeom>
+          <a:noFill/>
+          <a:ln/>
+        </p:spPr>
+        <p:txBody>
+          <a:bodyPr wrap="square" rtlCol="0" anchor="t">
+            <a:normAutofit/>
+          </a:bodyPr>
+          <a:lstStyle/>
+          <a:p>
+            <a:pPr marL="0" indent="0" algn="l">
+              <a:lnSpc>
+                <a:spcPct val="92000"/>
+              </a:lnSpc>
+              <a:buNone/>
+            </a:pPr>
+            <a:r>
+              <a:rPr lang="en-US" sz="1000" b="0" kern="0" dirty="0">
+                <a:solidFill>
+                  <a:srgbClr val="333333"/>
+                </a:solidFill>
+                <a:latin typeface="Calibri" pitchFamily="34" charset="0"/>
+                <a:ea typeface="Calibri" pitchFamily="34" charset="-122"/>
+                <a:cs typeface="Calibri" pitchFamily="34" charset="-120"/>
+              </a:rPr>
+              <a:t>The agreed structure of the file plan, shown as it exists in the term store rather than as a document.</a:t>
+            </a:r>
+          </a:p>
+        </p:txBody>
+      </p:sp>
+      <p:sp>
+        <p:nvSpPr>
+          <p:cNvPr id="1066" name="Rule"/>
+          <p:cNvSpPr/>
+          <p:nvPr/>
+        </p:nvSpPr>
+        <p:spPr>
+          <a:xfrm>
+            <a:off x="3282696" y="1097280"/>
+            <a:ext cx="2578608" cy="36576"/>
+          </a:xfrm>
+          <a:prstGeom prst="rect">
+            <a:avLst/>
+          </a:prstGeom>
+          <a:solidFill>
+            <a:srgbClr val="009B8A"/>
+          </a:solidFill>
+          <a:ln/>
+        </p:spPr>
+        <p:txBody>
+          <a:bodyPr/>
+          <a:lstStyle/>
+          <a:p>
+            <a:endParaRPr lang="en-PH" sz="1000"/>
+          </a:p>
+        </p:txBody>
+      </p:sp>
+      <p:sp>
+        <p:nvSpPr>
+          <p:cNvPr id="1067" name="Text"/>
+          <p:cNvSpPr/>
+          <p:nvPr/>
+        </p:nvSpPr>
+        <p:spPr>
+          <a:xfrm>
+            <a:off x="3282696" y="1152144"/>
+            <a:ext cx="2578608" cy="210312"/>
+          </a:xfrm>
+          <a:prstGeom prst="rect">
+            <a:avLst/>
+          </a:prstGeom>
+          <a:noFill/>
+          <a:ln/>
+        </p:spPr>
+        <p:txBody>
+          <a:bodyPr wrap="square" rtlCol="0" anchor="ctr">
+            <a:normAutofit/>
+          </a:bodyPr>
+          <a:lstStyle/>
+          <a:p>
+            <a:pPr marL="0" indent="0" algn="l">
+              <a:buNone/>
+            </a:pPr>
+            <a:r>
+              <a:rPr lang="en-US" sz="1200" b="1" kern="0" dirty="0">
+                <a:solidFill>
+                  <a:srgbClr val="003D5B"/>
+                </a:solidFill>
+                <a:latin typeface="Calibri" pitchFamily="34" charset="0"/>
+                <a:ea typeface="Calibri" pitchFamily="34" charset="-122"/>
+                <a:cs typeface="Calibri" pitchFamily="34" charset="-120"/>
+              </a:rPr>
+              <a:t>Coverage at a glance</a:t>
+            </a:r>
+          </a:p>
+        </p:txBody>
+      </p:sp>
+      <p:sp>
+        <p:nvSpPr>
+          <p:cNvPr id="1068" name="Text"/>
+          <p:cNvSpPr/>
+          <p:nvPr/>
+        </p:nvSpPr>
+        <p:spPr>
+          <a:xfrm>
+            <a:off x="3282696" y="1435607"/>
+            <a:ext cx="2578608" cy="786384"/>
+          </a:xfrm>
+          <a:prstGeom prst="rect">
+            <a:avLst/>
+          </a:prstGeom>
+          <a:noFill/>
+          <a:ln/>
+        </p:spPr>
+        <p:txBody>
+          <a:bodyPr wrap="square" rtlCol="0" anchor="t">
+            <a:normAutofit/>
+          </a:bodyPr>
+          <a:lstStyle/>
+          <a:p>
+            <a:pPr marL="0" indent="0" algn="l">
+              <a:lnSpc>
+                <a:spcPct val="92000"/>
+              </a:lnSpc>
+              <a:buNone/>
+            </a:pPr>
+            <a:r>
+              <a:rPr lang="en-US" sz="1000" b="0" kern="0" dirty="0">
+                <a:solidFill>
+                  <a:srgbClr val="333333"/>
+                </a:solidFill>
+                <a:latin typeface="Calibri" pitchFamily="34" charset="0"/>
+                <a:ea typeface="Calibri" pitchFamily="34" charset="-122"/>
+                <a:cs typeface="Calibri" pitchFamily="34" charset="-120"/>
+              </a:rPr>
+              <a:t>How much of what has been declared actually maps onto the plan, and where the plan is not being used.</a:t>
+            </a:r>
+          </a:p>
+        </p:txBody>
+      </p:sp>
+      <p:sp>
+        <p:nvSpPr>
+          <p:cNvPr id="1069" name="Rule"/>
+          <p:cNvSpPr/>
+          <p:nvPr/>
+        </p:nvSpPr>
+        <p:spPr>
+          <a:xfrm>
+            <a:off x="6153912" y="1097280"/>
+            <a:ext cx="2578608" cy="36576"/>
+          </a:xfrm>
+          <a:prstGeom prst="rect">
+            <a:avLst/>
+          </a:prstGeom>
+          <a:solidFill>
+            <a:srgbClr val="009B8A"/>
+          </a:solidFill>
+          <a:ln/>
+        </p:spPr>
+        <p:txBody>
+          <a:bodyPr/>
+          <a:lstStyle/>
+          <a:p>
+            <a:endParaRPr lang="en-PH" sz="1000"/>
+          </a:p>
+        </p:txBody>
+      </p:sp>
+      <p:sp>
+        <p:nvSpPr>
+          <p:cNvPr id="1070" name="Text"/>
+          <p:cNvSpPr/>
+          <p:nvPr/>
+        </p:nvSpPr>
+        <p:spPr>
+          <a:xfrm>
+            <a:off x="6153912" y="1152144"/>
+            <a:ext cx="2578608" cy="210312"/>
+          </a:xfrm>
+          <a:prstGeom prst="rect">
+            <a:avLst/>
+          </a:prstGeom>
+          <a:noFill/>
+          <a:ln/>
+        </p:spPr>
+        <p:txBody>
+          <a:bodyPr wrap="square" rtlCol="0" anchor="ctr">
+            <a:normAutofit/>
+          </a:bodyPr>
+          <a:lstStyle/>
+          <a:p>
+            <a:pPr marL="0" indent="0" algn="l">
+              <a:buNone/>
+            </a:pPr>
+            <a:r>
+              <a:rPr lang="en-US" sz="1200" b="1" kern="0" dirty="0">
+                <a:solidFill>
+                  <a:srgbClr val="003D5B"/>
+                </a:solidFill>
+                <a:latin typeface="Calibri" pitchFamily="34" charset="0"/>
+                <a:ea typeface="Calibri" pitchFamily="34" charset="-122"/>
+                <a:cs typeface="Calibri" pitchFamily="34" charset="-120"/>
+              </a:rPr>
+              <a:t>Complete as drawn</a:t>
+            </a:r>
+          </a:p>
+        </p:txBody>
+      </p:sp>
+      <p:sp>
+        <p:nvSpPr>
+          <p:cNvPr id="1071" name="Text"/>
+          <p:cNvSpPr/>
+          <p:nvPr/>
+        </p:nvSpPr>
+        <p:spPr>
+          <a:xfrm>
+            <a:off x="6153912" y="1435607"/>
+            <a:ext cx="2578608" cy="786384"/>
+          </a:xfrm>
+          <a:prstGeom prst="rect">
+            <a:avLst/>
+          </a:prstGeom>
+          <a:noFill/>
+          <a:ln/>
+        </p:spPr>
+        <p:txBody>
+          <a:bodyPr wrap="square" rtlCol="0" anchor="t">
+            <a:normAutofit/>
+          </a:bodyPr>
+          <a:lstStyle/>
+          <a:p>
+            <a:pPr marL="0" indent="0" algn="l">
+              <a:lnSpc>
+                <a:spcPct val="92000"/>
+              </a:lnSpc>
+              <a:buNone/>
+            </a:pPr>
+            <a:r>
+              <a:rPr lang="en-US" sz="1000" b="0" kern="0" dirty="0">
+                <a:solidFill>
+                  <a:srgbClr val="333333"/>
+                </a:solidFill>
+                <a:latin typeface="Calibri" pitchFamily="34" charset="0"/>
+                <a:ea typeface="Calibri" pitchFamily="34" charset="-122"/>
+                <a:cs typeface="Calibri" pitchFamily="34" charset="-120"/>
+              </a:rPr>
+              <a:t>This page is built end to end. What we need from you here is confirmation rather than new information.</a:t>
+            </a:r>
+          </a:p>
+        </p:txBody>
+      </p:sp>
+      <p:sp>
+        <p:nvSpPr>
+          <p:cNvPr id="1072" name="Text"/>
+          <p:cNvSpPr/>
+          <p:nvPr/>
+        </p:nvSpPr>
+        <p:spPr>
+          <a:xfrm>
+            <a:off x="411480" y="2231136"/>
+            <a:ext cx="4572000" cy="201168"/>
+          </a:xfrm>
+          <a:prstGeom prst="rect">
+            <a:avLst/>
+          </a:prstGeom>
+          <a:noFill/>
+          <a:ln/>
+        </p:spPr>
+        <p:txBody>
+          <a:bodyPr wrap="square" rtlCol="0" anchor="ctr">
+            <a:normAutofit/>
+          </a:bodyPr>
+          <a:lstStyle/>
+          <a:p>
+            <a:pPr marL="0" indent="0" algn="l">
+              <a:buNone/>
+            </a:pPr>
+            <a:r>
+              <a:rPr lang="en-US" sz="1200" b="1" kern="0" spc="105" dirty="0">
+                <a:solidFill>
+                  <a:srgbClr val="003D5B"/>
+                </a:solidFill>
+                <a:latin typeface="Calibri" pitchFamily="34" charset="0"/>
+                <a:ea typeface="Calibri" pitchFamily="34" charset="-122"/>
+                <a:cs typeface="Calibri" pitchFamily="34" charset="-120"/>
+              </a:rPr>
+              <a:t>WHAT YOU WILL SEE ON THE PAGE</a:t>
+            </a:r>
+          </a:p>
+        </p:txBody>
+      </p:sp>
+      <p:sp>
+        <p:nvSpPr>
+          <p:cNvPr id="1073" name="Panel"/>
+          <p:cNvSpPr/>
+          <p:nvPr/>
+        </p:nvSpPr>
+        <p:spPr>
+          <a:xfrm>
+            <a:off x="411480" y="2487168"/>
+            <a:ext cx="8321040" cy="2084831"/>
+          </a:xfrm>
+          <a:prstGeom prst="rect">
+            <a:avLst/>
+          </a:prstGeom>
+          <a:solidFill>
+            <a:srgbClr val="F4F7F8"/>
+          </a:solidFill>
+          <a:ln w="12700">
+            <a:solidFill>
+              <a:srgbClr val="D8DEE1"/>
+            </a:solidFill>
+            <a:prstDash val="solid"/>
+          </a:ln>
+        </p:spPr>
+        <p:txBody>
+          <a:bodyPr/>
+          <a:lstStyle/>
+          <a:p>
+            <a:endParaRPr lang="en-PH" sz="1000"/>
+          </a:p>
+        </p:txBody>
+      </p:sp>
+      <p:sp>
+        <p:nvSpPr>
+          <p:cNvPr id="1074" name="Rule"/>
+          <p:cNvSpPr/>
+          <p:nvPr/>
+        </p:nvSpPr>
+        <p:spPr>
+          <a:xfrm>
+            <a:off x="612648" y="2688336"/>
+            <a:ext cx="1655063" cy="32004"/>
+          </a:xfrm>
+          <a:prstGeom prst="rect">
+            <a:avLst/>
+          </a:prstGeom>
+          <a:solidFill>
+            <a:srgbClr val="009B8A"/>
+          </a:solidFill>
+          <a:ln/>
+        </p:spPr>
+        <p:txBody>
+          <a:bodyPr/>
+          <a:lstStyle/>
+          <a:p>
+            <a:endParaRPr lang="en-PH" sz="1000"/>
+          </a:p>
+        </p:txBody>
+      </p:sp>
+      <p:sp>
+        <p:nvSpPr>
+          <p:cNvPr id="1075" name="Text"/>
+          <p:cNvSpPr/>
+          <p:nvPr/>
+        </p:nvSpPr>
+        <p:spPr>
+          <a:xfrm>
+            <a:off x="612648" y="2761488"/>
+            <a:ext cx="1655063" cy="219456"/>
+          </a:xfrm>
+          <a:prstGeom prst="rect">
+            <a:avLst/>
+          </a:prstGeom>
+          <a:noFill/>
+          <a:ln/>
+        </p:spPr>
+        <p:txBody>
+          <a:bodyPr wrap="square" rtlCol="0" anchor="ctr">
+            <a:normAutofit/>
+          </a:bodyPr>
+          <a:lstStyle/>
+          <a:p>
+            <a:pPr marL="0" indent="0" algn="l">
+              <a:buNone/>
+            </a:pPr>
+            <a:r>
+              <a:rPr lang="en-US" sz="1050" b="1" kern="0" dirty="0">
+                <a:solidFill>
+                  <a:srgbClr val="003D5B"/>
+                </a:solidFill>
+                <a:latin typeface="Calibri" pitchFamily="34" charset="0"/>
+                <a:ea typeface="Calibri" pitchFamily="34" charset="-122"/>
+                <a:cs typeface="Calibri" pitchFamily="34" charset="-120"/>
+              </a:rPr>
+              <a:t>The hierarchy</a:t>
+            </a:r>
+          </a:p>
+        </p:txBody>
+      </p:sp>
+      <p:sp>
+        <p:nvSpPr>
+          <p:cNvPr id="1076" name="Bullet"/>
+          <p:cNvSpPr/>
+          <p:nvPr/>
+        </p:nvSpPr>
+        <p:spPr>
+          <a:xfrm>
+            <a:off x="612648" y="3118103"/>
+            <a:ext cx="50292" cy="50292"/>
+          </a:xfrm>
+          <a:prstGeom prst="rect">
+            <a:avLst/>
+          </a:prstGeom>
+          <a:solidFill>
+            <a:srgbClr val="009B8A"/>
+          </a:solidFill>
+          <a:ln/>
+        </p:spPr>
+        <p:txBody>
+          <a:bodyPr/>
+          <a:lstStyle/>
+          <a:p>
+            <a:endParaRPr lang="en-PH" sz="1000"/>
+          </a:p>
+        </p:txBody>
+      </p:sp>
+      <p:sp>
+        <p:nvSpPr>
+          <p:cNvPr id="1077" name="Text"/>
+          <p:cNvSpPr/>
+          <p:nvPr/>
+        </p:nvSpPr>
+        <p:spPr>
+          <a:xfrm>
+            <a:off x="758952" y="3054096"/>
+            <a:ext cx="1545336" cy="201168"/>
+          </a:xfrm>
+          <a:prstGeom prst="rect">
+            <a:avLst/>
+          </a:prstGeom>
+          <a:noFill/>
+          <a:ln/>
+        </p:spPr>
+        <p:txBody>
+          <a:bodyPr wrap="square" rtlCol="0" anchor="ctr">
+            <a:normAutofit/>
+          </a:bodyPr>
+          <a:lstStyle/>
+          <a:p>
+            <a:pPr marL="0" indent="0" algn="l">
+              <a:buNone/>
+            </a:pPr>
+            <a:r>
+              <a:rPr lang="en-US" sz="900" b="0" kern="0" dirty="0">
+                <a:solidFill>
+                  <a:srgbClr val="333333"/>
+                </a:solidFill>
+                <a:latin typeface="Calibri" pitchFamily="34" charset="0"/>
+                <a:ea typeface="Calibri" pitchFamily="34" charset="-122"/>
+                <a:cs typeface="Calibri" pitchFamily="34" charset="-120"/>
+              </a:rPr>
+              <a:t>Five top-level categories</a:t>
+            </a:r>
+          </a:p>
+        </p:txBody>
+      </p:sp>
+      <p:sp>
+        <p:nvSpPr>
+          <p:cNvPr id="1078" name="Bullet"/>
+          <p:cNvSpPr/>
+          <p:nvPr/>
+        </p:nvSpPr>
+        <p:spPr>
+          <a:xfrm>
+            <a:off x="612648" y="3392423"/>
+            <a:ext cx="50292" cy="50292"/>
+          </a:xfrm>
+          <a:prstGeom prst="rect">
+            <a:avLst/>
+          </a:prstGeom>
+          <a:solidFill>
+            <a:srgbClr val="009B8A"/>
+          </a:solidFill>
+          <a:ln/>
+        </p:spPr>
+        <p:txBody>
+          <a:bodyPr/>
+          <a:lstStyle/>
+          <a:p>
+            <a:endParaRPr lang="en-PH" sz="1000"/>
+          </a:p>
+        </p:txBody>
+      </p:sp>
+      <p:sp>
+        <p:nvSpPr>
+          <p:cNvPr id="1079" name="Text"/>
+          <p:cNvSpPr/>
+          <p:nvPr/>
+        </p:nvSpPr>
+        <p:spPr>
+          <a:xfrm>
+            <a:off x="758952" y="3328415"/>
+            <a:ext cx="1545336" cy="201168"/>
+          </a:xfrm>
+          <a:prstGeom prst="rect">
+            <a:avLst/>
+          </a:prstGeom>
+          <a:noFill/>
+          <a:ln/>
+        </p:spPr>
+        <p:txBody>
+          <a:bodyPr wrap="square" rtlCol="0" anchor="ctr">
+            <a:normAutofit/>
+          </a:bodyPr>
+          <a:lstStyle/>
+          <a:p>
+            <a:pPr marL="0" indent="0" algn="l">
+              <a:buNone/>
+            </a:pPr>
+            <a:r>
+              <a:rPr lang="en-US" sz="900" b="0" kern="0" dirty="0">
+                <a:solidFill>
+                  <a:srgbClr val="333333"/>
+                </a:solidFill>
+                <a:latin typeface="Calibri" pitchFamily="34" charset="0"/>
+                <a:ea typeface="Calibri" pitchFamily="34" charset="-122"/>
+                <a:cs typeface="Calibri" pitchFamily="34" charset="-120"/>
+              </a:rPr>
+              <a:t>Terms within each category</a:t>
+            </a:r>
+          </a:p>
+        </p:txBody>
+      </p:sp>
+      <p:sp>
+        <p:nvSpPr>
+          <p:cNvPr id="1080" name="Rule"/>
+          <p:cNvSpPr/>
+          <p:nvPr/>
+        </p:nvSpPr>
+        <p:spPr>
+          <a:xfrm>
+            <a:off x="2578608" y="2688336"/>
+            <a:ext cx="1655063" cy="32004"/>
+          </a:xfrm>
+          <a:prstGeom prst="rect">
+            <a:avLst/>
+          </a:prstGeom>
+          <a:solidFill>
+            <a:srgbClr val="009B8A"/>
+          </a:solidFill>
+          <a:ln/>
+        </p:spPr>
+        <p:txBody>
+          <a:bodyPr/>
+          <a:lstStyle/>
+          <a:p>
+            <a:endParaRPr lang="en-PH" sz="1000"/>
+          </a:p>
+        </p:txBody>
+      </p:sp>
+      <p:sp>
+        <p:nvSpPr>
+          <p:cNvPr id="1081" name="Text"/>
+          <p:cNvSpPr/>
+          <p:nvPr/>
+        </p:nvSpPr>
+        <p:spPr>
+          <a:xfrm>
+            <a:off x="2578608" y="2761488"/>
+            <a:ext cx="1655063" cy="219456"/>
+          </a:xfrm>
+          <a:prstGeom prst="rect">
+            <a:avLst/>
+          </a:prstGeom>
+          <a:noFill/>
+          <a:ln/>
+        </p:spPr>
+        <p:txBody>
+          <a:bodyPr wrap="square" rtlCol="0" anchor="ctr">
+            <a:normAutofit/>
+          </a:bodyPr>
+          <a:lstStyle/>
+          <a:p>
+            <a:pPr marL="0" indent="0" algn="l">
+              <a:buNone/>
+            </a:pPr>
+            <a:r>
+              <a:rPr lang="en-US" sz="1050" b="1" kern="0" dirty="0">
+                <a:solidFill>
+                  <a:srgbClr val="003D5B"/>
+                </a:solidFill>
+                <a:latin typeface="Calibri" pitchFamily="34" charset="0"/>
+                <a:ea typeface="Calibri" pitchFamily="34" charset="-122"/>
+                <a:cs typeface="Calibri" pitchFamily="34" charset="-120"/>
+              </a:rPr>
+              <a:t>Rollup</a:t>
+            </a:r>
+          </a:p>
+        </p:txBody>
+      </p:sp>
+      <p:sp>
+        <p:nvSpPr>
+          <p:cNvPr id="1082" name="Bullet"/>
+          <p:cNvSpPr/>
+          <p:nvPr/>
+        </p:nvSpPr>
+        <p:spPr>
+          <a:xfrm>
+            <a:off x="2578608" y="3118103"/>
+            <a:ext cx="50292" cy="50292"/>
+          </a:xfrm>
+          <a:prstGeom prst="rect">
+            <a:avLst/>
+          </a:prstGeom>
+          <a:solidFill>
+            <a:srgbClr val="009B8A"/>
+          </a:solidFill>
+          <a:ln/>
+        </p:spPr>
+        <p:txBody>
+          <a:bodyPr/>
+          <a:lstStyle/>
+          <a:p>
+            <a:endParaRPr lang="en-PH" sz="1000"/>
+          </a:p>
+        </p:txBody>
+      </p:sp>
+      <p:sp>
+        <p:nvSpPr>
+          <p:cNvPr id="1083" name="Text"/>
+          <p:cNvSpPr/>
+          <p:nvPr/>
+        </p:nvSpPr>
+        <p:spPr>
+          <a:xfrm>
+            <a:off x="2724912" y="3054096"/>
+            <a:ext cx="1545336" cy="201168"/>
+          </a:xfrm>
+          <a:prstGeom prst="rect">
+            <a:avLst/>
+          </a:prstGeom>
+          <a:noFill/>
+          <a:ln/>
+        </p:spPr>
+        <p:txBody>
+          <a:bodyPr wrap="square" rtlCol="0" anchor="ctr">
+            <a:normAutofit/>
+          </a:bodyPr>
+          <a:lstStyle/>
+          <a:p>
+            <a:pPr marL="0" indent="0" algn="l">
+              <a:buNone/>
+            </a:pPr>
+            <a:r>
+              <a:rPr lang="en-US" sz="900" b="0" kern="0" dirty="0">
+                <a:solidFill>
+                  <a:srgbClr val="333333"/>
+                </a:solidFill>
+                <a:latin typeface="Calibri" pitchFamily="34" charset="0"/>
+                <a:ea typeface="Calibri" pitchFamily="34" charset="-122"/>
+                <a:cs typeface="Calibri" pitchFamily="34" charset="-120"/>
+              </a:rPr>
+              <a:t>Total terms per category</a:t>
+            </a:r>
+          </a:p>
+        </p:txBody>
+      </p:sp>
+      <p:sp>
+        <p:nvSpPr>
+          <p:cNvPr id="1084" name="Bullet"/>
+          <p:cNvSpPr/>
+          <p:nvPr/>
+        </p:nvSpPr>
+        <p:spPr>
+          <a:xfrm>
+            <a:off x="2578608" y="3392423"/>
+            <a:ext cx="50292" cy="50292"/>
+          </a:xfrm>
+          <a:prstGeom prst="rect">
+            <a:avLst/>
+          </a:prstGeom>
+          <a:solidFill>
+            <a:srgbClr val="009B8A"/>
+          </a:solidFill>
+          <a:ln/>
+        </p:spPr>
+        <p:txBody>
+          <a:bodyPr/>
+          <a:lstStyle/>
+          <a:p>
+            <a:endParaRPr lang="en-PH" sz="1000"/>
+          </a:p>
+        </p:txBody>
+      </p:sp>
+      <p:sp>
+        <p:nvSpPr>
+          <p:cNvPr id="1085" name="Text"/>
+          <p:cNvSpPr/>
+          <p:nvPr/>
+        </p:nvSpPr>
+        <p:spPr>
+          <a:xfrm>
+            <a:off x="2724912" y="3328415"/>
+            <a:ext cx="1545336" cy="201168"/>
+          </a:xfrm>
+          <a:prstGeom prst="rect">
+            <a:avLst/>
+          </a:prstGeom>
+          <a:noFill/>
+          <a:ln/>
+        </p:spPr>
+        <p:txBody>
+          <a:bodyPr wrap="square" rtlCol="0" anchor="ctr">
+            <a:normAutofit/>
+          </a:bodyPr>
+          <a:lstStyle/>
+          <a:p>
+            <a:pPr marL="0" indent="0" algn="l">
+              <a:buNone/>
+            </a:pPr>
+            <a:r>
+              <a:rPr lang="en-US" sz="900" b="0" kern="0" dirty="0">
+                <a:solidFill>
+                  <a:srgbClr val="333333"/>
+                </a:solidFill>
+                <a:latin typeface="Calibri" pitchFamily="34" charset="0"/>
+                <a:ea typeface="Calibri" pitchFamily="34" charset="-122"/>
+                <a:cs typeface="Calibri" pitchFamily="34" charset="-120"/>
+              </a:rPr>
+              <a:t>One screen per category</a:t>
+            </a:r>
+          </a:p>
+        </p:txBody>
+      </p:sp>
+      <p:sp>
+        <p:nvSpPr>
+          <p:cNvPr id="1086" name="Rule"/>
+          <p:cNvSpPr/>
+          <p:nvPr/>
+        </p:nvSpPr>
+        <p:spPr>
+          <a:xfrm>
+            <a:off x="4544568" y="2688336"/>
+            <a:ext cx="1655063" cy="32004"/>
+          </a:xfrm>
+          <a:prstGeom prst="rect">
+            <a:avLst/>
+          </a:prstGeom>
+          <a:solidFill>
+            <a:srgbClr val="009B8A"/>
+          </a:solidFill>
+          <a:ln/>
+        </p:spPr>
+        <p:txBody>
+          <a:bodyPr/>
+          <a:lstStyle/>
+          <a:p>
+            <a:endParaRPr lang="en-PH" sz="1000"/>
+          </a:p>
+        </p:txBody>
+      </p:sp>
+      <p:sp>
+        <p:nvSpPr>
+          <p:cNvPr id="1087" name="Text"/>
+          <p:cNvSpPr/>
+          <p:nvPr/>
+        </p:nvSpPr>
+        <p:spPr>
+          <a:xfrm>
+            <a:off x="4544568" y="2761488"/>
+            <a:ext cx="1655063" cy="219456"/>
+          </a:xfrm>
+          <a:prstGeom prst="rect">
+            <a:avLst/>
+          </a:prstGeom>
+          <a:noFill/>
+          <a:ln/>
+        </p:spPr>
+        <p:txBody>
+          <a:bodyPr wrap="square" rtlCol="0" anchor="ctr">
+            <a:normAutofit/>
+          </a:bodyPr>
+          <a:lstStyle/>
+          <a:p>
+            <a:pPr marL="0" indent="0" algn="l">
+              <a:buNone/>
+            </a:pPr>
+            <a:r>
+              <a:rPr lang="en-US" sz="1050" b="1" kern="0" dirty="0">
+                <a:solidFill>
+                  <a:srgbClr val="003D5B"/>
+                </a:solidFill>
+                <a:latin typeface="Calibri" pitchFamily="34" charset="0"/>
+                <a:ea typeface="Calibri" pitchFamily="34" charset="-122"/>
+                <a:cs typeface="Calibri" pitchFamily="34" charset="-120"/>
+              </a:rPr>
+              <a:t>Usage</a:t>
+            </a:r>
+          </a:p>
+        </p:txBody>
+      </p:sp>
+      <p:sp>
+        <p:nvSpPr>
+          <p:cNvPr id="1088" name="Bullet"/>
+          <p:cNvSpPr/>
+          <p:nvPr/>
+        </p:nvSpPr>
+        <p:spPr>
+          <a:xfrm>
+            <a:off x="4544568" y="3118103"/>
+            <a:ext cx="50292" cy="50292"/>
+          </a:xfrm>
+          <a:prstGeom prst="rect">
+            <a:avLst/>
+          </a:prstGeom>
+          <a:solidFill>
+            <a:srgbClr val="009B8A"/>
+          </a:solidFill>
+          <a:ln/>
+        </p:spPr>
+        <p:txBody>
+          <a:bodyPr/>
+          <a:lstStyle/>
+          <a:p>
+            <a:endParaRPr lang="en-PH" sz="1000"/>
+          </a:p>
+        </p:txBody>
+      </p:sp>
+      <p:sp>
+        <p:nvSpPr>
+          <p:cNvPr id="1089" name="Text"/>
+          <p:cNvSpPr/>
+          <p:nvPr/>
+        </p:nvSpPr>
+        <p:spPr>
+          <a:xfrm>
+            <a:off x="4690872" y="3054096"/>
+            <a:ext cx="1545336" cy="201168"/>
+          </a:xfrm>
+          <a:prstGeom prst="rect">
+            <a:avLst/>
+          </a:prstGeom>
+          <a:noFill/>
+          <a:ln/>
+        </p:spPr>
+        <p:txBody>
+          <a:bodyPr wrap="square" rtlCol="0" anchor="ctr">
+            <a:normAutofit/>
+          </a:bodyPr>
+          <a:lstStyle/>
+          <a:p>
+            <a:pPr marL="0" indent="0" algn="l">
+              <a:buNone/>
+            </a:pPr>
+            <a:r>
+              <a:rPr lang="en-US" sz="900" b="0" kern="0" dirty="0">
+                <a:solidFill>
+                  <a:srgbClr val="333333"/>
+                </a:solidFill>
+                <a:latin typeface="Calibri" pitchFamily="34" charset="0"/>
+                <a:ea typeface="Calibri" pitchFamily="34" charset="-122"/>
+                <a:cs typeface="Calibri" pitchFamily="34" charset="-120"/>
+              </a:rPr>
+              <a:t>Records mapped against each term</a:t>
+            </a:r>
+          </a:p>
+        </p:txBody>
+      </p:sp>
+      <p:sp>
+        <p:nvSpPr>
+          <p:cNvPr id="1090" name="Bullet"/>
+          <p:cNvSpPr/>
+          <p:nvPr/>
+        </p:nvSpPr>
+        <p:spPr>
+          <a:xfrm>
+            <a:off x="4544568" y="3392423"/>
+            <a:ext cx="50292" cy="50292"/>
+          </a:xfrm>
+          <a:prstGeom prst="rect">
+            <a:avLst/>
+          </a:prstGeom>
+          <a:solidFill>
+            <a:srgbClr val="009B8A"/>
+          </a:solidFill>
+          <a:ln/>
+        </p:spPr>
+        <p:txBody>
+          <a:bodyPr/>
+          <a:lstStyle/>
+          <a:p>
+            <a:endParaRPr lang="en-PH" sz="1000"/>
+          </a:p>
+        </p:txBody>
+      </p:sp>
+      <p:sp>
+        <p:nvSpPr>
+          <p:cNvPr id="1091" name="Text"/>
+          <p:cNvSpPr/>
+          <p:nvPr/>
+        </p:nvSpPr>
+        <p:spPr>
+          <a:xfrm>
+            <a:off x="4690872" y="3328415"/>
+            <a:ext cx="1545336" cy="201168"/>
+          </a:xfrm>
+          <a:prstGeom prst="rect">
+            <a:avLst/>
+          </a:prstGeom>
+          <a:noFill/>
+          <a:ln/>
+        </p:spPr>
+        <p:txBody>
+          <a:bodyPr wrap="square" rtlCol="0" anchor="ctr">
+            <a:normAutofit/>
+          </a:bodyPr>
+          <a:lstStyle/>
+          <a:p>
+            <a:pPr marL="0" indent="0" algn="l">
+              <a:buNone/>
+            </a:pPr>
+            <a:r>
+              <a:rPr lang="en-US" sz="900" b="0" kern="0" dirty="0">
+                <a:solidFill>
+                  <a:srgbClr val="333333"/>
+                </a:solidFill>
+                <a:latin typeface="Calibri" pitchFamily="34" charset="0"/>
+                <a:ea typeface="Calibri" pitchFamily="34" charset="-122"/>
+                <a:cs typeface="Calibri" pitchFamily="34" charset="-120"/>
+              </a:rPr>
+              <a:t>Terms with nothing declared against them</a:t>
+            </a:r>
+          </a:p>
+        </p:txBody>
+      </p:sp>
+      <p:sp>
+        <p:nvSpPr>
+          <p:cNvPr id="1092" name="Rule"/>
+          <p:cNvSpPr/>
+          <p:nvPr/>
+        </p:nvSpPr>
+        <p:spPr>
+          <a:xfrm>
+            <a:off x="6510527" y="2688336"/>
+            <a:ext cx="1655063" cy="32004"/>
+          </a:xfrm>
+          <a:prstGeom prst="rect">
+            <a:avLst/>
+          </a:prstGeom>
+          <a:solidFill>
+            <a:srgbClr val="009B8A"/>
+          </a:solidFill>
+          <a:ln/>
+        </p:spPr>
+        <p:txBody>
+          <a:bodyPr/>
+          <a:lstStyle/>
+          <a:p>
+            <a:endParaRPr lang="en-PH" sz="1000"/>
+          </a:p>
+        </p:txBody>
+      </p:sp>
+      <p:sp>
+        <p:nvSpPr>
+          <p:cNvPr id="1093" name="Text"/>
+          <p:cNvSpPr/>
+          <p:nvPr/>
+        </p:nvSpPr>
+        <p:spPr>
+          <a:xfrm>
+            <a:off x="6510527" y="2761488"/>
+            <a:ext cx="1655063" cy="219456"/>
+          </a:xfrm>
+          <a:prstGeom prst="rect">
+            <a:avLst/>
+          </a:prstGeom>
+          <a:noFill/>
+          <a:ln/>
+        </p:spPr>
+        <p:txBody>
+          <a:bodyPr wrap="square" rtlCol="0" anchor="ctr">
+            <a:normAutofit/>
+          </a:bodyPr>
+          <a:lstStyle/>
+          <a:p>
+            <a:pPr marL="0" indent="0" algn="l">
+              <a:buNone/>
+            </a:pPr>
+            <a:r>
+              <a:rPr lang="en-US" sz="1050" b="1" kern="0" dirty="0">
+                <a:solidFill>
+                  <a:srgbClr val="003D5B"/>
+                </a:solidFill>
+                <a:latin typeface="Calibri" pitchFamily="34" charset="0"/>
+                <a:ea typeface="Calibri" pitchFamily="34" charset="-122"/>
+                <a:cs typeface="Calibri" pitchFamily="34" charset="-120"/>
+              </a:rPr>
+              <a:t>Navigation</a:t>
+            </a:r>
+          </a:p>
+        </p:txBody>
+      </p:sp>
+      <p:sp>
+        <p:nvSpPr>
+          <p:cNvPr id="1094" name="Bullet"/>
+          <p:cNvSpPr/>
+          <p:nvPr/>
+        </p:nvSpPr>
+        <p:spPr>
+          <a:xfrm>
+            <a:off x="6510527" y="3118103"/>
+            <a:ext cx="50292" cy="50292"/>
+          </a:xfrm>
+          <a:prstGeom prst="rect">
+            <a:avLst/>
+          </a:prstGeom>
+          <a:solidFill>
+            <a:srgbClr val="009B8A"/>
+          </a:solidFill>
+          <a:ln/>
+        </p:spPr>
+        <p:txBody>
+          <a:bodyPr/>
+          <a:lstStyle/>
+          <a:p>
+            <a:endParaRPr lang="en-PH" sz="1000"/>
+          </a:p>
+        </p:txBody>
+      </p:sp>
+      <p:sp>
+        <p:nvSpPr>
+          <p:cNvPr id="1095" name="Text"/>
+          <p:cNvSpPr/>
+          <p:nvPr/>
+        </p:nvSpPr>
+        <p:spPr>
+          <a:xfrm>
+            <a:off x="6656831" y="3054096"/>
+            <a:ext cx="1545336" cy="201168"/>
+          </a:xfrm>
+          <a:prstGeom prst="rect">
+            <a:avLst/>
+          </a:prstGeom>
+          <a:noFill/>
+          <a:ln/>
+        </p:spPr>
+        <p:txBody>
+          <a:bodyPr wrap="square" rtlCol="0" anchor="ctr">
+            <a:normAutofit/>
+          </a:bodyPr>
+          <a:lstStyle/>
+          <a:p>
+            <a:pPr marL="0" indent="0" algn="l">
+              <a:buNone/>
+            </a:pPr>
+            <a:r>
+              <a:rPr lang="en-US" sz="900" b="0" kern="0" dirty="0">
+                <a:solidFill>
+                  <a:srgbClr val="333333"/>
+                </a:solidFill>
+                <a:latin typeface="Calibri" pitchFamily="34" charset="0"/>
+                <a:ea typeface="Calibri" pitchFamily="34" charset="-122"/>
+                <a:cs typeface="Calibri" pitchFamily="34" charset="-120"/>
+              </a:rPr>
+              <a:t>Category to term drill-down</a:t>
+            </a:r>
+          </a:p>
+        </p:txBody>
+      </p:sp>
+      <p:sp>
+        <p:nvSpPr>
+          <p:cNvPr id="1096" name="Bullet"/>
+          <p:cNvSpPr/>
+          <p:nvPr/>
+        </p:nvSpPr>
+        <p:spPr>
+          <a:xfrm>
+            <a:off x="6510527" y="3392423"/>
+            <a:ext cx="50292" cy="50292"/>
+          </a:xfrm>
+          <a:prstGeom prst="rect">
+            <a:avLst/>
+          </a:prstGeom>
+          <a:solidFill>
+            <a:srgbClr val="009B8A"/>
+          </a:solidFill>
+          <a:ln/>
+        </p:spPr>
+        <p:txBody>
+          <a:bodyPr/>
+          <a:lstStyle/>
+          <a:p>
+            <a:endParaRPr lang="en-PH" sz="1000"/>
+          </a:p>
+        </p:txBody>
+      </p:sp>
+      <p:sp>
+        <p:nvSpPr>
+          <p:cNvPr id="1097" name="Text"/>
+          <p:cNvSpPr/>
+          <p:nvPr/>
+        </p:nvSpPr>
+        <p:spPr>
+          <a:xfrm>
+            <a:off x="6656831" y="3328415"/>
+            <a:ext cx="1545336" cy="201168"/>
+          </a:xfrm>
+          <a:prstGeom prst="rect">
+            <a:avLst/>
+          </a:prstGeom>
+          <a:noFill/>
+          <a:ln/>
+        </p:spPr>
+        <p:txBody>
+          <a:bodyPr wrap="square" rtlCol="0" anchor="ctr">
+            <a:normAutofit/>
+          </a:bodyPr>
+          <a:lstStyle/>
+          <a:p>
+            <a:pPr marL="0" indent="0" algn="l">
+              <a:buNone/>
+            </a:pPr>
+            <a:r>
+              <a:rPr lang="en-US" sz="900" b="0" kern="0" dirty="0">
+                <a:solidFill>
+                  <a:srgbClr val="333333"/>
+                </a:solidFill>
+                <a:latin typeface="Calibri" pitchFamily="34" charset="0"/>
+                <a:ea typeface="Calibri" pitchFamily="34" charset="-122"/>
+                <a:cs typeface="Calibri" pitchFamily="34" charset="-120"/>
+              </a:rPr>
+              <a:t>Term to declared records</a:t>
+            </a:r>
           </a:p>
         </p:txBody>
       </p:sp>
     </p:spTree>
-    <p:extLst>
-      <p:ext uri="{BB962C8B-B14F-4D97-AF65-F5344CB8AC3E}">
-        <p14:creationId xmlns:p14="http://schemas.microsoft.com/office/powerpoint/2010/main" val="2558533216"/>
-      </p:ext>
-    </p:extLst>
   </p:cSld>
   <p:clrMapOvr>
     <a:masterClrMapping/>
@@ -3451,16 +4678,18 @@
 
 <file path=ppt/slides/slide11.xml><?xml version="1.0" encoding="utf-8"?>
 <p:sld xmlns:a="http://schemas.openxmlformats.org/drawingml/2006/main" xmlns:r="http://schemas.openxmlformats.org/officeDocument/2006/relationships" xmlns:p="http://schemas.openxmlformats.org/presentationml/2006/main">
-  <p:cSld>
+  <p:cSld name="Institutional File Plan — asks">
+    <p:bg>
+      <p:bgPr>
+        <a:solidFill>
+          <a:srgbClr val="FFFFFF"/>
+        </a:solidFill>
+        <a:effectLst/>
+      </p:bgPr>
+    </p:bg>
     <p:spTree>
       <p:nvGrpSpPr>
-        <p:cNvPr id="1" name="">
-          <a:extLst>
-            <a:ext uri="{FF2B5EF4-FFF2-40B4-BE49-F238E27FC236}">
-              <a16:creationId xmlns:a16="http://schemas.microsoft.com/office/drawing/2014/main" id="{F762D66C-C930-5B0B-4787-575BDAE3B4C9}"/>
-            </a:ext>
-          </a:extLst>
-        </p:cNvPr>
+        <p:cNvPr id="1" name=""/>
         <p:cNvGrpSpPr/>
         <p:nvPr/>
       </p:nvGrpSpPr>
@@ -3474,19 +4703,13 @@
       </p:grpSpPr>
       <p:sp>
         <p:nvSpPr>
-          <p:cNvPr id="4" name="Text 2">
-            <a:extLst>
-              <a:ext uri="{FF2B5EF4-FFF2-40B4-BE49-F238E27FC236}">
-                <a16:creationId xmlns:a16="http://schemas.microsoft.com/office/drawing/2014/main" id="{86E21968-6359-FF18-0B38-1C5A7C0F0E7A}"/>
-              </a:ext>
-            </a:extLst>
-          </p:cNvPr>
-          <p:cNvSpPr/>
-          <p:nvPr/>
-        </p:nvSpPr>
-        <p:spPr>
-          <a:xfrm>
-            <a:off x="198186" y="93986"/>
+          <p:cNvPr id="1098" name="Title"/>
+          <p:cNvSpPr/>
+          <p:nvPr/>
+        </p:nvSpPr>
+        <p:spPr>
+          <a:xfrm>
+            <a:off x="201168" y="91440"/>
             <a:ext cx="8412480" cy="493776"/>
           </a:xfrm>
           <a:prstGeom prst="rect">
@@ -3496,44 +4719,709 @@
           <a:ln/>
         </p:spPr>
         <p:txBody>
-          <a:bodyPr wrap="square" lIns="0" tIns="0" rIns="0" bIns="0" rtlCol="0" anchor="ctr"/>
-          <a:lstStyle/>
-          <a:p>
-            <a:pPr marL="0" indent="0">
-              <a:buNone/>
-            </a:pPr>
-            <a:r>
-              <a:rPr lang="en-US" sz="2700" b="1" dirty="0">
-                <a:solidFill>
-                  <a:schemeClr val="tx2">
-                    <a:lumMod val="76000"/>
-                  </a:schemeClr>
-                </a:solidFill>
-                <a:latin typeface="Cambria"/>
-                <a:ea typeface="Cambria"/>
-                <a:cs typeface="Cambria" pitchFamily="34" charset="-120"/>
+          <a:bodyPr wrap="square" rtlCol="0" anchor="ctr">
+            <a:normAutofit/>
+          </a:bodyPr>
+          <a:lstStyle/>
+          <a:p>
+            <a:pPr marL="0" indent="0" algn="l">
+              <a:buNone/>
+            </a:pPr>
+            <a:r>
+              <a:rPr lang="en-US" sz="2700" b="1" kern="0" dirty="0">
+                <a:solidFill>
+                  <a:srgbClr val="003D5B"/>
+                </a:solidFill>
+                <a:latin typeface="Calibri" pitchFamily="34" charset="0"/>
+                <a:ea typeface="Calibri" pitchFamily="34" charset="-122"/>
+                <a:cs typeface="Calibri" pitchFamily="34" charset="-120"/>
               </a:rPr>
               <a:t>Institutional File Plan</a:t>
             </a:r>
-            <a:endParaRPr lang="en-US" sz="2700" dirty="0">
-              <a:solidFill>
-                <a:schemeClr val="tx2">
-                  <a:lumMod val="76000"/>
-                </a:schemeClr>
-              </a:solidFill>
-              <a:latin typeface="Cambria"/>
-              <a:ea typeface="Cambria"/>
-              <a:cs typeface="Calibri"/>
-            </a:endParaRPr>
+          </a:p>
+        </p:txBody>
+      </p:sp>
+      <p:sp>
+        <p:nvSpPr>
+          <p:cNvPr id="1099" name="Subtitle"/>
+          <p:cNvSpPr/>
+          <p:nvPr/>
+        </p:nvSpPr>
+        <p:spPr>
+          <a:xfrm>
+            <a:off x="192024" y="640080"/>
+            <a:ext cx="8412480" cy="310896"/>
+          </a:xfrm>
+          <a:prstGeom prst="rect">
+            <a:avLst/>
+          </a:prstGeom>
+          <a:noFill/>
+          <a:ln/>
+        </p:spPr>
+        <p:txBody>
+          <a:bodyPr wrap="square" rtlCol="0" anchor="ctr">
+            <a:normAutofit/>
+          </a:bodyPr>
+          <a:lstStyle/>
+          <a:p>
+            <a:pPr marL="0" indent="0" algn="l">
+              <a:buNone/>
+            </a:pPr>
+            <a:r>
+              <a:rPr lang="en-US" sz="1400" b="0" kern="0" dirty="0">
+                <a:solidFill>
+                  <a:srgbClr val="009B8A"/>
+                </a:solidFill>
+                <a:latin typeface="Calibri" pitchFamily="34" charset="0"/>
+                <a:ea typeface="Calibri" pitchFamily="34" charset="-122"/>
+                <a:cs typeface="Calibri" pitchFamily="34" charset="-120"/>
+              </a:rPr>
+              <a:t>What we need from you before these can be built.</a:t>
+            </a:r>
+          </a:p>
+        </p:txBody>
+      </p:sp>
+      <p:sp>
+        <p:nvSpPr>
+          <p:cNvPr id="1100" name="Text"/>
+          <p:cNvSpPr/>
+          <p:nvPr/>
+        </p:nvSpPr>
+        <p:spPr>
+          <a:xfrm>
+            <a:off x="411480" y="1024128"/>
+            <a:ext cx="4572000" cy="201168"/>
+          </a:xfrm>
+          <a:prstGeom prst="rect">
+            <a:avLst/>
+          </a:prstGeom>
+          <a:noFill/>
+          <a:ln/>
+        </p:spPr>
+        <p:txBody>
+          <a:bodyPr wrap="square" rtlCol="0" anchor="ctr">
+            <a:normAutofit/>
+          </a:bodyPr>
+          <a:lstStyle/>
+          <a:p>
+            <a:pPr marL="0" indent="0" algn="l">
+              <a:buNone/>
+            </a:pPr>
+            <a:r>
+              <a:rPr lang="en-US" sz="1200" b="1" kern="0" spc="105" dirty="0">
+                <a:solidFill>
+                  <a:srgbClr val="003D5B"/>
+                </a:solidFill>
+                <a:latin typeface="Calibri" pitchFamily="34" charset="0"/>
+                <a:ea typeface="Calibri" pitchFamily="34" charset="-122"/>
+                <a:cs typeface="Calibri" pitchFamily="34" charset="-120"/>
+              </a:rPr>
+              <a:t>WHAT WE NEED FROM YOU</a:t>
+            </a:r>
+          </a:p>
+        </p:txBody>
+      </p:sp>
+      <p:sp>
+        <p:nvSpPr>
+          <p:cNvPr id="1101" name="Dot"/>
+          <p:cNvSpPr/>
+          <p:nvPr/>
+        </p:nvSpPr>
+        <p:spPr>
+          <a:xfrm>
+            <a:off x="411480" y="1335024"/>
+            <a:ext cx="256032" cy="256032"/>
+          </a:xfrm>
+          <a:prstGeom prst="ellipse">
+            <a:avLst/>
+          </a:prstGeom>
+          <a:solidFill>
+            <a:srgbClr val="009B8A"/>
+          </a:solidFill>
+          <a:ln/>
+        </p:spPr>
+        <p:txBody>
+          <a:bodyPr/>
+          <a:lstStyle/>
+          <a:p>
+            <a:endParaRPr lang="en-PH" sz="1000"/>
+          </a:p>
+        </p:txBody>
+      </p:sp>
+      <p:sp>
+        <p:nvSpPr>
+          <p:cNvPr id="1102" name="Text"/>
+          <p:cNvSpPr/>
+          <p:nvPr/>
+        </p:nvSpPr>
+        <p:spPr>
+          <a:xfrm>
+            <a:off x="411480" y="1353312"/>
+            <a:ext cx="256032" cy="219456"/>
+          </a:xfrm>
+          <a:prstGeom prst="rect">
+            <a:avLst/>
+          </a:prstGeom>
+          <a:noFill/>
+          <a:ln/>
+        </p:spPr>
+        <p:txBody>
+          <a:bodyPr wrap="square" rtlCol="0" anchor="ctr">
+            <a:normAutofit/>
+          </a:bodyPr>
+          <a:lstStyle/>
+          <a:p>
+            <a:pPr marL="0" indent="0" algn="ctr">
+              <a:buNone/>
+            </a:pPr>
+            <a:r>
+              <a:rPr lang="en-US" sz="1100" b="1" kern="0" dirty="0">
+                <a:solidFill>
+                  <a:srgbClr val="FFFFFF"/>
+                </a:solidFill>
+                <a:latin typeface="Calibri" pitchFamily="34" charset="0"/>
+                <a:ea typeface="Calibri" pitchFamily="34" charset="-122"/>
+                <a:cs typeface="Calibri" pitchFamily="34" charset="-120"/>
+              </a:rPr>
+              <a:t>1</a:t>
+            </a:r>
+          </a:p>
+        </p:txBody>
+      </p:sp>
+      <p:sp>
+        <p:nvSpPr>
+          <p:cNvPr id="1103" name="Text"/>
+          <p:cNvSpPr/>
+          <p:nvPr/>
+        </p:nvSpPr>
+        <p:spPr>
+          <a:xfrm>
+            <a:off x="758952" y="1325880"/>
+            <a:ext cx="3648456" cy="237744"/>
+          </a:xfrm>
+          <a:prstGeom prst="rect">
+            <a:avLst/>
+          </a:prstGeom>
+          <a:noFill/>
+          <a:ln/>
+        </p:spPr>
+        <p:txBody>
+          <a:bodyPr wrap="square" rtlCol="0" anchor="ctr">
+            <a:normAutofit/>
+          </a:bodyPr>
+          <a:lstStyle/>
+          <a:p>
+            <a:pPr marL="0" indent="0" algn="l">
+              <a:buNone/>
+            </a:pPr>
+            <a:r>
+              <a:rPr lang="en-US" sz="1200" b="1" kern="0" dirty="0">
+                <a:solidFill>
+                  <a:srgbClr val="003D5B"/>
+                </a:solidFill>
+                <a:latin typeface="Calibri" pitchFamily="34" charset="0"/>
+                <a:ea typeface="Calibri" pitchFamily="34" charset="-122"/>
+                <a:cs typeface="Calibri" pitchFamily="34" charset="-120"/>
+              </a:rPr>
+              <a:t>Is the structure right</a:t>
+            </a:r>
+          </a:p>
+        </p:txBody>
+      </p:sp>
+      <p:sp>
+        <p:nvSpPr>
+          <p:cNvPr id="1104" name="Text"/>
+          <p:cNvSpPr/>
+          <p:nvPr/>
+        </p:nvSpPr>
+        <p:spPr>
+          <a:xfrm>
+            <a:off x="758952" y="1581912"/>
+            <a:ext cx="3630168" cy="731520"/>
+          </a:xfrm>
+          <a:prstGeom prst="rect">
+            <a:avLst/>
+          </a:prstGeom>
+          <a:noFill/>
+          <a:ln/>
+        </p:spPr>
+        <p:txBody>
+          <a:bodyPr wrap="square" rtlCol="0" anchor="t">
+            <a:normAutofit/>
+          </a:bodyPr>
+          <a:lstStyle/>
+          <a:p>
+            <a:pPr marL="0" indent="0" algn="l">
+              <a:lnSpc>
+                <a:spcPct val="92000"/>
+              </a:lnSpc>
+              <a:buNone/>
+            </a:pPr>
+            <a:r>
+              <a:rPr lang="en-US" sz="1000" b="0" kern="0" dirty="0">
+                <a:solidFill>
+                  <a:srgbClr val="333333"/>
+                </a:solidFill>
+                <a:latin typeface="Calibri" pitchFamily="34" charset="0"/>
+                <a:ea typeface="Calibri" pitchFamily="34" charset="-122"/>
+                <a:cs typeface="Calibri" pitchFamily="34" charset="-120"/>
+              </a:rPr>
+              <a:t>Does the hierarchy shown match your current approved file plan, including the category names?</a:t>
+            </a:r>
+          </a:p>
+        </p:txBody>
+      </p:sp>
+      <p:sp>
+        <p:nvSpPr>
+          <p:cNvPr id="1105" name="Dot"/>
+          <p:cNvSpPr/>
+          <p:nvPr/>
+        </p:nvSpPr>
+        <p:spPr>
+          <a:xfrm>
+            <a:off x="4736592" y="1335024"/>
+            <a:ext cx="256032" cy="256032"/>
+          </a:xfrm>
+          <a:prstGeom prst="ellipse">
+            <a:avLst/>
+          </a:prstGeom>
+          <a:solidFill>
+            <a:srgbClr val="009B8A"/>
+          </a:solidFill>
+          <a:ln/>
+        </p:spPr>
+        <p:txBody>
+          <a:bodyPr/>
+          <a:lstStyle/>
+          <a:p>
+            <a:endParaRPr lang="en-PH" sz="1000"/>
+          </a:p>
+        </p:txBody>
+      </p:sp>
+      <p:sp>
+        <p:nvSpPr>
+          <p:cNvPr id="1106" name="Text"/>
+          <p:cNvSpPr/>
+          <p:nvPr/>
+        </p:nvSpPr>
+        <p:spPr>
+          <a:xfrm>
+            <a:off x="4736592" y="1353312"/>
+            <a:ext cx="256032" cy="219456"/>
+          </a:xfrm>
+          <a:prstGeom prst="rect">
+            <a:avLst/>
+          </a:prstGeom>
+          <a:noFill/>
+          <a:ln/>
+        </p:spPr>
+        <p:txBody>
+          <a:bodyPr wrap="square" rtlCol="0" anchor="ctr">
+            <a:normAutofit/>
+          </a:bodyPr>
+          <a:lstStyle/>
+          <a:p>
+            <a:pPr marL="0" indent="0" algn="ctr">
+              <a:buNone/>
+            </a:pPr>
+            <a:r>
+              <a:rPr lang="en-US" sz="1100" b="1" kern="0" dirty="0">
+                <a:solidFill>
+                  <a:srgbClr val="FFFFFF"/>
+                </a:solidFill>
+                <a:latin typeface="Calibri" pitchFamily="34" charset="0"/>
+                <a:ea typeface="Calibri" pitchFamily="34" charset="-122"/>
+                <a:cs typeface="Calibri" pitchFamily="34" charset="-120"/>
+              </a:rPr>
+              <a:t>2</a:t>
+            </a:r>
+          </a:p>
+        </p:txBody>
+      </p:sp>
+      <p:sp>
+        <p:nvSpPr>
+          <p:cNvPr id="1107" name="Text"/>
+          <p:cNvSpPr/>
+          <p:nvPr/>
+        </p:nvSpPr>
+        <p:spPr>
+          <a:xfrm>
+            <a:off x="5084064" y="1325880"/>
+            <a:ext cx="3648456" cy="237744"/>
+          </a:xfrm>
+          <a:prstGeom prst="rect">
+            <a:avLst/>
+          </a:prstGeom>
+          <a:noFill/>
+          <a:ln/>
+        </p:spPr>
+        <p:txBody>
+          <a:bodyPr wrap="square" rtlCol="0" anchor="ctr">
+            <a:normAutofit/>
+          </a:bodyPr>
+          <a:lstStyle/>
+          <a:p>
+            <a:pPr marL="0" indent="0" algn="l">
+              <a:buNone/>
+            </a:pPr>
+            <a:r>
+              <a:rPr lang="en-US" sz="1200" b="1" kern="0" dirty="0">
+                <a:solidFill>
+                  <a:srgbClr val="003D5B"/>
+                </a:solidFill>
+                <a:latin typeface="Calibri" pitchFamily="34" charset="0"/>
+                <a:ea typeface="Calibri" pitchFamily="34" charset="-122"/>
+                <a:cs typeface="Calibri" pitchFamily="34" charset="-120"/>
+              </a:rPr>
+              <a:t>Retired terms</a:t>
+            </a:r>
+          </a:p>
+        </p:txBody>
+      </p:sp>
+      <p:sp>
+        <p:nvSpPr>
+          <p:cNvPr id="1108" name="Text"/>
+          <p:cNvSpPr/>
+          <p:nvPr/>
+        </p:nvSpPr>
+        <p:spPr>
+          <a:xfrm>
+            <a:off x="5084064" y="1581912"/>
+            <a:ext cx="3630168" cy="731520"/>
+          </a:xfrm>
+          <a:prstGeom prst="rect">
+            <a:avLst/>
+          </a:prstGeom>
+          <a:noFill/>
+          <a:ln/>
+        </p:spPr>
+        <p:txBody>
+          <a:bodyPr wrap="square" rtlCol="0" anchor="t">
+            <a:normAutofit/>
+          </a:bodyPr>
+          <a:lstStyle/>
+          <a:p>
+            <a:pPr marL="0" indent="0" algn="l">
+              <a:lnSpc>
+                <a:spcPct val="92000"/>
+              </a:lnSpc>
+              <a:buNone/>
+            </a:pPr>
+            <a:r>
+              <a:rPr lang="en-US" sz="1000" b="0" kern="0" dirty="0">
+                <a:solidFill>
+                  <a:srgbClr val="333333"/>
+                </a:solidFill>
+                <a:latin typeface="Calibri" pitchFamily="34" charset="0"/>
+                <a:ea typeface="Calibri" pitchFamily="34" charset="-122"/>
+                <a:cs typeface="Calibri" pitchFamily="34" charset="-120"/>
+              </a:rPr>
+              <a:t>Are there terms that are deprecated but still present? Should they show, or be suppressed?</a:t>
+            </a:r>
+          </a:p>
+        </p:txBody>
+      </p:sp>
+      <p:sp>
+        <p:nvSpPr>
+          <p:cNvPr id="1109" name="Dot"/>
+          <p:cNvSpPr/>
+          <p:nvPr/>
+        </p:nvSpPr>
+        <p:spPr>
+          <a:xfrm>
+            <a:off x="411480" y="2395728"/>
+            <a:ext cx="256032" cy="256032"/>
+          </a:xfrm>
+          <a:prstGeom prst="ellipse">
+            <a:avLst/>
+          </a:prstGeom>
+          <a:solidFill>
+            <a:srgbClr val="009B8A"/>
+          </a:solidFill>
+          <a:ln/>
+        </p:spPr>
+        <p:txBody>
+          <a:bodyPr/>
+          <a:lstStyle/>
+          <a:p>
+            <a:endParaRPr lang="en-PH" sz="1000"/>
+          </a:p>
+        </p:txBody>
+      </p:sp>
+      <p:sp>
+        <p:nvSpPr>
+          <p:cNvPr id="1110" name="Text"/>
+          <p:cNvSpPr/>
+          <p:nvPr/>
+        </p:nvSpPr>
+        <p:spPr>
+          <a:xfrm>
+            <a:off x="411480" y="2414016"/>
+            <a:ext cx="256032" cy="219456"/>
+          </a:xfrm>
+          <a:prstGeom prst="rect">
+            <a:avLst/>
+          </a:prstGeom>
+          <a:noFill/>
+          <a:ln/>
+        </p:spPr>
+        <p:txBody>
+          <a:bodyPr wrap="square" rtlCol="0" anchor="ctr">
+            <a:normAutofit/>
+          </a:bodyPr>
+          <a:lstStyle/>
+          <a:p>
+            <a:pPr marL="0" indent="0" algn="ctr">
+              <a:buNone/>
+            </a:pPr>
+            <a:r>
+              <a:rPr lang="en-US" sz="1100" b="1" kern="0" dirty="0">
+                <a:solidFill>
+                  <a:srgbClr val="FFFFFF"/>
+                </a:solidFill>
+                <a:latin typeface="Calibri" pitchFamily="34" charset="0"/>
+                <a:ea typeface="Calibri" pitchFamily="34" charset="-122"/>
+                <a:cs typeface="Calibri" pitchFamily="34" charset="-120"/>
+              </a:rPr>
+              <a:t>3</a:t>
+            </a:r>
+          </a:p>
+        </p:txBody>
+      </p:sp>
+      <p:sp>
+        <p:nvSpPr>
+          <p:cNvPr id="1111" name="Text"/>
+          <p:cNvSpPr/>
+          <p:nvPr/>
+        </p:nvSpPr>
+        <p:spPr>
+          <a:xfrm>
+            <a:off x="758952" y="2386584"/>
+            <a:ext cx="3648456" cy="237744"/>
+          </a:xfrm>
+          <a:prstGeom prst="rect">
+            <a:avLst/>
+          </a:prstGeom>
+          <a:noFill/>
+          <a:ln/>
+        </p:spPr>
+        <p:txBody>
+          <a:bodyPr wrap="square" rtlCol="0" anchor="ctr">
+            <a:normAutofit/>
+          </a:bodyPr>
+          <a:lstStyle/>
+          <a:p>
+            <a:pPr marL="0" indent="0" algn="l">
+              <a:buNone/>
+            </a:pPr>
+            <a:r>
+              <a:rPr lang="en-US" sz="1200" b="1" kern="0" dirty="0">
+                <a:solidFill>
+                  <a:srgbClr val="003D5B"/>
+                </a:solidFill>
+                <a:latin typeface="Calibri" pitchFamily="34" charset="0"/>
+                <a:ea typeface="Calibri" pitchFamily="34" charset="-122"/>
+                <a:cs typeface="Calibri" pitchFamily="34" charset="-120"/>
+              </a:rPr>
+              <a:t>Change cadence</a:t>
+            </a:r>
+          </a:p>
+        </p:txBody>
+      </p:sp>
+      <p:sp>
+        <p:nvSpPr>
+          <p:cNvPr id="1112" name="Text"/>
+          <p:cNvSpPr/>
+          <p:nvPr/>
+        </p:nvSpPr>
+        <p:spPr>
+          <a:xfrm>
+            <a:off x="758952" y="2642616"/>
+            <a:ext cx="3630168" cy="731520"/>
+          </a:xfrm>
+          <a:prstGeom prst="rect">
+            <a:avLst/>
+          </a:prstGeom>
+          <a:noFill/>
+          <a:ln/>
+        </p:spPr>
+        <p:txBody>
+          <a:bodyPr wrap="square" rtlCol="0" anchor="t">
+            <a:normAutofit/>
+          </a:bodyPr>
+          <a:lstStyle/>
+          <a:p>
+            <a:pPr marL="0" indent="0" algn="l">
+              <a:lnSpc>
+                <a:spcPct val="92000"/>
+              </a:lnSpc>
+              <a:buNone/>
+            </a:pPr>
+            <a:r>
+              <a:rPr lang="en-US" sz="1000" b="0" kern="0" dirty="0">
+                <a:solidFill>
+                  <a:srgbClr val="333333"/>
+                </a:solidFill>
+                <a:latin typeface="Calibri" pitchFamily="34" charset="0"/>
+                <a:ea typeface="Calibri" pitchFamily="34" charset="-122"/>
+                <a:cs typeface="Calibri" pitchFamily="34" charset="-120"/>
+              </a:rPr>
+              <a:t>How often does the file plan change, and who should we expect the updated structure from?</a:t>
+            </a:r>
+          </a:p>
+        </p:txBody>
+      </p:sp>
+      <p:sp>
+        <p:nvSpPr>
+          <p:cNvPr id="1113" name="Dot"/>
+          <p:cNvSpPr/>
+          <p:nvPr/>
+        </p:nvSpPr>
+        <p:spPr>
+          <a:xfrm>
+            <a:off x="4736592" y="2395728"/>
+            <a:ext cx="256032" cy="256032"/>
+          </a:xfrm>
+          <a:prstGeom prst="ellipse">
+            <a:avLst/>
+          </a:prstGeom>
+          <a:solidFill>
+            <a:srgbClr val="009B8A"/>
+          </a:solidFill>
+          <a:ln/>
+        </p:spPr>
+        <p:txBody>
+          <a:bodyPr/>
+          <a:lstStyle/>
+          <a:p>
+            <a:endParaRPr lang="en-PH" sz="1000"/>
+          </a:p>
+        </p:txBody>
+      </p:sp>
+      <p:sp>
+        <p:nvSpPr>
+          <p:cNvPr id="1114" name="Text"/>
+          <p:cNvSpPr/>
+          <p:nvPr/>
+        </p:nvSpPr>
+        <p:spPr>
+          <a:xfrm>
+            <a:off x="4736592" y="2414016"/>
+            <a:ext cx="256032" cy="219456"/>
+          </a:xfrm>
+          <a:prstGeom prst="rect">
+            <a:avLst/>
+          </a:prstGeom>
+          <a:noFill/>
+          <a:ln/>
+        </p:spPr>
+        <p:txBody>
+          <a:bodyPr wrap="square" rtlCol="0" anchor="ctr">
+            <a:normAutofit/>
+          </a:bodyPr>
+          <a:lstStyle/>
+          <a:p>
+            <a:pPr marL="0" indent="0" algn="ctr">
+              <a:buNone/>
+            </a:pPr>
+            <a:r>
+              <a:rPr lang="en-US" sz="1100" b="1" kern="0" dirty="0">
+                <a:solidFill>
+                  <a:srgbClr val="FFFFFF"/>
+                </a:solidFill>
+                <a:latin typeface="Calibri" pitchFamily="34" charset="0"/>
+                <a:ea typeface="Calibri" pitchFamily="34" charset="-122"/>
+                <a:cs typeface="Calibri" pitchFamily="34" charset="-120"/>
+              </a:rPr>
+              <a:t>4</a:t>
+            </a:r>
+          </a:p>
+        </p:txBody>
+      </p:sp>
+      <p:sp>
+        <p:nvSpPr>
+          <p:cNvPr id="1115" name="Text"/>
+          <p:cNvSpPr/>
+          <p:nvPr/>
+        </p:nvSpPr>
+        <p:spPr>
+          <a:xfrm>
+            <a:off x="5084064" y="2386584"/>
+            <a:ext cx="3648456" cy="237744"/>
+          </a:xfrm>
+          <a:prstGeom prst="rect">
+            <a:avLst/>
+          </a:prstGeom>
+          <a:noFill/>
+          <a:ln/>
+        </p:spPr>
+        <p:txBody>
+          <a:bodyPr wrap="square" rtlCol="0" anchor="ctr">
+            <a:normAutofit/>
+          </a:bodyPr>
+          <a:lstStyle/>
+          <a:p>
+            <a:pPr marL="0" indent="0" algn="l">
+              <a:buNone/>
+            </a:pPr>
+            <a:r>
+              <a:rPr lang="en-US" sz="1200" b="1" kern="0" dirty="0">
+                <a:solidFill>
+                  <a:srgbClr val="003D5B"/>
+                </a:solidFill>
+                <a:latin typeface="Calibri" pitchFamily="34" charset="0"/>
+                <a:ea typeface="Calibri" pitchFamily="34" charset="-122"/>
+                <a:cs typeface="Calibri" pitchFamily="34" charset="-120"/>
+              </a:rPr>
+              <a:t>Anything missing</a:t>
+            </a:r>
+          </a:p>
+        </p:txBody>
+      </p:sp>
+      <p:sp>
+        <p:nvSpPr>
+          <p:cNvPr id="1116" name="Text"/>
+          <p:cNvSpPr/>
+          <p:nvPr/>
+        </p:nvSpPr>
+        <p:spPr>
+          <a:xfrm>
+            <a:off x="5084064" y="2642616"/>
+            <a:ext cx="3630168" cy="731520"/>
+          </a:xfrm>
+          <a:prstGeom prst="rect">
+            <a:avLst/>
+          </a:prstGeom>
+          <a:noFill/>
+          <a:ln/>
+        </p:spPr>
+        <p:txBody>
+          <a:bodyPr wrap="square" rtlCol="0" anchor="t">
+            <a:normAutofit/>
+          </a:bodyPr>
+          <a:lstStyle/>
+          <a:p>
+            <a:pPr marL="0" indent="0" algn="l">
+              <a:lnSpc>
+                <a:spcPct val="92000"/>
+              </a:lnSpc>
+              <a:buNone/>
+            </a:pPr>
+            <a:r>
+              <a:rPr lang="en-US" sz="1000" b="0" kern="0" dirty="0">
+                <a:solidFill>
+                  <a:srgbClr val="333333"/>
+                </a:solidFill>
+                <a:latin typeface="Calibri" pitchFamily="34" charset="0"/>
+                <a:ea typeface="Calibri" pitchFamily="34" charset="-122"/>
+                <a:cs typeface="Calibri" pitchFamily="34" charset="-120"/>
+              </a:rPr>
+              <a:t>This page carries no open gaps on our side. If something you expected is absent, this is the moment to say so.</a:t>
+            </a:r>
           </a:p>
         </p:txBody>
       </p:sp>
     </p:spTree>
-    <p:extLst>
-      <p:ext uri="{BB962C8B-B14F-4D97-AF65-F5344CB8AC3E}">
-        <p14:creationId xmlns:p14="http://schemas.microsoft.com/office/powerpoint/2010/main" val="1630078666"/>
-      </p:ext>
-    </p:extLst>
   </p:cSld>
   <p:clrMapOvr>
     <a:masterClrMapping/>
@@ -11808,16 +13696,18 @@
 
 <file path=ppt/slides/slide8.xml><?xml version="1.0" encoding="utf-8"?>
 <p:sld xmlns:a="http://schemas.openxmlformats.org/drawingml/2006/main" xmlns:r="http://schemas.openxmlformats.org/officeDocument/2006/relationships" xmlns:p="http://schemas.openxmlformats.org/presentationml/2006/main">
-  <p:cSld>
+  <p:cSld name="Project Insights">
+    <p:bg>
+      <p:bgPr>
+        <a:solidFill>
+          <a:srgbClr val="FFFFFF"/>
+        </a:solidFill>
+        <a:effectLst/>
+      </p:bgPr>
+    </p:bg>
     <p:spTree>
       <p:nvGrpSpPr>
-        <p:cNvPr id="1" name="">
-          <a:extLst>
-            <a:ext uri="{FF2B5EF4-FFF2-40B4-BE49-F238E27FC236}">
-              <a16:creationId xmlns:a16="http://schemas.microsoft.com/office/drawing/2014/main" id="{566C5788-3B78-0408-23ED-722639F563F8}"/>
-            </a:ext>
-          </a:extLst>
-        </p:cNvPr>
+        <p:cNvPr id="1" name=""/>
         <p:cNvGrpSpPr/>
         <p:nvPr/>
       </p:nvGrpSpPr>
@@ -11831,19 +13721,13 @@
       </p:grpSpPr>
       <p:sp>
         <p:nvSpPr>
-          <p:cNvPr id="4" name="Text 2">
-            <a:extLst>
-              <a:ext uri="{FF2B5EF4-FFF2-40B4-BE49-F238E27FC236}">
-                <a16:creationId xmlns:a16="http://schemas.microsoft.com/office/drawing/2014/main" id="{071CD5B6-097F-1E93-AB4C-58A81D2C3CE8}"/>
-              </a:ext>
-            </a:extLst>
-          </p:cNvPr>
-          <p:cNvSpPr/>
-          <p:nvPr/>
-        </p:nvSpPr>
-        <p:spPr>
-          <a:xfrm>
-            <a:off x="198186" y="93986"/>
+          <p:cNvPr id="1001" name="Title"/>
+          <p:cNvSpPr/>
+          <p:nvPr/>
+        </p:nvSpPr>
+        <p:spPr>
+          <a:xfrm>
+            <a:off x="201168" y="91440"/>
             <a:ext cx="8412480" cy="493776"/>
           </a:xfrm>
           <a:prstGeom prst="rect">
@@ -11853,44 +13737,1409 @@
           <a:ln/>
         </p:spPr>
         <p:txBody>
-          <a:bodyPr wrap="square" lIns="0" tIns="0" rIns="0" bIns="0" rtlCol="0" anchor="ctr"/>
-          <a:lstStyle/>
-          <a:p>
-            <a:pPr marL="0" indent="0">
-              <a:buNone/>
-            </a:pPr>
-            <a:r>
-              <a:rPr lang="en-US" sz="2700" b="1" dirty="0">
-                <a:solidFill>
-                  <a:schemeClr val="tx2">
-                    <a:lumMod val="76000"/>
-                  </a:schemeClr>
-                </a:solidFill>
-                <a:latin typeface="Cambria"/>
-                <a:ea typeface="Cambria"/>
-                <a:cs typeface="Cambria" pitchFamily="34" charset="-120"/>
+          <a:bodyPr wrap="square" rtlCol="0" anchor="ctr">
+            <a:normAutofit/>
+          </a:bodyPr>
+          <a:lstStyle/>
+          <a:p>
+            <a:pPr marL="0" indent="0" algn="l">
+              <a:buNone/>
+            </a:pPr>
+            <a:r>
+              <a:rPr lang="en-US" sz="2700" b="1" kern="0" dirty="0">
+                <a:solidFill>
+                  <a:srgbClr val="003D5B"/>
+                </a:solidFill>
+                <a:latin typeface="Calibri" pitchFamily="34" charset="0"/>
+                <a:ea typeface="Calibri" pitchFamily="34" charset="-122"/>
+                <a:cs typeface="Calibri" pitchFamily="34" charset="-120"/>
               </a:rPr>
               <a:t>Project Insights</a:t>
             </a:r>
-            <a:endParaRPr lang="en-US" sz="2700" dirty="0">
-              <a:solidFill>
-                <a:schemeClr val="tx2">
-                  <a:lumMod val="76000"/>
-                </a:schemeClr>
-              </a:solidFill>
-              <a:latin typeface="Cambria"/>
-              <a:ea typeface="Cambria"/>
-              <a:cs typeface="Calibri"/>
-            </a:endParaRPr>
+          </a:p>
+        </p:txBody>
+      </p:sp>
+      <p:sp>
+        <p:nvSpPr>
+          <p:cNvPr id="1002" name="Subtitle"/>
+          <p:cNvSpPr/>
+          <p:nvPr/>
+        </p:nvSpPr>
+        <p:spPr>
+          <a:xfrm>
+            <a:off x="192024" y="640080"/>
+            <a:ext cx="8412480" cy="310896"/>
+          </a:xfrm>
+          <a:prstGeom prst="rect">
+            <a:avLst/>
+          </a:prstGeom>
+          <a:noFill/>
+          <a:ln/>
+        </p:spPr>
+        <p:txBody>
+          <a:bodyPr wrap="square" rtlCol="0" anchor="ctr">
+            <a:normAutofit/>
+          </a:bodyPr>
+          <a:lstStyle/>
+          <a:p>
+            <a:pPr marL="0" indent="0" algn="l">
+              <a:buNone/>
+            </a:pPr>
+            <a:r>
+              <a:rPr lang="en-US" sz="1400" b="0" kern="0" dirty="0">
+                <a:solidFill>
+                  <a:srgbClr val="009B8A"/>
+                </a:solidFill>
+                <a:latin typeface="Calibri" pitchFamily="34" charset="0"/>
+                <a:ea typeface="Calibri" pitchFamily="34" charset="-122"/>
+                <a:cs typeface="Calibri" pitchFamily="34" charset="-120"/>
+              </a:rPr>
+              <a:t>Project attributes set against the EDRMS activity of the sites that belong to them.</a:t>
+            </a:r>
+          </a:p>
+        </p:txBody>
+      </p:sp>
+      <p:sp>
+        <p:nvSpPr>
+          <p:cNvPr id="1003" name="Rule"/>
+          <p:cNvSpPr/>
+          <p:nvPr/>
+        </p:nvSpPr>
+        <p:spPr>
+          <a:xfrm>
+            <a:off x="411480" y="1097280"/>
+            <a:ext cx="2578608" cy="36576"/>
+          </a:xfrm>
+          <a:prstGeom prst="rect">
+            <a:avLst/>
+          </a:prstGeom>
+          <a:solidFill>
+            <a:srgbClr val="009B8A"/>
+          </a:solidFill>
+          <a:ln/>
+        </p:spPr>
+        <p:txBody>
+          <a:bodyPr/>
+          <a:lstStyle/>
+          <a:p>
+            <a:endParaRPr lang="en-PH" sz="1000"/>
+          </a:p>
+        </p:txBody>
+      </p:sp>
+      <p:sp>
+        <p:nvSpPr>
+          <p:cNvPr id="1004" name="Text"/>
+          <p:cNvSpPr/>
+          <p:nvPr/>
+        </p:nvSpPr>
+        <p:spPr>
+          <a:xfrm>
+            <a:off x="411480" y="1152144"/>
+            <a:ext cx="2578608" cy="210312"/>
+          </a:xfrm>
+          <a:prstGeom prst="rect">
+            <a:avLst/>
+          </a:prstGeom>
+          <a:noFill/>
+          <a:ln/>
+        </p:spPr>
+        <p:txBody>
+          <a:bodyPr wrap="square" rtlCol="0" anchor="ctr">
+            <a:normAutofit/>
+          </a:bodyPr>
+          <a:lstStyle/>
+          <a:p>
+            <a:pPr marL="0" indent="0" algn="l">
+              <a:buNone/>
+            </a:pPr>
+            <a:r>
+              <a:rPr lang="en-US" sz="1200" b="1" kern="0" dirty="0">
+                <a:solidFill>
+                  <a:srgbClr val="003D5B"/>
+                </a:solidFill>
+                <a:latin typeface="Calibri" pitchFamily="34" charset="0"/>
+                <a:ea typeface="Calibri" pitchFamily="34" charset="-122"/>
+                <a:cs typeface="Calibri" pitchFamily="34" charset="-120"/>
+              </a:rPr>
+              <a:t>Activity in project terms</a:t>
+            </a:r>
+          </a:p>
+        </p:txBody>
+      </p:sp>
+      <p:sp>
+        <p:nvSpPr>
+          <p:cNvPr id="1005" name="Text"/>
+          <p:cNvSpPr/>
+          <p:nvPr/>
+        </p:nvSpPr>
+        <p:spPr>
+          <a:xfrm>
+            <a:off x="411480" y="1435607"/>
+            <a:ext cx="2578608" cy="786384"/>
+          </a:xfrm>
+          <a:prstGeom prst="rect">
+            <a:avLst/>
+          </a:prstGeom>
+          <a:noFill/>
+          <a:ln/>
+        </p:spPr>
+        <p:txBody>
+          <a:bodyPr wrap="square" rtlCol="0" anchor="t">
+            <a:normAutofit/>
+          </a:bodyPr>
+          <a:lstStyle/>
+          <a:p>
+            <a:pPr marL="0" indent="0" algn="l">
+              <a:lnSpc>
+                <a:spcPct val="92000"/>
+              </a:lnSpc>
+              <a:buNone/>
+            </a:pPr>
+            <a:r>
+              <a:rPr lang="en-US" sz="1000" b="0" kern="0" dirty="0">
+                <a:solidFill>
+                  <a:srgbClr val="333333"/>
+                </a:solidFill>
+                <a:latin typeface="Calibri" pitchFamily="34" charset="0"/>
+                <a:ea typeface="Calibri" pitchFamily="34" charset="-122"/>
+                <a:cs typeface="Calibri" pitchFamily="34" charset="-120"/>
+              </a:rPr>
+              <a:t>The same EDRMS activity, grouped the way the business thinks — by project rather than by department.</a:t>
+            </a:r>
+          </a:p>
+        </p:txBody>
+      </p:sp>
+      <p:sp>
+        <p:nvSpPr>
+          <p:cNvPr id="1006" name="Rule"/>
+          <p:cNvSpPr/>
+          <p:nvPr/>
+        </p:nvSpPr>
+        <p:spPr>
+          <a:xfrm>
+            <a:off x="3282696" y="1097280"/>
+            <a:ext cx="2578608" cy="36576"/>
+          </a:xfrm>
+          <a:prstGeom prst="rect">
+            <a:avLst/>
+          </a:prstGeom>
+          <a:solidFill>
+            <a:srgbClr val="009B8A"/>
+          </a:solidFill>
+          <a:ln/>
+        </p:spPr>
+        <p:txBody>
+          <a:bodyPr/>
+          <a:lstStyle/>
+          <a:p>
+            <a:endParaRPr lang="en-PH" sz="1000"/>
+          </a:p>
+        </p:txBody>
+      </p:sp>
+      <p:sp>
+        <p:nvSpPr>
+          <p:cNvPr id="1007" name="Text"/>
+          <p:cNvSpPr/>
+          <p:nvPr/>
+        </p:nvSpPr>
+        <p:spPr>
+          <a:xfrm>
+            <a:off x="3282696" y="1152144"/>
+            <a:ext cx="2578608" cy="210312"/>
+          </a:xfrm>
+          <a:prstGeom prst="rect">
+            <a:avLst/>
+          </a:prstGeom>
+          <a:noFill/>
+          <a:ln/>
+        </p:spPr>
+        <p:txBody>
+          <a:bodyPr wrap="square" rtlCol="0" anchor="ctr">
+            <a:normAutofit/>
+          </a:bodyPr>
+          <a:lstStyle/>
+          <a:p>
+            <a:pPr marL="0" indent="0" algn="l">
+              <a:buNone/>
+            </a:pPr>
+            <a:r>
+              <a:rPr lang="en-US" sz="1200" b="1" kern="0" dirty="0">
+                <a:solidFill>
+                  <a:srgbClr val="003D5B"/>
+                </a:solidFill>
+                <a:latin typeface="Calibri" pitchFamily="34" charset="0"/>
+                <a:ea typeface="Calibri" pitchFamily="34" charset="-122"/>
+                <a:cs typeface="Calibri" pitchFamily="34" charset="-120"/>
+              </a:rPr>
+              <a:t>Built and ready</a:t>
+            </a:r>
+          </a:p>
+        </p:txBody>
+      </p:sp>
+      <p:sp>
+        <p:nvSpPr>
+          <p:cNvPr id="1008" name="Text"/>
+          <p:cNvSpPr/>
+          <p:nvPr/>
+        </p:nvSpPr>
+        <p:spPr>
+          <a:xfrm>
+            <a:off x="3282696" y="1435607"/>
+            <a:ext cx="2578608" cy="786384"/>
+          </a:xfrm>
+          <a:prstGeom prst="rect">
+            <a:avLst/>
+          </a:prstGeom>
+          <a:noFill/>
+          <a:ln/>
+        </p:spPr>
+        <p:txBody>
+          <a:bodyPr wrap="square" rtlCol="0" anchor="t">
+            <a:normAutofit/>
+          </a:bodyPr>
+          <a:lstStyle/>
+          <a:p>
+            <a:pPr marL="0" indent="0" algn="l">
+              <a:lnSpc>
+                <a:spcPct val="92000"/>
+              </a:lnSpc>
+              <a:buNone/>
+            </a:pPr>
+            <a:r>
+              <a:rPr lang="en-US" sz="1000" b="0" kern="0" dirty="0">
+                <a:solidFill>
+                  <a:srgbClr val="333333"/>
+                </a:solidFill>
+                <a:latin typeface="Calibri" pitchFamily="34" charset="0"/>
+                <a:ea typeface="Calibri" pitchFamily="34" charset="-122"/>
+                <a:cs typeface="Calibri" pitchFamily="34" charset="-120"/>
+              </a:rPr>
+              <a:t>Every field and tile on this page is built in the prototype. You can see exactly how it will look and behave.</a:t>
+            </a:r>
+          </a:p>
+        </p:txBody>
+      </p:sp>
+      <p:sp>
+        <p:nvSpPr>
+          <p:cNvPr id="1009" name="Rule"/>
+          <p:cNvSpPr/>
+          <p:nvPr/>
+        </p:nvSpPr>
+        <p:spPr>
+          <a:xfrm>
+            <a:off x="6153912" y="1097280"/>
+            <a:ext cx="2578608" cy="36576"/>
+          </a:xfrm>
+          <a:prstGeom prst="rect">
+            <a:avLst/>
+          </a:prstGeom>
+          <a:solidFill>
+            <a:srgbClr val="009B8A"/>
+          </a:solidFill>
+          <a:ln/>
+        </p:spPr>
+        <p:txBody>
+          <a:bodyPr/>
+          <a:lstStyle/>
+          <a:p>
+            <a:endParaRPr lang="en-PH" sz="1000"/>
+          </a:p>
+        </p:txBody>
+      </p:sp>
+      <p:sp>
+        <p:nvSpPr>
+          <p:cNvPr id="1010" name="Text"/>
+          <p:cNvSpPr/>
+          <p:nvPr/>
+        </p:nvSpPr>
+        <p:spPr>
+          <a:xfrm>
+            <a:off x="6153912" y="1152144"/>
+            <a:ext cx="2578608" cy="210312"/>
+          </a:xfrm>
+          <a:prstGeom prst="rect">
+            <a:avLst/>
+          </a:prstGeom>
+          <a:noFill/>
+          <a:ln/>
+        </p:spPr>
+        <p:txBody>
+          <a:bodyPr wrap="square" rtlCol="0" anchor="ctr">
+            <a:normAutofit/>
+          </a:bodyPr>
+          <a:lstStyle/>
+          <a:p>
+            <a:pPr marL="0" indent="0" algn="l">
+              <a:buNone/>
+            </a:pPr>
+            <a:r>
+              <a:rPr lang="en-US" sz="1200" b="1" kern="0" dirty="0">
+                <a:solidFill>
+                  <a:srgbClr val="003D5B"/>
+                </a:solidFill>
+                <a:latin typeface="Calibri" pitchFamily="34" charset="0"/>
+                <a:ea typeface="Calibri" pitchFamily="34" charset="-122"/>
+                <a:cs typeface="Calibri" pitchFamily="34" charset="-120"/>
+              </a:rPr>
+              <a:t>Waiting on a source</a:t>
+            </a:r>
+          </a:p>
+        </p:txBody>
+      </p:sp>
+      <p:sp>
+        <p:nvSpPr>
+          <p:cNvPr id="1011" name="Text"/>
+          <p:cNvSpPr/>
+          <p:nvPr/>
+        </p:nvSpPr>
+        <p:spPr>
+          <a:xfrm>
+            <a:off x="6153912" y="1435607"/>
+            <a:ext cx="2578608" cy="786384"/>
+          </a:xfrm>
+          <a:prstGeom prst="rect">
+            <a:avLst/>
+          </a:prstGeom>
+          <a:noFill/>
+          <a:ln/>
+        </p:spPr>
+        <p:txBody>
+          <a:bodyPr wrap="square" rtlCol="0" anchor="t">
+            <a:normAutofit/>
+          </a:bodyPr>
+          <a:lstStyle/>
+          <a:p>
+            <a:pPr marL="0" indent="0" algn="l">
+              <a:lnSpc>
+                <a:spcPct val="92000"/>
+              </a:lnSpc>
+              <a:buNone/>
+            </a:pPr>
+            <a:r>
+              <a:rPr lang="en-US" sz="1000" b="0" kern="0" dirty="0">
+                <a:solidFill>
+                  <a:srgbClr val="333333"/>
+                </a:solidFill>
+                <a:latin typeface="Calibri" pitchFamily="34" charset="0"/>
+                <a:ea typeface="Calibri" pitchFamily="34" charset="-122"/>
+                <a:cs typeface="Calibri" pitchFamily="34" charset="-120"/>
+              </a:rPr>
+              <a:t>What it does not yet have is a confirmed system to read project attributes from. That is the whole of the ask.</a:t>
+            </a:r>
+          </a:p>
+        </p:txBody>
+      </p:sp>
+      <p:sp>
+        <p:nvSpPr>
+          <p:cNvPr id="1012" name="Text"/>
+          <p:cNvSpPr/>
+          <p:nvPr/>
+        </p:nvSpPr>
+        <p:spPr>
+          <a:xfrm>
+            <a:off x="411480" y="2231136"/>
+            <a:ext cx="4572000" cy="201168"/>
+          </a:xfrm>
+          <a:prstGeom prst="rect">
+            <a:avLst/>
+          </a:prstGeom>
+          <a:noFill/>
+          <a:ln/>
+        </p:spPr>
+        <p:txBody>
+          <a:bodyPr wrap="square" rtlCol="0" anchor="ctr">
+            <a:normAutofit/>
+          </a:bodyPr>
+          <a:lstStyle/>
+          <a:p>
+            <a:pPr marL="0" indent="0" algn="l">
+              <a:buNone/>
+            </a:pPr>
+            <a:r>
+              <a:rPr lang="en-US" sz="1200" b="1" kern="0" spc="105" dirty="0">
+                <a:solidFill>
+                  <a:srgbClr val="003D5B"/>
+                </a:solidFill>
+                <a:latin typeface="Calibri" pitchFamily="34" charset="0"/>
+                <a:ea typeface="Calibri" pitchFamily="34" charset="-122"/>
+                <a:cs typeface="Calibri" pitchFamily="34" charset="-120"/>
+              </a:rPr>
+              <a:t>WHAT YOU WILL SEE ON THE PAGE</a:t>
+            </a:r>
+          </a:p>
+        </p:txBody>
+      </p:sp>
+      <p:sp>
+        <p:nvSpPr>
+          <p:cNvPr id="1013" name="Panel"/>
+          <p:cNvSpPr/>
+          <p:nvPr/>
+        </p:nvSpPr>
+        <p:spPr>
+          <a:xfrm>
+            <a:off x="411480" y="2487168"/>
+            <a:ext cx="8321040" cy="2084831"/>
+          </a:xfrm>
+          <a:prstGeom prst="rect">
+            <a:avLst/>
+          </a:prstGeom>
+          <a:solidFill>
+            <a:srgbClr val="F4F7F8"/>
+          </a:solidFill>
+          <a:ln w="12700">
+            <a:solidFill>
+              <a:srgbClr val="D8DEE1"/>
+            </a:solidFill>
+            <a:prstDash val="solid"/>
+          </a:ln>
+        </p:spPr>
+        <p:txBody>
+          <a:bodyPr/>
+          <a:lstStyle/>
+          <a:p>
+            <a:endParaRPr lang="en-PH" sz="1000"/>
+          </a:p>
+        </p:txBody>
+      </p:sp>
+      <p:sp>
+        <p:nvSpPr>
+          <p:cNvPr id="1014" name="Rule"/>
+          <p:cNvSpPr/>
+          <p:nvPr/>
+        </p:nvSpPr>
+        <p:spPr>
+          <a:xfrm>
+            <a:off x="612648" y="2688336"/>
+            <a:ext cx="1655063" cy="32004"/>
+          </a:xfrm>
+          <a:prstGeom prst="rect">
+            <a:avLst/>
+          </a:prstGeom>
+          <a:solidFill>
+            <a:srgbClr val="009B8A"/>
+          </a:solidFill>
+          <a:ln/>
+        </p:spPr>
+        <p:txBody>
+          <a:bodyPr/>
+          <a:lstStyle/>
+          <a:p>
+            <a:endParaRPr lang="en-PH" sz="1000"/>
+          </a:p>
+        </p:txBody>
+      </p:sp>
+      <p:sp>
+        <p:nvSpPr>
+          <p:cNvPr id="1015" name="Text"/>
+          <p:cNvSpPr/>
+          <p:nvPr/>
+        </p:nvSpPr>
+        <p:spPr>
+          <a:xfrm>
+            <a:off x="612648" y="2761488"/>
+            <a:ext cx="1655063" cy="219456"/>
+          </a:xfrm>
+          <a:prstGeom prst="rect">
+            <a:avLst/>
+          </a:prstGeom>
+          <a:noFill/>
+          <a:ln/>
+        </p:spPr>
+        <p:txBody>
+          <a:bodyPr wrap="square" rtlCol="0" anchor="ctr">
+            <a:normAutofit/>
+          </a:bodyPr>
+          <a:lstStyle/>
+          <a:p>
+            <a:pPr marL="0" indent="0" algn="l">
+              <a:buNone/>
+            </a:pPr>
+            <a:r>
+              <a:rPr lang="en-US" sz="1050" b="1" kern="0" dirty="0">
+                <a:solidFill>
+                  <a:srgbClr val="003D5B"/>
+                </a:solidFill>
+                <a:latin typeface="Calibri" pitchFamily="34" charset="0"/>
+                <a:ea typeface="Calibri" pitchFamily="34" charset="-122"/>
+                <a:cs typeface="Calibri" pitchFamily="34" charset="-120"/>
+              </a:rPr>
+              <a:t>Project profile</a:t>
+            </a:r>
+          </a:p>
+        </p:txBody>
+      </p:sp>
+      <p:sp>
+        <p:nvSpPr>
+          <p:cNvPr id="1016" name="Bullet"/>
+          <p:cNvSpPr/>
+          <p:nvPr/>
+        </p:nvSpPr>
+        <p:spPr>
+          <a:xfrm>
+            <a:off x="612648" y="3118103"/>
+            <a:ext cx="50292" cy="50292"/>
+          </a:xfrm>
+          <a:prstGeom prst="rect">
+            <a:avLst/>
+          </a:prstGeom>
+          <a:solidFill>
+            <a:srgbClr val="009B8A"/>
+          </a:solidFill>
+          <a:ln/>
+        </p:spPr>
+        <p:txBody>
+          <a:bodyPr/>
+          <a:lstStyle/>
+          <a:p>
+            <a:endParaRPr lang="en-PH" sz="1000"/>
+          </a:p>
+        </p:txBody>
+      </p:sp>
+      <p:sp>
+        <p:nvSpPr>
+          <p:cNvPr id="1017" name="Text"/>
+          <p:cNvSpPr/>
+          <p:nvPr/>
+        </p:nvSpPr>
+        <p:spPr>
+          <a:xfrm>
+            <a:off x="758952" y="3054096"/>
+            <a:ext cx="1545336" cy="201168"/>
+          </a:xfrm>
+          <a:prstGeom prst="rect">
+            <a:avLst/>
+          </a:prstGeom>
+          <a:noFill/>
+          <a:ln/>
+        </p:spPr>
+        <p:txBody>
+          <a:bodyPr wrap="square" rtlCol="0" anchor="ctr">
+            <a:normAutofit/>
+          </a:bodyPr>
+          <a:lstStyle/>
+          <a:p>
+            <a:pPr marL="0" indent="0" algn="l">
+              <a:buNone/>
+            </a:pPr>
+            <a:r>
+              <a:rPr lang="en-US" sz="900" b="0" kern="0" dirty="0">
+                <a:solidFill>
+                  <a:srgbClr val="333333"/>
+                </a:solidFill>
+                <a:latin typeface="Calibri" pitchFamily="34" charset="0"/>
+                <a:ea typeface="Calibri" pitchFamily="34" charset="-122"/>
+                <a:cs typeface="Calibri" pitchFamily="34" charset="-120"/>
+              </a:rPr>
+              <a:t>Facility type</a:t>
+            </a:r>
+          </a:p>
+        </p:txBody>
+      </p:sp>
+      <p:sp>
+        <p:nvSpPr>
+          <p:cNvPr id="1018" name="Bullet"/>
+          <p:cNvSpPr/>
+          <p:nvPr/>
+        </p:nvSpPr>
+        <p:spPr>
+          <a:xfrm>
+            <a:off x="612648" y="3392423"/>
+            <a:ext cx="50292" cy="50292"/>
+          </a:xfrm>
+          <a:prstGeom prst="rect">
+            <a:avLst/>
+          </a:prstGeom>
+          <a:solidFill>
+            <a:srgbClr val="009B8A"/>
+          </a:solidFill>
+          <a:ln/>
+        </p:spPr>
+        <p:txBody>
+          <a:bodyPr/>
+          <a:lstStyle/>
+          <a:p>
+            <a:endParaRPr lang="en-PH" sz="1000"/>
+          </a:p>
+        </p:txBody>
+      </p:sp>
+      <p:sp>
+        <p:nvSpPr>
+          <p:cNvPr id="1019" name="Text"/>
+          <p:cNvSpPr/>
+          <p:nvPr/>
+        </p:nvSpPr>
+        <p:spPr>
+          <a:xfrm>
+            <a:off x="758952" y="3328415"/>
+            <a:ext cx="1545336" cy="201168"/>
+          </a:xfrm>
+          <a:prstGeom prst="rect">
+            <a:avLst/>
+          </a:prstGeom>
+          <a:noFill/>
+          <a:ln/>
+        </p:spPr>
+        <p:txBody>
+          <a:bodyPr wrap="square" rtlCol="0" anchor="ctr">
+            <a:normAutofit/>
+          </a:bodyPr>
+          <a:lstStyle/>
+          <a:p>
+            <a:pPr marL="0" indent="0" algn="l">
+              <a:buNone/>
+            </a:pPr>
+            <a:r>
+              <a:rPr lang="en-US" sz="900" b="0" kern="0" dirty="0">
+                <a:solidFill>
+                  <a:srgbClr val="333333"/>
+                </a:solidFill>
+                <a:latin typeface="Calibri" pitchFamily="34" charset="0"/>
+                <a:ea typeface="Calibri" pitchFamily="34" charset="-122"/>
+                <a:cs typeface="Calibri" pitchFamily="34" charset="-120"/>
+              </a:rPr>
+              <a:t>Modality</a:t>
+            </a:r>
+          </a:p>
+        </p:txBody>
+      </p:sp>
+      <p:sp>
+        <p:nvSpPr>
+          <p:cNvPr id="1020" name="Bullet"/>
+          <p:cNvSpPr/>
+          <p:nvPr/>
+        </p:nvSpPr>
+        <p:spPr>
+          <a:xfrm>
+            <a:off x="612648" y="3666744"/>
+            <a:ext cx="50292" cy="50292"/>
+          </a:xfrm>
+          <a:prstGeom prst="rect">
+            <a:avLst/>
+          </a:prstGeom>
+          <a:solidFill>
+            <a:srgbClr val="009B8A"/>
+          </a:solidFill>
+          <a:ln/>
+        </p:spPr>
+        <p:txBody>
+          <a:bodyPr/>
+          <a:lstStyle/>
+          <a:p>
+            <a:endParaRPr lang="en-PH" sz="1000"/>
+          </a:p>
+        </p:txBody>
+      </p:sp>
+      <p:sp>
+        <p:nvSpPr>
+          <p:cNvPr id="1021" name="Text"/>
+          <p:cNvSpPr/>
+          <p:nvPr/>
+        </p:nvSpPr>
+        <p:spPr>
+          <a:xfrm>
+            <a:off x="758952" y="3602735"/>
+            <a:ext cx="1545336" cy="201168"/>
+          </a:xfrm>
+          <a:prstGeom prst="rect">
+            <a:avLst/>
+          </a:prstGeom>
+          <a:noFill/>
+          <a:ln/>
+        </p:spPr>
+        <p:txBody>
+          <a:bodyPr wrap="square" rtlCol="0" anchor="ctr">
+            <a:normAutofit/>
+          </a:bodyPr>
+          <a:lstStyle/>
+          <a:p>
+            <a:pPr marL="0" indent="0" algn="l">
+              <a:buNone/>
+            </a:pPr>
+            <a:r>
+              <a:rPr lang="en-US" sz="900" b="0" kern="0" dirty="0">
+                <a:solidFill>
+                  <a:srgbClr val="333333"/>
+                </a:solidFill>
+                <a:latin typeface="Calibri" pitchFamily="34" charset="0"/>
+                <a:ea typeface="Calibri" pitchFamily="34" charset="-122"/>
+                <a:cs typeface="Calibri" pitchFamily="34" charset="-120"/>
+              </a:rPr>
+              <a:t>Country</a:t>
+            </a:r>
+          </a:p>
+        </p:txBody>
+      </p:sp>
+      <p:sp>
+        <p:nvSpPr>
+          <p:cNvPr id="1022" name="Rule"/>
+          <p:cNvSpPr/>
+          <p:nvPr/>
+        </p:nvSpPr>
+        <p:spPr>
+          <a:xfrm>
+            <a:off x="2578608" y="2688336"/>
+            <a:ext cx="1655063" cy="32004"/>
+          </a:xfrm>
+          <a:prstGeom prst="rect">
+            <a:avLst/>
+          </a:prstGeom>
+          <a:solidFill>
+            <a:srgbClr val="009B8A"/>
+          </a:solidFill>
+          <a:ln/>
+        </p:spPr>
+        <p:txBody>
+          <a:bodyPr/>
+          <a:lstStyle/>
+          <a:p>
+            <a:endParaRPr lang="en-PH" sz="1000"/>
+          </a:p>
+        </p:txBody>
+      </p:sp>
+      <p:sp>
+        <p:nvSpPr>
+          <p:cNvPr id="1023" name="Text"/>
+          <p:cNvSpPr/>
+          <p:nvPr/>
+        </p:nvSpPr>
+        <p:spPr>
+          <a:xfrm>
+            <a:off x="2578608" y="2761488"/>
+            <a:ext cx="1655063" cy="219456"/>
+          </a:xfrm>
+          <a:prstGeom prst="rect">
+            <a:avLst/>
+          </a:prstGeom>
+          <a:noFill/>
+          <a:ln/>
+        </p:spPr>
+        <p:txBody>
+          <a:bodyPr wrap="square" rtlCol="0" anchor="ctr">
+            <a:normAutofit/>
+          </a:bodyPr>
+          <a:lstStyle/>
+          <a:p>
+            <a:pPr marL="0" indent="0" algn="l">
+              <a:buNone/>
+            </a:pPr>
+            <a:r>
+              <a:rPr lang="en-US" sz="1050" b="1" kern="0" dirty="0">
+                <a:solidFill>
+                  <a:srgbClr val="003D5B"/>
+                </a:solidFill>
+                <a:latin typeface="Calibri" pitchFamily="34" charset="0"/>
+                <a:ea typeface="Calibri" pitchFamily="34" charset="-122"/>
+                <a:cs typeface="Calibri" pitchFamily="34" charset="-120"/>
+              </a:rPr>
+              <a:t>Project status</a:t>
+            </a:r>
+          </a:p>
+        </p:txBody>
+      </p:sp>
+      <p:sp>
+        <p:nvSpPr>
+          <p:cNvPr id="1024" name="Bullet"/>
+          <p:cNvSpPr/>
+          <p:nvPr/>
+        </p:nvSpPr>
+        <p:spPr>
+          <a:xfrm>
+            <a:off x="2578608" y="3118103"/>
+            <a:ext cx="50292" cy="50292"/>
+          </a:xfrm>
+          <a:prstGeom prst="rect">
+            <a:avLst/>
+          </a:prstGeom>
+          <a:solidFill>
+            <a:srgbClr val="009B8A"/>
+          </a:solidFill>
+          <a:ln/>
+        </p:spPr>
+        <p:txBody>
+          <a:bodyPr/>
+          <a:lstStyle/>
+          <a:p>
+            <a:endParaRPr lang="en-PH" sz="1000"/>
+          </a:p>
+        </p:txBody>
+      </p:sp>
+      <p:sp>
+        <p:nvSpPr>
+          <p:cNvPr id="1025" name="Text"/>
+          <p:cNvSpPr/>
+          <p:nvPr/>
+        </p:nvSpPr>
+        <p:spPr>
+          <a:xfrm>
+            <a:off x="2724912" y="3054096"/>
+            <a:ext cx="1545336" cy="201168"/>
+          </a:xfrm>
+          <a:prstGeom prst="rect">
+            <a:avLst/>
+          </a:prstGeom>
+          <a:noFill/>
+          <a:ln/>
+        </p:spPr>
+        <p:txBody>
+          <a:bodyPr wrap="square" rtlCol="0" anchor="ctr">
+            <a:normAutofit/>
+          </a:bodyPr>
+          <a:lstStyle/>
+          <a:p>
+            <a:pPr marL="0" indent="0" algn="l">
+              <a:buNone/>
+            </a:pPr>
+            <a:r>
+              <a:rPr lang="en-US" sz="900" b="0" kern="0" dirty="0">
+                <a:solidFill>
+                  <a:srgbClr val="333333"/>
+                </a:solidFill>
+                <a:latin typeface="Calibri" pitchFamily="34" charset="0"/>
+                <a:ea typeface="Calibri" pitchFamily="34" charset="-122"/>
+                <a:cs typeface="Calibri" pitchFamily="34" charset="-120"/>
+              </a:rPr>
+              <a:t>Status</a:t>
+            </a:r>
+          </a:p>
+        </p:txBody>
+      </p:sp>
+      <p:sp>
+        <p:nvSpPr>
+          <p:cNvPr id="1026" name="Bullet"/>
+          <p:cNvSpPr/>
+          <p:nvPr/>
+        </p:nvSpPr>
+        <p:spPr>
+          <a:xfrm>
+            <a:off x="2578608" y="3392423"/>
+            <a:ext cx="50292" cy="50292"/>
+          </a:xfrm>
+          <a:prstGeom prst="rect">
+            <a:avLst/>
+          </a:prstGeom>
+          <a:solidFill>
+            <a:srgbClr val="009B8A"/>
+          </a:solidFill>
+          <a:ln/>
+        </p:spPr>
+        <p:txBody>
+          <a:bodyPr/>
+          <a:lstStyle/>
+          <a:p>
+            <a:endParaRPr lang="en-PH" sz="1000"/>
+          </a:p>
+        </p:txBody>
+      </p:sp>
+      <p:sp>
+        <p:nvSpPr>
+          <p:cNvPr id="1027" name="Text"/>
+          <p:cNvSpPr/>
+          <p:nvPr/>
+        </p:nvSpPr>
+        <p:spPr>
+          <a:xfrm>
+            <a:off x="2724912" y="3328415"/>
+            <a:ext cx="1545336" cy="201168"/>
+          </a:xfrm>
+          <a:prstGeom prst="rect">
+            <a:avLst/>
+          </a:prstGeom>
+          <a:noFill/>
+          <a:ln/>
+        </p:spPr>
+        <p:txBody>
+          <a:bodyPr wrap="square" rtlCol="0" anchor="ctr">
+            <a:normAutofit/>
+          </a:bodyPr>
+          <a:lstStyle/>
+          <a:p>
+            <a:pPr marL="0" indent="0" algn="l">
+              <a:buNone/>
+            </a:pPr>
+            <a:r>
+              <a:rPr lang="en-US" sz="900" b="0" kern="0" dirty="0">
+                <a:solidFill>
+                  <a:srgbClr val="333333"/>
+                </a:solidFill>
+                <a:latin typeface="Calibri" pitchFamily="34" charset="0"/>
+                <a:ea typeface="Calibri" pitchFamily="34" charset="-122"/>
+                <a:cs typeface="Calibri" pitchFamily="34" charset="-120"/>
+              </a:rPr>
+              <a:t>Effectivity date</a:t>
+            </a:r>
+          </a:p>
+        </p:txBody>
+      </p:sp>
+      <p:sp>
+        <p:nvSpPr>
+          <p:cNvPr id="1028" name="Bullet"/>
+          <p:cNvSpPr/>
+          <p:nvPr/>
+        </p:nvSpPr>
+        <p:spPr>
+          <a:xfrm>
+            <a:off x="2578608" y="3666744"/>
+            <a:ext cx="50292" cy="50292"/>
+          </a:xfrm>
+          <a:prstGeom prst="rect">
+            <a:avLst/>
+          </a:prstGeom>
+          <a:solidFill>
+            <a:srgbClr val="009B8A"/>
+          </a:solidFill>
+          <a:ln/>
+        </p:spPr>
+        <p:txBody>
+          <a:bodyPr/>
+          <a:lstStyle/>
+          <a:p>
+            <a:endParaRPr lang="en-PH" sz="1000"/>
+          </a:p>
+        </p:txBody>
+      </p:sp>
+      <p:sp>
+        <p:nvSpPr>
+          <p:cNvPr id="1029" name="Text"/>
+          <p:cNvSpPr/>
+          <p:nvPr/>
+        </p:nvSpPr>
+        <p:spPr>
+          <a:xfrm>
+            <a:off x="2724912" y="3602735"/>
+            <a:ext cx="1545336" cy="201168"/>
+          </a:xfrm>
+          <a:prstGeom prst="rect">
+            <a:avLst/>
+          </a:prstGeom>
+          <a:noFill/>
+          <a:ln/>
+        </p:spPr>
+        <p:txBody>
+          <a:bodyPr wrap="square" rtlCol="0" anchor="ctr">
+            <a:normAutofit/>
+          </a:bodyPr>
+          <a:lstStyle/>
+          <a:p>
+            <a:pPr marL="0" indent="0" algn="l">
+              <a:buNone/>
+            </a:pPr>
+            <a:r>
+              <a:rPr lang="en-US" sz="900" b="0" kern="0" dirty="0">
+                <a:solidFill>
+                  <a:srgbClr val="333333"/>
+                </a:solidFill>
+                <a:latin typeface="Calibri" pitchFamily="34" charset="0"/>
+                <a:ea typeface="Calibri" pitchFamily="34" charset="-122"/>
+                <a:cs typeface="Calibri" pitchFamily="34" charset="-120"/>
+              </a:rPr>
+              <a:t>Closing date</a:t>
+            </a:r>
+          </a:p>
+        </p:txBody>
+      </p:sp>
+      <p:sp>
+        <p:nvSpPr>
+          <p:cNvPr id="1030" name="Rule"/>
+          <p:cNvSpPr/>
+          <p:nvPr/>
+        </p:nvSpPr>
+        <p:spPr>
+          <a:xfrm>
+            <a:off x="4544568" y="2688336"/>
+            <a:ext cx="1655063" cy="32004"/>
+          </a:xfrm>
+          <a:prstGeom prst="rect">
+            <a:avLst/>
+          </a:prstGeom>
+          <a:solidFill>
+            <a:srgbClr val="009B8A"/>
+          </a:solidFill>
+          <a:ln/>
+        </p:spPr>
+        <p:txBody>
+          <a:bodyPr/>
+          <a:lstStyle/>
+          <a:p>
+            <a:endParaRPr lang="en-PH" sz="1000"/>
+          </a:p>
+        </p:txBody>
+      </p:sp>
+      <p:sp>
+        <p:nvSpPr>
+          <p:cNvPr id="1031" name="Text"/>
+          <p:cNvSpPr/>
+          <p:nvPr/>
+        </p:nvSpPr>
+        <p:spPr>
+          <a:xfrm>
+            <a:off x="4544568" y="2761488"/>
+            <a:ext cx="1655063" cy="219456"/>
+          </a:xfrm>
+          <a:prstGeom prst="rect">
+            <a:avLst/>
+          </a:prstGeom>
+          <a:noFill/>
+          <a:ln/>
+        </p:spPr>
+        <p:txBody>
+          <a:bodyPr wrap="square" rtlCol="0" anchor="ctr">
+            <a:normAutofit/>
+          </a:bodyPr>
+          <a:lstStyle/>
+          <a:p>
+            <a:pPr marL="0" indent="0" algn="l">
+              <a:buNone/>
+            </a:pPr>
+            <a:r>
+              <a:rPr lang="en-US" sz="1050" b="1" kern="0" dirty="0">
+                <a:solidFill>
+                  <a:srgbClr val="003D5B"/>
+                </a:solidFill>
+                <a:latin typeface="Calibri" pitchFamily="34" charset="0"/>
+                <a:ea typeface="Calibri" pitchFamily="34" charset="-122"/>
+                <a:cs typeface="Calibri" pitchFamily="34" charset="-120"/>
+              </a:rPr>
+              <a:t>Linked activity</a:t>
+            </a:r>
+          </a:p>
+        </p:txBody>
+      </p:sp>
+      <p:sp>
+        <p:nvSpPr>
+          <p:cNvPr id="1032" name="Bullet"/>
+          <p:cNvSpPr/>
+          <p:nvPr/>
+        </p:nvSpPr>
+        <p:spPr>
+          <a:xfrm>
+            <a:off x="4544568" y="3118103"/>
+            <a:ext cx="50292" cy="50292"/>
+          </a:xfrm>
+          <a:prstGeom prst="rect">
+            <a:avLst/>
+          </a:prstGeom>
+          <a:solidFill>
+            <a:srgbClr val="009B8A"/>
+          </a:solidFill>
+          <a:ln/>
+        </p:spPr>
+        <p:txBody>
+          <a:bodyPr/>
+          <a:lstStyle/>
+          <a:p>
+            <a:endParaRPr lang="en-PH" sz="1000"/>
+          </a:p>
+        </p:txBody>
+      </p:sp>
+      <p:sp>
+        <p:nvSpPr>
+          <p:cNvPr id="1033" name="Text"/>
+          <p:cNvSpPr/>
+          <p:nvPr/>
+        </p:nvSpPr>
+        <p:spPr>
+          <a:xfrm>
+            <a:off x="4690872" y="3054096"/>
+            <a:ext cx="1545336" cy="201168"/>
+          </a:xfrm>
+          <a:prstGeom prst="rect">
+            <a:avLst/>
+          </a:prstGeom>
+          <a:noFill/>
+          <a:ln/>
+        </p:spPr>
+        <p:txBody>
+          <a:bodyPr wrap="square" rtlCol="0" anchor="ctr">
+            <a:normAutofit/>
+          </a:bodyPr>
+          <a:lstStyle/>
+          <a:p>
+            <a:pPr marL="0" indent="0" algn="l">
+              <a:buNone/>
+            </a:pPr>
+            <a:r>
+              <a:rPr lang="en-US" sz="900" b="0" kern="0" dirty="0">
+                <a:solidFill>
+                  <a:srgbClr val="333333"/>
+                </a:solidFill>
+                <a:latin typeface="Calibri" pitchFamily="34" charset="0"/>
+                <a:ea typeface="Calibri" pitchFamily="34" charset="-122"/>
+                <a:cs typeface="Calibri" pitchFamily="34" charset="-120"/>
+              </a:rPr>
+              <a:t>Records declared for this project</a:t>
+            </a:r>
+          </a:p>
+        </p:txBody>
+      </p:sp>
+      <p:sp>
+        <p:nvSpPr>
+          <p:cNvPr id="1034" name="Bullet"/>
+          <p:cNvSpPr/>
+          <p:nvPr/>
+        </p:nvSpPr>
+        <p:spPr>
+          <a:xfrm>
+            <a:off x="4544568" y="3392423"/>
+            <a:ext cx="50292" cy="50292"/>
+          </a:xfrm>
+          <a:prstGeom prst="rect">
+            <a:avLst/>
+          </a:prstGeom>
+          <a:solidFill>
+            <a:srgbClr val="009B8A"/>
+          </a:solidFill>
+          <a:ln/>
+        </p:spPr>
+        <p:txBody>
+          <a:bodyPr/>
+          <a:lstStyle/>
+          <a:p>
+            <a:endParaRPr lang="en-PH" sz="1000"/>
+          </a:p>
+        </p:txBody>
+      </p:sp>
+      <p:sp>
+        <p:nvSpPr>
+          <p:cNvPr id="1035" name="Text"/>
+          <p:cNvSpPr/>
+          <p:nvPr/>
+        </p:nvSpPr>
+        <p:spPr>
+          <a:xfrm>
+            <a:off x="4690872" y="3328415"/>
+            <a:ext cx="1545336" cy="201168"/>
+          </a:xfrm>
+          <a:prstGeom prst="rect">
+            <a:avLst/>
+          </a:prstGeom>
+          <a:noFill/>
+          <a:ln/>
+        </p:spPr>
+        <p:txBody>
+          <a:bodyPr wrap="square" rtlCol="0" anchor="ctr">
+            <a:normAutofit/>
+          </a:bodyPr>
+          <a:lstStyle/>
+          <a:p>
+            <a:pPr marL="0" indent="0" algn="l">
+              <a:buNone/>
+            </a:pPr>
+            <a:r>
+              <a:rPr lang="en-US" sz="900" b="0" kern="0" dirty="0">
+                <a:solidFill>
+                  <a:srgbClr val="333333"/>
+                </a:solidFill>
+                <a:latin typeface="Calibri" pitchFamily="34" charset="0"/>
+                <a:ea typeface="Calibri" pitchFamily="34" charset="-122"/>
+                <a:cs typeface="Calibri" pitchFamily="34" charset="-120"/>
+              </a:rPr>
+              <a:t>Sites belonging to the project</a:t>
+            </a:r>
+          </a:p>
+        </p:txBody>
+      </p:sp>
+      <p:sp>
+        <p:nvSpPr>
+          <p:cNvPr id="1036" name="Rule"/>
+          <p:cNvSpPr/>
+          <p:nvPr/>
+        </p:nvSpPr>
+        <p:spPr>
+          <a:xfrm>
+            <a:off x="6510527" y="2688336"/>
+            <a:ext cx="1655063" cy="32004"/>
+          </a:xfrm>
+          <a:prstGeom prst="rect">
+            <a:avLst/>
+          </a:prstGeom>
+          <a:solidFill>
+            <a:srgbClr val="009B8A"/>
+          </a:solidFill>
+          <a:ln/>
+        </p:spPr>
+        <p:txBody>
+          <a:bodyPr/>
+          <a:lstStyle/>
+          <a:p>
+            <a:endParaRPr lang="en-PH" sz="1000"/>
+          </a:p>
+        </p:txBody>
+      </p:sp>
+      <p:sp>
+        <p:nvSpPr>
+          <p:cNvPr id="1037" name="Text"/>
+          <p:cNvSpPr/>
+          <p:nvPr/>
+        </p:nvSpPr>
+        <p:spPr>
+          <a:xfrm>
+            <a:off x="6510527" y="2761488"/>
+            <a:ext cx="1655063" cy="219456"/>
+          </a:xfrm>
+          <a:prstGeom prst="rect">
+            <a:avLst/>
+          </a:prstGeom>
+          <a:noFill/>
+          <a:ln/>
+        </p:spPr>
+        <p:txBody>
+          <a:bodyPr wrap="square" rtlCol="0" anchor="ctr">
+            <a:normAutofit/>
+          </a:bodyPr>
+          <a:lstStyle/>
+          <a:p>
+            <a:pPr marL="0" indent="0" algn="l">
+              <a:buNone/>
+            </a:pPr>
+            <a:r>
+              <a:rPr lang="en-US" sz="1050" b="1" kern="0" dirty="0">
+                <a:solidFill>
+                  <a:srgbClr val="003D5B"/>
+                </a:solidFill>
+                <a:latin typeface="Calibri" pitchFamily="34" charset="0"/>
+                <a:ea typeface="Calibri" pitchFamily="34" charset="-122"/>
+                <a:cs typeface="Calibri" pitchFamily="34" charset="-120"/>
+              </a:rPr>
+              <a:t>Drill-through</a:t>
+            </a:r>
+          </a:p>
+        </p:txBody>
+      </p:sp>
+      <p:sp>
+        <p:nvSpPr>
+          <p:cNvPr id="1038" name="Bullet"/>
+          <p:cNvSpPr/>
+          <p:nvPr/>
+        </p:nvSpPr>
+        <p:spPr>
+          <a:xfrm>
+            <a:off x="6510527" y="3118103"/>
+            <a:ext cx="50292" cy="50292"/>
+          </a:xfrm>
+          <a:prstGeom prst="rect">
+            <a:avLst/>
+          </a:prstGeom>
+          <a:solidFill>
+            <a:srgbClr val="009B8A"/>
+          </a:solidFill>
+          <a:ln/>
+        </p:spPr>
+        <p:txBody>
+          <a:bodyPr/>
+          <a:lstStyle/>
+          <a:p>
+            <a:endParaRPr lang="en-PH" sz="1000"/>
+          </a:p>
+        </p:txBody>
+      </p:sp>
+      <p:sp>
+        <p:nvSpPr>
+          <p:cNvPr id="1039" name="Text"/>
+          <p:cNvSpPr/>
+          <p:nvPr/>
+        </p:nvSpPr>
+        <p:spPr>
+          <a:xfrm>
+            <a:off x="6656831" y="3054096"/>
+            <a:ext cx="1545336" cy="201168"/>
+          </a:xfrm>
+          <a:prstGeom prst="rect">
+            <a:avLst/>
+          </a:prstGeom>
+          <a:noFill/>
+          <a:ln/>
+        </p:spPr>
+        <p:txBody>
+          <a:bodyPr wrap="square" rtlCol="0" anchor="ctr">
+            <a:normAutofit/>
+          </a:bodyPr>
+          <a:lstStyle/>
+          <a:p>
+            <a:pPr marL="0" indent="0" algn="l">
+              <a:buNone/>
+            </a:pPr>
+            <a:r>
+              <a:rPr lang="en-US" sz="900" b="0" kern="0" dirty="0">
+                <a:solidFill>
+                  <a:srgbClr val="333333"/>
+                </a:solidFill>
+                <a:latin typeface="Calibri" pitchFamily="34" charset="0"/>
+                <a:ea typeface="Calibri" pitchFamily="34" charset="-122"/>
+                <a:cs typeface="Calibri" pitchFamily="34" charset="-120"/>
+              </a:rPr>
+              <a:t>From project to its sites</a:t>
+            </a:r>
+          </a:p>
+        </p:txBody>
+      </p:sp>
+      <p:sp>
+        <p:nvSpPr>
+          <p:cNvPr id="1040" name="Bullet"/>
+          <p:cNvSpPr/>
+          <p:nvPr/>
+        </p:nvSpPr>
+        <p:spPr>
+          <a:xfrm>
+            <a:off x="6510527" y="3392423"/>
+            <a:ext cx="50292" cy="50292"/>
+          </a:xfrm>
+          <a:prstGeom prst="rect">
+            <a:avLst/>
+          </a:prstGeom>
+          <a:solidFill>
+            <a:srgbClr val="009B8A"/>
+          </a:solidFill>
+          <a:ln/>
+        </p:spPr>
+        <p:txBody>
+          <a:bodyPr/>
+          <a:lstStyle/>
+          <a:p>
+            <a:endParaRPr lang="en-PH" sz="1000"/>
+          </a:p>
+        </p:txBody>
+      </p:sp>
+      <p:sp>
+        <p:nvSpPr>
+          <p:cNvPr id="1041" name="Text"/>
+          <p:cNvSpPr/>
+          <p:nvPr/>
+        </p:nvSpPr>
+        <p:spPr>
+          <a:xfrm>
+            <a:off x="6656831" y="3328415"/>
+            <a:ext cx="1545336" cy="201168"/>
+          </a:xfrm>
+          <a:prstGeom prst="rect">
+            <a:avLst/>
+          </a:prstGeom>
+          <a:noFill/>
+          <a:ln/>
+        </p:spPr>
+        <p:txBody>
+          <a:bodyPr wrap="square" rtlCol="0" anchor="ctr">
+            <a:normAutofit/>
+          </a:bodyPr>
+          <a:lstStyle/>
+          <a:p>
+            <a:pPr marL="0" indent="0" algn="l">
+              <a:buNone/>
+            </a:pPr>
+            <a:r>
+              <a:rPr lang="en-US" sz="900" b="0" kern="0" dirty="0">
+                <a:solidFill>
+                  <a:srgbClr val="333333"/>
+                </a:solidFill>
+                <a:latin typeface="Calibri" pitchFamily="34" charset="0"/>
+                <a:ea typeface="Calibri" pitchFamily="34" charset="-122"/>
+                <a:cs typeface="Calibri" pitchFamily="34" charset="-120"/>
+              </a:rPr>
+              <a:t>From a site to its libraries</a:t>
+            </a:r>
           </a:p>
         </p:txBody>
       </p:sp>
     </p:spTree>
-    <p:extLst>
-      <p:ext uri="{BB962C8B-B14F-4D97-AF65-F5344CB8AC3E}">
-        <p14:creationId xmlns:p14="http://schemas.microsoft.com/office/powerpoint/2010/main" val="3636661724"/>
-      </p:ext>
-    </p:extLst>
   </p:cSld>
   <p:clrMapOvr>
     <a:masterClrMapping/>
@@ -11900,16 +15149,18 @@
 
 <file path=ppt/slides/slide9.xml><?xml version="1.0" encoding="utf-8"?>
 <p:sld xmlns:a="http://schemas.openxmlformats.org/drawingml/2006/main" xmlns:r="http://schemas.openxmlformats.org/officeDocument/2006/relationships" xmlns:p="http://schemas.openxmlformats.org/presentationml/2006/main">
-  <p:cSld>
+  <p:cSld name="Project Insights — asks">
+    <p:bg>
+      <p:bgPr>
+        <a:solidFill>
+          <a:srgbClr val="FFFFFF"/>
+        </a:solidFill>
+        <a:effectLst/>
+      </p:bgPr>
+    </p:bg>
     <p:spTree>
       <p:nvGrpSpPr>
-        <p:cNvPr id="1" name="">
-          <a:extLst>
-            <a:ext uri="{FF2B5EF4-FFF2-40B4-BE49-F238E27FC236}">
-              <a16:creationId xmlns:a16="http://schemas.microsoft.com/office/drawing/2014/main" id="{8A6D0C98-0CD0-DD64-5050-F700D3B01748}"/>
-            </a:ext>
-          </a:extLst>
-        </p:cNvPr>
+        <p:cNvPr id="1" name=""/>
         <p:cNvGrpSpPr/>
         <p:nvPr/>
       </p:nvGrpSpPr>
@@ -11923,19 +15174,13 @@
       </p:grpSpPr>
       <p:sp>
         <p:nvSpPr>
-          <p:cNvPr id="4" name="Text 2">
-            <a:extLst>
-              <a:ext uri="{FF2B5EF4-FFF2-40B4-BE49-F238E27FC236}">
-                <a16:creationId xmlns:a16="http://schemas.microsoft.com/office/drawing/2014/main" id="{87E10E6C-648D-E613-E9E7-8E174D4C8C9C}"/>
-              </a:ext>
-            </a:extLst>
-          </p:cNvPr>
-          <p:cNvSpPr/>
-          <p:nvPr/>
-        </p:nvSpPr>
-        <p:spPr>
-          <a:xfrm>
-            <a:off x="198186" y="93986"/>
+          <p:cNvPr id="1042" name="Title"/>
+          <p:cNvSpPr/>
+          <p:nvPr/>
+        </p:nvSpPr>
+        <p:spPr>
+          <a:xfrm>
+            <a:off x="201168" y="91440"/>
             <a:ext cx="8412480" cy="493776"/>
           </a:xfrm>
           <a:prstGeom prst="rect">
@@ -11945,44 +15190,709 @@
           <a:ln/>
         </p:spPr>
         <p:txBody>
-          <a:bodyPr wrap="square" lIns="0" tIns="0" rIns="0" bIns="0" rtlCol="0" anchor="ctr"/>
-          <a:lstStyle/>
-          <a:p>
-            <a:pPr marL="0" indent="0">
-              <a:buNone/>
-            </a:pPr>
-            <a:r>
-              <a:rPr lang="en-US" sz="2700" b="1" dirty="0">
-                <a:solidFill>
-                  <a:schemeClr val="tx2">
-                    <a:lumMod val="76000"/>
-                  </a:schemeClr>
-                </a:solidFill>
-                <a:latin typeface="Cambria"/>
-                <a:ea typeface="Cambria"/>
-                <a:cs typeface="Cambria" pitchFamily="34" charset="-120"/>
+          <a:bodyPr wrap="square" rtlCol="0" anchor="ctr">
+            <a:normAutofit/>
+          </a:bodyPr>
+          <a:lstStyle/>
+          <a:p>
+            <a:pPr marL="0" indent="0" algn="l">
+              <a:buNone/>
+            </a:pPr>
+            <a:r>
+              <a:rPr lang="en-US" sz="2700" b="1" kern="0" dirty="0">
+                <a:solidFill>
+                  <a:srgbClr val="003D5B"/>
+                </a:solidFill>
+                <a:latin typeface="Calibri" pitchFamily="34" charset="0"/>
+                <a:ea typeface="Calibri" pitchFamily="34" charset="-122"/>
+                <a:cs typeface="Calibri" pitchFamily="34" charset="-120"/>
               </a:rPr>
               <a:t>Project Insights</a:t>
             </a:r>
-            <a:endParaRPr lang="en-US" sz="2700" dirty="0">
-              <a:solidFill>
-                <a:schemeClr val="tx2">
-                  <a:lumMod val="76000"/>
-                </a:schemeClr>
-              </a:solidFill>
-              <a:latin typeface="Cambria"/>
-              <a:ea typeface="Cambria"/>
-              <a:cs typeface="Calibri"/>
-            </a:endParaRPr>
+          </a:p>
+        </p:txBody>
+      </p:sp>
+      <p:sp>
+        <p:nvSpPr>
+          <p:cNvPr id="1043" name="Subtitle"/>
+          <p:cNvSpPr/>
+          <p:nvPr/>
+        </p:nvSpPr>
+        <p:spPr>
+          <a:xfrm>
+            <a:off x="192024" y="640080"/>
+            <a:ext cx="8412480" cy="310896"/>
+          </a:xfrm>
+          <a:prstGeom prst="rect">
+            <a:avLst/>
+          </a:prstGeom>
+          <a:noFill/>
+          <a:ln/>
+        </p:spPr>
+        <p:txBody>
+          <a:bodyPr wrap="square" rtlCol="0" anchor="ctr">
+            <a:normAutofit/>
+          </a:bodyPr>
+          <a:lstStyle/>
+          <a:p>
+            <a:pPr marL="0" indent="0" algn="l">
+              <a:buNone/>
+            </a:pPr>
+            <a:r>
+              <a:rPr lang="en-US" sz="1400" b="0" kern="0" dirty="0">
+                <a:solidFill>
+                  <a:srgbClr val="009B8A"/>
+                </a:solidFill>
+                <a:latin typeface="Calibri" pitchFamily="34" charset="0"/>
+                <a:ea typeface="Calibri" pitchFamily="34" charset="-122"/>
+                <a:cs typeface="Calibri" pitchFamily="34" charset="-120"/>
+              </a:rPr>
+              <a:t>What we need from you before these can be built.</a:t>
+            </a:r>
+          </a:p>
+        </p:txBody>
+      </p:sp>
+      <p:sp>
+        <p:nvSpPr>
+          <p:cNvPr id="1044" name="Text"/>
+          <p:cNvSpPr/>
+          <p:nvPr/>
+        </p:nvSpPr>
+        <p:spPr>
+          <a:xfrm>
+            <a:off x="411480" y="1024128"/>
+            <a:ext cx="4572000" cy="201168"/>
+          </a:xfrm>
+          <a:prstGeom prst="rect">
+            <a:avLst/>
+          </a:prstGeom>
+          <a:noFill/>
+          <a:ln/>
+        </p:spPr>
+        <p:txBody>
+          <a:bodyPr wrap="square" rtlCol="0" anchor="ctr">
+            <a:normAutofit/>
+          </a:bodyPr>
+          <a:lstStyle/>
+          <a:p>
+            <a:pPr marL="0" indent="0" algn="l">
+              <a:buNone/>
+            </a:pPr>
+            <a:r>
+              <a:rPr lang="en-US" sz="1200" b="1" kern="0" spc="105" dirty="0">
+                <a:solidFill>
+                  <a:srgbClr val="003D5B"/>
+                </a:solidFill>
+                <a:latin typeface="Calibri" pitchFamily="34" charset="0"/>
+                <a:ea typeface="Calibri" pitchFamily="34" charset="-122"/>
+                <a:cs typeface="Calibri" pitchFamily="34" charset="-120"/>
+              </a:rPr>
+              <a:t>WHAT WE NEED FROM YOU</a:t>
+            </a:r>
+          </a:p>
+        </p:txBody>
+      </p:sp>
+      <p:sp>
+        <p:nvSpPr>
+          <p:cNvPr id="1045" name="Dot"/>
+          <p:cNvSpPr/>
+          <p:nvPr/>
+        </p:nvSpPr>
+        <p:spPr>
+          <a:xfrm>
+            <a:off x="411480" y="1335024"/>
+            <a:ext cx="256032" cy="256032"/>
+          </a:xfrm>
+          <a:prstGeom prst="ellipse">
+            <a:avLst/>
+          </a:prstGeom>
+          <a:solidFill>
+            <a:srgbClr val="009B8A"/>
+          </a:solidFill>
+          <a:ln/>
+        </p:spPr>
+        <p:txBody>
+          <a:bodyPr/>
+          <a:lstStyle/>
+          <a:p>
+            <a:endParaRPr lang="en-PH" sz="1000"/>
+          </a:p>
+        </p:txBody>
+      </p:sp>
+      <p:sp>
+        <p:nvSpPr>
+          <p:cNvPr id="1046" name="Text"/>
+          <p:cNvSpPr/>
+          <p:nvPr/>
+        </p:nvSpPr>
+        <p:spPr>
+          <a:xfrm>
+            <a:off x="411480" y="1353312"/>
+            <a:ext cx="256032" cy="219456"/>
+          </a:xfrm>
+          <a:prstGeom prst="rect">
+            <a:avLst/>
+          </a:prstGeom>
+          <a:noFill/>
+          <a:ln/>
+        </p:spPr>
+        <p:txBody>
+          <a:bodyPr wrap="square" rtlCol="0" anchor="ctr">
+            <a:normAutofit/>
+          </a:bodyPr>
+          <a:lstStyle/>
+          <a:p>
+            <a:pPr marL="0" indent="0" algn="ctr">
+              <a:buNone/>
+            </a:pPr>
+            <a:r>
+              <a:rPr lang="en-US" sz="1100" b="1" kern="0" dirty="0">
+                <a:solidFill>
+                  <a:srgbClr val="FFFFFF"/>
+                </a:solidFill>
+                <a:latin typeface="Calibri" pitchFamily="34" charset="0"/>
+                <a:ea typeface="Calibri" pitchFamily="34" charset="-122"/>
+                <a:cs typeface="Calibri" pitchFamily="34" charset="-120"/>
+              </a:rPr>
+              <a:t>1</a:t>
+            </a:r>
+          </a:p>
+        </p:txBody>
+      </p:sp>
+      <p:sp>
+        <p:nvSpPr>
+          <p:cNvPr id="1047" name="Text"/>
+          <p:cNvSpPr/>
+          <p:nvPr/>
+        </p:nvSpPr>
+        <p:spPr>
+          <a:xfrm>
+            <a:off x="758952" y="1325880"/>
+            <a:ext cx="3648456" cy="237744"/>
+          </a:xfrm>
+          <a:prstGeom prst="rect">
+            <a:avLst/>
+          </a:prstGeom>
+          <a:noFill/>
+          <a:ln/>
+        </p:spPr>
+        <p:txBody>
+          <a:bodyPr wrap="square" rtlCol="0" anchor="ctr">
+            <a:normAutofit/>
+          </a:bodyPr>
+          <a:lstStyle/>
+          <a:p>
+            <a:pPr marL="0" indent="0" algn="l">
+              <a:buNone/>
+            </a:pPr>
+            <a:r>
+              <a:rPr lang="en-US" sz="1200" b="1" kern="0" dirty="0">
+                <a:solidFill>
+                  <a:srgbClr val="003D5B"/>
+                </a:solidFill>
+                <a:latin typeface="Calibri" pitchFamily="34" charset="0"/>
+                <a:ea typeface="Calibri" pitchFamily="34" charset="-122"/>
+                <a:cs typeface="Calibri" pitchFamily="34" charset="-120"/>
+              </a:rPr>
+              <a:t>The system of record</a:t>
+            </a:r>
+          </a:p>
+        </p:txBody>
+      </p:sp>
+      <p:sp>
+        <p:nvSpPr>
+          <p:cNvPr id="1048" name="Text"/>
+          <p:cNvSpPr/>
+          <p:nvPr/>
+        </p:nvSpPr>
+        <p:spPr>
+          <a:xfrm>
+            <a:off x="758952" y="1581912"/>
+            <a:ext cx="3630168" cy="731520"/>
+          </a:xfrm>
+          <a:prstGeom prst="rect">
+            <a:avLst/>
+          </a:prstGeom>
+          <a:noFill/>
+          <a:ln/>
+        </p:spPr>
+        <p:txBody>
+          <a:bodyPr wrap="square" rtlCol="0" anchor="t">
+            <a:normAutofit/>
+          </a:bodyPr>
+          <a:lstStyle/>
+          <a:p>
+            <a:pPr marL="0" indent="0" algn="l">
+              <a:lnSpc>
+                <a:spcPct val="92000"/>
+              </a:lnSpc>
+              <a:buNone/>
+            </a:pPr>
+            <a:r>
+              <a:rPr lang="en-US" sz="1000" b="0" kern="0" dirty="0">
+                <a:solidFill>
+                  <a:srgbClr val="333333"/>
+                </a:solidFill>
+                <a:latin typeface="Calibri" pitchFamily="34" charset="0"/>
+                <a:ea typeface="Calibri" pitchFamily="34" charset="-122"/>
+                <a:cs typeface="Calibri" pitchFamily="34" charset="-120"/>
+              </a:rPr>
+              <a:t>Which system holds facility type, modality, country, status, effectivity and closing date — and who owns it?</a:t>
+            </a:r>
+          </a:p>
+        </p:txBody>
+      </p:sp>
+      <p:sp>
+        <p:nvSpPr>
+          <p:cNvPr id="1049" name="Dot"/>
+          <p:cNvSpPr/>
+          <p:nvPr/>
+        </p:nvSpPr>
+        <p:spPr>
+          <a:xfrm>
+            <a:off x="4736592" y="1335024"/>
+            <a:ext cx="256032" cy="256032"/>
+          </a:xfrm>
+          <a:prstGeom prst="ellipse">
+            <a:avLst/>
+          </a:prstGeom>
+          <a:solidFill>
+            <a:srgbClr val="009B8A"/>
+          </a:solidFill>
+          <a:ln/>
+        </p:spPr>
+        <p:txBody>
+          <a:bodyPr/>
+          <a:lstStyle/>
+          <a:p>
+            <a:endParaRPr lang="en-PH" sz="1000"/>
+          </a:p>
+        </p:txBody>
+      </p:sp>
+      <p:sp>
+        <p:nvSpPr>
+          <p:cNvPr id="1050" name="Text"/>
+          <p:cNvSpPr/>
+          <p:nvPr/>
+        </p:nvSpPr>
+        <p:spPr>
+          <a:xfrm>
+            <a:off x="4736592" y="1353312"/>
+            <a:ext cx="256032" cy="219456"/>
+          </a:xfrm>
+          <a:prstGeom prst="rect">
+            <a:avLst/>
+          </a:prstGeom>
+          <a:noFill/>
+          <a:ln/>
+        </p:spPr>
+        <p:txBody>
+          <a:bodyPr wrap="square" rtlCol="0" anchor="ctr">
+            <a:normAutofit/>
+          </a:bodyPr>
+          <a:lstStyle/>
+          <a:p>
+            <a:pPr marL="0" indent="0" algn="ctr">
+              <a:buNone/>
+            </a:pPr>
+            <a:r>
+              <a:rPr lang="en-US" sz="1100" b="1" kern="0" dirty="0">
+                <a:solidFill>
+                  <a:srgbClr val="FFFFFF"/>
+                </a:solidFill>
+                <a:latin typeface="Calibri" pitchFamily="34" charset="0"/>
+                <a:ea typeface="Calibri" pitchFamily="34" charset="-122"/>
+                <a:cs typeface="Calibri" pitchFamily="34" charset="-120"/>
+              </a:rPr>
+              <a:t>2</a:t>
+            </a:r>
+          </a:p>
+        </p:txBody>
+      </p:sp>
+      <p:sp>
+        <p:nvSpPr>
+          <p:cNvPr id="1051" name="Text"/>
+          <p:cNvSpPr/>
+          <p:nvPr/>
+        </p:nvSpPr>
+        <p:spPr>
+          <a:xfrm>
+            <a:off x="5084064" y="1325880"/>
+            <a:ext cx="3648456" cy="237744"/>
+          </a:xfrm>
+          <a:prstGeom prst="rect">
+            <a:avLst/>
+          </a:prstGeom>
+          <a:noFill/>
+          <a:ln/>
+        </p:spPr>
+        <p:txBody>
+          <a:bodyPr wrap="square" rtlCol="0" anchor="ctr">
+            <a:normAutofit/>
+          </a:bodyPr>
+          <a:lstStyle/>
+          <a:p>
+            <a:pPr marL="0" indent="0" algn="l">
+              <a:buNone/>
+            </a:pPr>
+            <a:r>
+              <a:rPr lang="en-US" sz="1200" b="1" kern="0" dirty="0">
+                <a:solidFill>
+                  <a:srgbClr val="003D5B"/>
+                </a:solidFill>
+                <a:latin typeface="Calibri" pitchFamily="34" charset="0"/>
+                <a:ea typeface="Calibri" pitchFamily="34" charset="-122"/>
+                <a:cs typeface="Calibri" pitchFamily="34" charset="-120"/>
+              </a:rPr>
+              <a:t>Read access</a:t>
+            </a:r>
+          </a:p>
+        </p:txBody>
+      </p:sp>
+      <p:sp>
+        <p:nvSpPr>
+          <p:cNvPr id="1052" name="Text"/>
+          <p:cNvSpPr/>
+          <p:nvPr/>
+        </p:nvSpPr>
+        <p:spPr>
+          <a:xfrm>
+            <a:off x="5084064" y="1581912"/>
+            <a:ext cx="3630168" cy="731520"/>
+          </a:xfrm>
+          <a:prstGeom prst="rect">
+            <a:avLst/>
+          </a:prstGeom>
+          <a:noFill/>
+          <a:ln/>
+        </p:spPr>
+        <p:txBody>
+          <a:bodyPr wrap="square" rtlCol="0" anchor="t">
+            <a:normAutofit/>
+          </a:bodyPr>
+          <a:lstStyle/>
+          <a:p>
+            <a:pPr marL="0" indent="0" algn="l">
+              <a:lnSpc>
+                <a:spcPct val="92000"/>
+              </a:lnSpc>
+              <a:buNone/>
+            </a:pPr>
+            <a:r>
+              <a:rPr lang="en-US" sz="1000" b="0" kern="0" dirty="0">
+                <a:solidFill>
+                  <a:srgbClr val="333333"/>
+                </a:solidFill>
+                <a:latin typeface="Calibri" pitchFamily="34" charset="0"/>
+                <a:ea typeface="Calibri" pitchFamily="34" charset="-122"/>
+                <a:cs typeface="Calibri" pitchFamily="34" charset="-120"/>
+              </a:rPr>
+              <a:t>Once named, can we be granted read access to it, and how often would it refresh?</a:t>
+            </a:r>
+          </a:p>
+        </p:txBody>
+      </p:sp>
+      <p:sp>
+        <p:nvSpPr>
+          <p:cNvPr id="1053" name="Dot"/>
+          <p:cNvSpPr/>
+          <p:nvPr/>
+        </p:nvSpPr>
+        <p:spPr>
+          <a:xfrm>
+            <a:off x="411480" y="2395728"/>
+            <a:ext cx="256032" cy="256032"/>
+          </a:xfrm>
+          <a:prstGeom prst="ellipse">
+            <a:avLst/>
+          </a:prstGeom>
+          <a:solidFill>
+            <a:srgbClr val="009B8A"/>
+          </a:solidFill>
+          <a:ln/>
+        </p:spPr>
+        <p:txBody>
+          <a:bodyPr/>
+          <a:lstStyle/>
+          <a:p>
+            <a:endParaRPr lang="en-PH" sz="1000"/>
+          </a:p>
+        </p:txBody>
+      </p:sp>
+      <p:sp>
+        <p:nvSpPr>
+          <p:cNvPr id="1054" name="Text"/>
+          <p:cNvSpPr/>
+          <p:nvPr/>
+        </p:nvSpPr>
+        <p:spPr>
+          <a:xfrm>
+            <a:off x="411480" y="2414016"/>
+            <a:ext cx="256032" cy="219456"/>
+          </a:xfrm>
+          <a:prstGeom prst="rect">
+            <a:avLst/>
+          </a:prstGeom>
+          <a:noFill/>
+          <a:ln/>
+        </p:spPr>
+        <p:txBody>
+          <a:bodyPr wrap="square" rtlCol="0" anchor="ctr">
+            <a:normAutofit/>
+          </a:bodyPr>
+          <a:lstStyle/>
+          <a:p>
+            <a:pPr marL="0" indent="0" algn="ctr">
+              <a:buNone/>
+            </a:pPr>
+            <a:r>
+              <a:rPr lang="en-US" sz="1100" b="1" kern="0" dirty="0">
+                <a:solidFill>
+                  <a:srgbClr val="FFFFFF"/>
+                </a:solidFill>
+                <a:latin typeface="Calibri" pitchFamily="34" charset="0"/>
+                <a:ea typeface="Calibri" pitchFamily="34" charset="-122"/>
+                <a:cs typeface="Calibri" pitchFamily="34" charset="-120"/>
+              </a:rPr>
+              <a:t>3</a:t>
+            </a:r>
+          </a:p>
+        </p:txBody>
+      </p:sp>
+      <p:sp>
+        <p:nvSpPr>
+          <p:cNvPr id="1055" name="Text"/>
+          <p:cNvSpPr/>
+          <p:nvPr/>
+        </p:nvSpPr>
+        <p:spPr>
+          <a:xfrm>
+            <a:off x="758952" y="2386584"/>
+            <a:ext cx="3648456" cy="237744"/>
+          </a:xfrm>
+          <a:prstGeom prst="rect">
+            <a:avLst/>
+          </a:prstGeom>
+          <a:noFill/>
+          <a:ln/>
+        </p:spPr>
+        <p:txBody>
+          <a:bodyPr wrap="square" rtlCol="0" anchor="ctr">
+            <a:normAutofit/>
+          </a:bodyPr>
+          <a:lstStyle/>
+          <a:p>
+            <a:pPr marL="0" indent="0" algn="l">
+              <a:buNone/>
+            </a:pPr>
+            <a:r>
+              <a:rPr lang="en-US" sz="1200" b="1" kern="0" dirty="0">
+                <a:solidFill>
+                  <a:srgbClr val="003D5B"/>
+                </a:solidFill>
+                <a:latin typeface="Calibri" pitchFamily="34" charset="0"/>
+                <a:ea typeface="Calibri" pitchFamily="34" charset="-122"/>
+                <a:cs typeface="Calibri" pitchFamily="34" charset="-120"/>
+              </a:rPr>
+              <a:t>Site to project register</a:t>
+            </a:r>
+          </a:p>
+        </p:txBody>
+      </p:sp>
+      <p:sp>
+        <p:nvSpPr>
+          <p:cNvPr id="1056" name="Text"/>
+          <p:cNvSpPr/>
+          <p:nvPr/>
+        </p:nvSpPr>
+        <p:spPr>
+          <a:xfrm>
+            <a:off x="758952" y="2642616"/>
+            <a:ext cx="3630168" cy="731520"/>
+          </a:xfrm>
+          <a:prstGeom prst="rect">
+            <a:avLst/>
+          </a:prstGeom>
+          <a:noFill/>
+          <a:ln/>
+        </p:spPr>
+        <p:txBody>
+          <a:bodyPr wrap="square" rtlCol="0" anchor="t">
+            <a:normAutofit/>
+          </a:bodyPr>
+          <a:lstStyle/>
+          <a:p>
+            <a:pPr marL="0" indent="0" algn="l">
+              <a:lnSpc>
+                <a:spcPct val="92000"/>
+              </a:lnSpc>
+              <a:buNone/>
+            </a:pPr>
+            <a:r>
+              <a:rPr lang="en-US" sz="1000" b="0" kern="0" dirty="0">
+                <a:solidFill>
+                  <a:srgbClr val="333333"/>
+                </a:solidFill>
+                <a:latin typeface="Calibri" pitchFamily="34" charset="0"/>
+                <a:ea typeface="Calibri" pitchFamily="34" charset="-122"/>
+                <a:cs typeface="Calibri" pitchFamily="34" charset="-120"/>
+              </a:rPr>
+              <a:t>Is there a register mapping EDRMS sites to project IDs? Without it, site activity cannot roll up to a project.</a:t>
+            </a:r>
+          </a:p>
+        </p:txBody>
+      </p:sp>
+      <p:sp>
+        <p:nvSpPr>
+          <p:cNvPr id="1057" name="Dot"/>
+          <p:cNvSpPr/>
+          <p:nvPr/>
+        </p:nvSpPr>
+        <p:spPr>
+          <a:xfrm>
+            <a:off x="4736592" y="2395728"/>
+            <a:ext cx="256032" cy="256032"/>
+          </a:xfrm>
+          <a:prstGeom prst="ellipse">
+            <a:avLst/>
+          </a:prstGeom>
+          <a:solidFill>
+            <a:srgbClr val="009B8A"/>
+          </a:solidFill>
+          <a:ln/>
+        </p:spPr>
+        <p:txBody>
+          <a:bodyPr/>
+          <a:lstStyle/>
+          <a:p>
+            <a:endParaRPr lang="en-PH" sz="1000"/>
+          </a:p>
+        </p:txBody>
+      </p:sp>
+      <p:sp>
+        <p:nvSpPr>
+          <p:cNvPr id="1058" name="Text"/>
+          <p:cNvSpPr/>
+          <p:nvPr/>
+        </p:nvSpPr>
+        <p:spPr>
+          <a:xfrm>
+            <a:off x="4736592" y="2414016"/>
+            <a:ext cx="256032" cy="219456"/>
+          </a:xfrm>
+          <a:prstGeom prst="rect">
+            <a:avLst/>
+          </a:prstGeom>
+          <a:noFill/>
+          <a:ln/>
+        </p:spPr>
+        <p:txBody>
+          <a:bodyPr wrap="square" rtlCol="0" anchor="ctr">
+            <a:normAutofit/>
+          </a:bodyPr>
+          <a:lstStyle/>
+          <a:p>
+            <a:pPr marL="0" indent="0" algn="ctr">
+              <a:buNone/>
+            </a:pPr>
+            <a:r>
+              <a:rPr lang="en-US" sz="1100" b="1" kern="0" dirty="0">
+                <a:solidFill>
+                  <a:srgbClr val="FFFFFF"/>
+                </a:solidFill>
+                <a:latin typeface="Calibri" pitchFamily="34" charset="0"/>
+                <a:ea typeface="Calibri" pitchFamily="34" charset="-122"/>
+                <a:cs typeface="Calibri" pitchFamily="34" charset="-120"/>
+              </a:rPr>
+              <a:t>4</a:t>
+            </a:r>
+          </a:p>
+        </p:txBody>
+      </p:sp>
+      <p:sp>
+        <p:nvSpPr>
+          <p:cNvPr id="1059" name="Text"/>
+          <p:cNvSpPr/>
+          <p:nvPr/>
+        </p:nvSpPr>
+        <p:spPr>
+          <a:xfrm>
+            <a:off x="5084064" y="2386584"/>
+            <a:ext cx="3648456" cy="237744"/>
+          </a:xfrm>
+          <a:prstGeom prst="rect">
+            <a:avLst/>
+          </a:prstGeom>
+          <a:noFill/>
+          <a:ln/>
+        </p:spPr>
+        <p:txBody>
+          <a:bodyPr wrap="square" rtlCol="0" anchor="ctr">
+            <a:normAutofit/>
+          </a:bodyPr>
+          <a:lstStyle/>
+          <a:p>
+            <a:pPr marL="0" indent="0" algn="l">
+              <a:buNone/>
+            </a:pPr>
+            <a:r>
+              <a:rPr lang="en-US" sz="1200" b="1" kern="0" dirty="0">
+                <a:solidFill>
+                  <a:srgbClr val="003D5B"/>
+                </a:solidFill>
+                <a:latin typeface="Calibri" pitchFamily="34" charset="0"/>
+                <a:ea typeface="Calibri" pitchFamily="34" charset="-122"/>
+                <a:cs typeface="Calibri" pitchFamily="34" charset="-120"/>
+              </a:rPr>
+              <a:t>If no register exists</a:t>
+            </a:r>
+          </a:p>
+        </p:txBody>
+      </p:sp>
+      <p:sp>
+        <p:nvSpPr>
+          <p:cNvPr id="1060" name="Text"/>
+          <p:cNvSpPr/>
+          <p:nvPr/>
+        </p:nvSpPr>
+        <p:spPr>
+          <a:xfrm>
+            <a:off x="5084064" y="2642616"/>
+            <a:ext cx="3630168" cy="731520"/>
+          </a:xfrm>
+          <a:prstGeom prst="rect">
+            <a:avLst/>
+          </a:prstGeom>
+          <a:noFill/>
+          <a:ln/>
+        </p:spPr>
+        <p:txBody>
+          <a:bodyPr wrap="square" rtlCol="0" anchor="t">
+            <a:normAutofit/>
+          </a:bodyPr>
+          <a:lstStyle/>
+          <a:p>
+            <a:pPr marL="0" indent="0" algn="l">
+              <a:lnSpc>
+                <a:spcPct val="92000"/>
+              </a:lnSpc>
+              <a:buNone/>
+            </a:pPr>
+            <a:r>
+              <a:rPr lang="en-US" sz="1000" b="0" kern="0" dirty="0">
+                <a:solidFill>
+                  <a:srgbClr val="333333"/>
+                </a:solidFill>
+                <a:latin typeface="Calibri" pitchFamily="34" charset="0"/>
+                <a:ea typeface="Calibri" pitchFamily="34" charset="-122"/>
+                <a:cs typeface="Calibri" pitchFamily="34" charset="-120"/>
+              </a:rPr>
+              <a:t>Would you accept us deriving the link by scanning site names, with the accuracy that implies?</a:t>
+            </a:r>
           </a:p>
         </p:txBody>
       </p:sp>
     </p:spTree>
-    <p:extLst>
-      <p:ext uri="{BB962C8B-B14F-4D97-AF65-F5344CB8AC3E}">
-        <p14:creationId xmlns:p14="http://schemas.microsoft.com/office/powerpoint/2010/main" val="2880485684"/>
-      </p:ext>
-    </p:extLst>
   </p:cSld>
   <p:clrMapOvr>
     <a:masterClrMapping/>

</xml_diff>